<commit_message>
add hidden node problem pic
</commit_message>
<xml_diff>
--- a/thesis_filled.pptx
+++ b/thesis_filled.pptx
@@ -125,6 +125,11 @@
       </a:defRPr>
     </a:lvl9pPr>
   </p:defaultTextStyle>
+  <p:extLst>
+    <p:ext uri="{EFAFB233-063F-42B5-8137-9DF3F51BA10A}">
+      <p15:sldGuideLst xmlns:p15="http://schemas.microsoft.com/office/powerpoint/2012/main"/>
+    </p:ext>
+  </p:extLst>
 </p:presentation>
 </file>
 
@@ -9811,37 +9816,6 @@
       </p:sp>
       <p:sp>
         <p:nvSpPr>
-          <p:cNvPr id="3" name="內容版面配置區 2">
-            <a:extLst>
-              <a:ext uri="{FF2B5EF4-FFF2-40B4-BE49-F238E27FC236}">
-                <a16:creationId xmlns:a16="http://schemas.microsoft.com/office/drawing/2014/main" id="{B761585F-5E53-49CE-948C-C549D563F1B7}"/>
-              </a:ext>
-            </a:extLst>
-          </p:cNvPr>
-          <p:cNvSpPr>
-            <a:spLocks noGrp="1"/>
-          </p:cNvSpPr>
-          <p:nvPr>
-            <p:ph idx="1"/>
-          </p:nvPr>
-        </p:nvSpPr>
-        <p:spPr/>
-        <p:txBody>
-          <a:bodyPr/>
-          <a:lstStyle/>
-          <a:p>
-            <a:r>
-              <a:rPr lang="en-US" altLang="zh-TW" dirty="0"/>
-              <a:t>Explain the hidden-node problem in Wi-Fi and why it can reduce throughput and fairness.</a:t>
-            </a:r>
-          </a:p>
-          <a:p>
-            <a:endParaRPr dirty="0"/>
-          </a:p>
-        </p:txBody>
-      </p:sp>
-      <p:sp>
-        <p:nvSpPr>
           <p:cNvPr id="4" name="投影片編號版面配置區 3">
             <a:extLst>
               <a:ext uri="{FF2B5EF4-FFF2-40B4-BE49-F238E27FC236}">
@@ -9880,6 +9854,432 @@
           </a:p>
         </p:txBody>
       </p:sp>
+      <p:sp>
+        <p:nvSpPr>
+          <p:cNvPr id="29" name="內容版面配置區 28">
+            <a:extLst>
+              <a:ext uri="{FF2B5EF4-FFF2-40B4-BE49-F238E27FC236}">
+                <a16:creationId xmlns:a16="http://schemas.microsoft.com/office/drawing/2014/main" id="{EC4A2511-2262-99A8-5D5C-D5FDC2C77C42}"/>
+              </a:ext>
+            </a:extLst>
+          </p:cNvPr>
+          <p:cNvSpPr>
+            <a:spLocks noGrp="1"/>
+          </p:cNvSpPr>
+          <p:nvPr>
+            <p:ph idx="1"/>
+          </p:nvPr>
+        </p:nvSpPr>
+        <p:spPr/>
+        <p:txBody>
+          <a:bodyPr/>
+          <a:lstStyle/>
+          <a:p>
+            <a:r>
+              <a:rPr lang="zh-TW" altLang="zh-TW" dirty="0"/>
+              <a:t>The hidden node problem occurs when two nodes in a wireless network can communicate with a third node, but cannot communicate with each other directly due to obstacles or being out of range</a:t>
+            </a:r>
+            <a:endParaRPr lang="en-US" altLang="zh-TW" dirty="0"/>
+          </a:p>
+          <a:p>
+            <a:r>
+              <a:rPr lang="zh-TW" altLang="zh-TW" dirty="0"/>
+              <a:t> This can lead to collisions at the third node when both nodes transmit simultaneously</a:t>
+            </a:r>
+            <a:endParaRPr lang="zh-TW" altLang="en-US" dirty="0"/>
+          </a:p>
+        </p:txBody>
+      </p:sp>
+      <p:grpSp>
+        <p:nvGrpSpPr>
+          <p:cNvPr id="30" name="群組 29">
+            <a:extLst>
+              <a:ext uri="{FF2B5EF4-FFF2-40B4-BE49-F238E27FC236}">
+                <a16:creationId xmlns:a16="http://schemas.microsoft.com/office/drawing/2014/main" id="{58B64D92-EB49-29A6-9035-D014E91FA694}"/>
+              </a:ext>
+            </a:extLst>
+          </p:cNvPr>
+          <p:cNvGrpSpPr/>
+          <p:nvPr/>
+        </p:nvGrpSpPr>
+        <p:grpSpPr>
+          <a:xfrm>
+            <a:off x="2968242" y="3129382"/>
+            <a:ext cx="6255516" cy="3356964"/>
+            <a:chOff x="2864188" y="3407243"/>
+            <a:chExt cx="6255516" cy="3356964"/>
+          </a:xfrm>
+        </p:grpSpPr>
+        <p:grpSp>
+          <p:nvGrpSpPr>
+            <p:cNvPr id="31" name="群組 30">
+              <a:extLst>
+                <a:ext uri="{FF2B5EF4-FFF2-40B4-BE49-F238E27FC236}">
+                  <a16:creationId xmlns:a16="http://schemas.microsoft.com/office/drawing/2014/main" id="{D0EADA24-3743-74BA-645B-C6278D8BAD57}"/>
+                </a:ext>
+              </a:extLst>
+            </p:cNvPr>
+            <p:cNvGrpSpPr/>
+            <p:nvPr/>
+          </p:nvGrpSpPr>
+          <p:grpSpPr>
+            <a:xfrm>
+              <a:off x="2864188" y="3407243"/>
+              <a:ext cx="6255516" cy="3356964"/>
+              <a:chOff x="2864188" y="3407243"/>
+              <a:chExt cx="6255516" cy="3356964"/>
+            </a:xfrm>
+          </p:grpSpPr>
+          <p:pic>
+            <p:nvPicPr>
+              <p:cNvPr id="34" name="圖片 33">
+                <a:extLst>
+                  <a:ext uri="{FF2B5EF4-FFF2-40B4-BE49-F238E27FC236}">
+                    <a16:creationId xmlns:a16="http://schemas.microsoft.com/office/drawing/2014/main" id="{BDAA1C12-72B9-53BC-1C4F-B9A924BC4A9A}"/>
+                  </a:ext>
+                </a:extLst>
+              </p:cNvPr>
+              <p:cNvPicPr>
+                <a:picLocks noChangeAspect="1"/>
+              </p:cNvPicPr>
+              <p:nvPr/>
+            </p:nvPicPr>
+            <p:blipFill>
+              <a:blip r:embed="rId3">
+                <a:extLst>
+                  <a:ext uri="{28A0092B-C50C-407E-A947-70E740481C1C}">
+                    <a14:useLocalDpi xmlns:a14="http://schemas.microsoft.com/office/drawing/2010/main" val="0"/>
+                  </a:ext>
+                </a:extLst>
+              </a:blip>
+              <a:stretch>
+                <a:fillRect/>
+              </a:stretch>
+            </p:blipFill>
+            <p:spPr>
+              <a:xfrm>
+                <a:off x="5506231" y="4621767"/>
+                <a:ext cx="971430" cy="971430"/>
+              </a:xfrm>
+              <a:prstGeom prst="rect">
+                <a:avLst/>
+              </a:prstGeom>
+            </p:spPr>
+          </p:pic>
+          <p:grpSp>
+            <p:nvGrpSpPr>
+              <p:cNvPr id="35" name="群組 34">
+                <a:extLst>
+                  <a:ext uri="{FF2B5EF4-FFF2-40B4-BE49-F238E27FC236}">
+                    <a16:creationId xmlns:a16="http://schemas.microsoft.com/office/drawing/2014/main" id="{F8BA280E-0E0C-ECCF-D6EB-DA7A1E9D34BE}"/>
+                  </a:ext>
+                </a:extLst>
+              </p:cNvPr>
+              <p:cNvGrpSpPr/>
+              <p:nvPr/>
+            </p:nvGrpSpPr>
+            <p:grpSpPr>
+              <a:xfrm>
+                <a:off x="2864188" y="3407243"/>
+                <a:ext cx="3432558" cy="3356964"/>
+                <a:chOff x="2177143" y="3429000"/>
+                <a:chExt cx="3432558" cy="3356964"/>
+              </a:xfrm>
+            </p:grpSpPr>
+            <p:pic>
+              <p:nvPicPr>
+                <p:cNvPr id="39" name="內容版面配置區 5">
+                  <a:extLst>
+                    <a:ext uri="{FF2B5EF4-FFF2-40B4-BE49-F238E27FC236}">
+                      <a16:creationId xmlns:a16="http://schemas.microsoft.com/office/drawing/2014/main" id="{12B9C05F-1274-449C-48AB-9A5A7D87F217}"/>
+                    </a:ext>
+                  </a:extLst>
+                </p:cNvPr>
+                <p:cNvPicPr>
+                  <a:picLocks noChangeAspect="1"/>
+                </p:cNvPicPr>
+                <p:nvPr/>
+              </p:nvPicPr>
+              <p:blipFill>
+                <a:blip r:embed="rId4">
+                  <a:extLst>
+                    <a:ext uri="{28A0092B-C50C-407E-A947-70E740481C1C}">
+                      <a14:useLocalDpi xmlns:a14="http://schemas.microsoft.com/office/drawing/2010/main" val="0"/>
+                    </a:ext>
+                  </a:extLst>
+                </a:blip>
+                <a:stretch>
+                  <a:fillRect/>
+                </a:stretch>
+              </p:blipFill>
+              <p:spPr>
+                <a:xfrm>
+                  <a:off x="3375354" y="4611186"/>
+                  <a:ext cx="1036137" cy="1036137"/>
+                </a:xfrm>
+                <a:prstGeom prst="rect">
+                  <a:avLst/>
+                </a:prstGeom>
+                <a:noFill/>
+              </p:spPr>
+            </p:pic>
+            <p:sp>
+              <p:nvSpPr>
+                <p:cNvPr id="40" name="橢圓 39">
+                  <a:extLst>
+                    <a:ext uri="{FF2B5EF4-FFF2-40B4-BE49-F238E27FC236}">
+                      <a16:creationId xmlns:a16="http://schemas.microsoft.com/office/drawing/2014/main" id="{C55DFED3-7882-FEDB-5B4B-FB8C86E1C94F}"/>
+                    </a:ext>
+                  </a:extLst>
+                </p:cNvPr>
+                <p:cNvSpPr/>
+                <p:nvPr/>
+              </p:nvSpPr>
+              <p:spPr>
+                <a:xfrm>
+                  <a:off x="2177143" y="3429000"/>
+                  <a:ext cx="3432558" cy="3356964"/>
+                </a:xfrm>
+                <a:prstGeom prst="ellipse">
+                  <a:avLst/>
+                </a:prstGeom>
+                <a:noFill/>
+                <a:ln>
+                  <a:solidFill>
+                    <a:srgbClr val="FF0000"/>
+                  </a:solidFill>
+                </a:ln>
+              </p:spPr>
+              <p:style>
+                <a:lnRef idx="2">
+                  <a:schemeClr val="accent1">
+                    <a:shade val="15000"/>
+                  </a:schemeClr>
+                </a:lnRef>
+                <a:fillRef idx="1">
+                  <a:schemeClr val="accent1"/>
+                </a:fillRef>
+                <a:effectRef idx="0">
+                  <a:schemeClr val="accent1"/>
+                </a:effectRef>
+                <a:fontRef idx="minor">
+                  <a:schemeClr val="lt1"/>
+                </a:fontRef>
+              </p:style>
+              <p:txBody>
+                <a:bodyPr rtlCol="0" anchor="ctr"/>
+                <a:lstStyle/>
+                <a:p>
+                  <a:pPr algn="ctr"/>
+                  <a:endParaRPr lang="zh-TW" altLang="en-US"/>
+                </a:p>
+              </p:txBody>
+            </p:sp>
+          </p:grpSp>
+          <p:grpSp>
+            <p:nvGrpSpPr>
+              <p:cNvPr id="36" name="群組 35">
+                <a:extLst>
+                  <a:ext uri="{FF2B5EF4-FFF2-40B4-BE49-F238E27FC236}">
+                    <a16:creationId xmlns:a16="http://schemas.microsoft.com/office/drawing/2014/main" id="{06D5EDDB-F982-DEF1-450F-60BF56CFC58C}"/>
+                  </a:ext>
+                </a:extLst>
+              </p:cNvPr>
+              <p:cNvGrpSpPr/>
+              <p:nvPr/>
+            </p:nvGrpSpPr>
+            <p:grpSpPr>
+              <a:xfrm>
+                <a:off x="5687146" y="3407243"/>
+                <a:ext cx="3432558" cy="3356964"/>
+                <a:chOff x="2177143" y="3429000"/>
+                <a:chExt cx="3432558" cy="3356964"/>
+              </a:xfrm>
+            </p:grpSpPr>
+            <p:pic>
+              <p:nvPicPr>
+                <p:cNvPr id="37" name="內容版面配置區 5">
+                  <a:extLst>
+                    <a:ext uri="{FF2B5EF4-FFF2-40B4-BE49-F238E27FC236}">
+                      <a16:creationId xmlns:a16="http://schemas.microsoft.com/office/drawing/2014/main" id="{99FBA6D5-6A8D-784C-D1F5-56C116E9E041}"/>
+                    </a:ext>
+                  </a:extLst>
+                </p:cNvPr>
+                <p:cNvPicPr>
+                  <a:picLocks noChangeAspect="1"/>
+                </p:cNvPicPr>
+                <p:nvPr/>
+              </p:nvPicPr>
+              <p:blipFill>
+                <a:blip r:embed="rId4">
+                  <a:extLst>
+                    <a:ext uri="{28A0092B-C50C-407E-A947-70E740481C1C}">
+                      <a14:useLocalDpi xmlns:a14="http://schemas.microsoft.com/office/drawing/2010/main" val="0"/>
+                    </a:ext>
+                  </a:extLst>
+                </a:blip>
+                <a:stretch>
+                  <a:fillRect/>
+                </a:stretch>
+              </p:blipFill>
+              <p:spPr>
+                <a:xfrm>
+                  <a:off x="3375354" y="4611186"/>
+                  <a:ext cx="1036137" cy="1036137"/>
+                </a:xfrm>
+                <a:prstGeom prst="rect">
+                  <a:avLst/>
+                </a:prstGeom>
+                <a:noFill/>
+              </p:spPr>
+            </p:pic>
+            <p:sp>
+              <p:nvSpPr>
+                <p:cNvPr id="38" name="橢圓 37">
+                  <a:extLst>
+                    <a:ext uri="{FF2B5EF4-FFF2-40B4-BE49-F238E27FC236}">
+                      <a16:creationId xmlns:a16="http://schemas.microsoft.com/office/drawing/2014/main" id="{8162223E-F766-B1C2-69E0-0E85662F9FD8}"/>
+                    </a:ext>
+                  </a:extLst>
+                </p:cNvPr>
+                <p:cNvSpPr/>
+                <p:nvPr/>
+              </p:nvSpPr>
+              <p:spPr>
+                <a:xfrm>
+                  <a:off x="2177143" y="3429000"/>
+                  <a:ext cx="3432558" cy="3356964"/>
+                </a:xfrm>
+                <a:prstGeom prst="ellipse">
+                  <a:avLst/>
+                </a:prstGeom>
+                <a:noFill/>
+                <a:ln>
+                  <a:solidFill>
+                    <a:srgbClr val="FF0000"/>
+                  </a:solidFill>
+                </a:ln>
+              </p:spPr>
+              <p:style>
+                <a:lnRef idx="2">
+                  <a:schemeClr val="accent1">
+                    <a:shade val="15000"/>
+                  </a:schemeClr>
+                </a:lnRef>
+                <a:fillRef idx="1">
+                  <a:schemeClr val="accent1"/>
+                </a:fillRef>
+                <a:effectRef idx="0">
+                  <a:schemeClr val="accent1"/>
+                </a:effectRef>
+                <a:fontRef idx="minor">
+                  <a:schemeClr val="lt1"/>
+                </a:fontRef>
+              </p:style>
+              <p:txBody>
+                <a:bodyPr rtlCol="0" anchor="ctr"/>
+                <a:lstStyle/>
+                <a:p>
+                  <a:pPr algn="ctr"/>
+                  <a:endParaRPr lang="zh-TW" altLang="en-US"/>
+                </a:p>
+              </p:txBody>
+            </p:sp>
+          </p:grpSp>
+        </p:grpSp>
+        <p:cxnSp>
+          <p:nvCxnSpPr>
+            <p:cNvPr id="32" name="直線接點 31">
+              <a:extLst>
+                <a:ext uri="{FF2B5EF4-FFF2-40B4-BE49-F238E27FC236}">
+                  <a16:creationId xmlns:a16="http://schemas.microsoft.com/office/drawing/2014/main" id="{E975B106-7280-547B-5C85-E48F0D77DD05}"/>
+                </a:ext>
+              </a:extLst>
+            </p:cNvPr>
+            <p:cNvCxnSpPr>
+              <a:cxnSpLocks/>
+              <a:stCxn id="34" idx="3"/>
+              <a:endCxn id="37" idx="1"/>
+            </p:cNvCxnSpPr>
+            <p:nvPr/>
+          </p:nvCxnSpPr>
+          <p:spPr>
+            <a:xfrm>
+              <a:off x="6477661" y="5107482"/>
+              <a:ext cx="407696" cy="16"/>
+            </a:xfrm>
+            <a:prstGeom prst="line">
+              <a:avLst/>
+            </a:prstGeom>
+            <a:ln w="38100">
+              <a:solidFill>
+                <a:schemeClr val="tx1"/>
+              </a:solidFill>
+              <a:prstDash val="dash"/>
+            </a:ln>
+          </p:spPr>
+          <p:style>
+            <a:lnRef idx="1">
+              <a:schemeClr val="accent1"/>
+            </a:lnRef>
+            <a:fillRef idx="0">
+              <a:schemeClr val="accent1"/>
+            </a:fillRef>
+            <a:effectRef idx="0">
+              <a:schemeClr val="accent1"/>
+            </a:effectRef>
+            <a:fontRef idx="minor">
+              <a:schemeClr val="tx1"/>
+            </a:fontRef>
+          </p:style>
+        </p:cxnSp>
+        <p:cxnSp>
+          <p:nvCxnSpPr>
+            <p:cNvPr id="33" name="直線接點 32">
+              <a:extLst>
+                <a:ext uri="{FF2B5EF4-FFF2-40B4-BE49-F238E27FC236}">
+                  <a16:creationId xmlns:a16="http://schemas.microsoft.com/office/drawing/2014/main" id="{8854315B-9485-444D-2076-E320F15A8B9A}"/>
+                </a:ext>
+              </a:extLst>
+            </p:cNvPr>
+            <p:cNvCxnSpPr>
+              <a:cxnSpLocks/>
+              <a:stCxn id="39" idx="3"/>
+              <a:endCxn id="34" idx="1"/>
+            </p:cNvCxnSpPr>
+            <p:nvPr/>
+          </p:nvCxnSpPr>
+          <p:spPr>
+            <a:xfrm flipV="1">
+              <a:off x="5098536" y="5107482"/>
+              <a:ext cx="407695" cy="16"/>
+            </a:xfrm>
+            <a:prstGeom prst="line">
+              <a:avLst/>
+            </a:prstGeom>
+            <a:ln w="38100">
+              <a:solidFill>
+                <a:schemeClr val="tx1"/>
+              </a:solidFill>
+              <a:prstDash val="dash"/>
+            </a:ln>
+          </p:spPr>
+          <p:style>
+            <a:lnRef idx="1">
+              <a:schemeClr val="accent1"/>
+            </a:lnRef>
+            <a:fillRef idx="0">
+              <a:schemeClr val="accent1"/>
+            </a:fillRef>
+            <a:effectRef idx="0">
+              <a:schemeClr val="accent1"/>
+            </a:effectRef>
+            <a:fontRef idx="minor">
+              <a:schemeClr val="tx1"/>
+            </a:fontRef>
+          </p:style>
+        </p:cxnSp>
+      </p:grpSp>
     </p:spTree>
     <p:extLst>
       <p:ext uri="{BB962C8B-B14F-4D97-AF65-F5344CB8AC3E}">
@@ -9961,10 +10361,29 @@
           <a:lstStyle/>
           <a:p>
             <a:r>
+              <a:rPr lang="zh-TW" altLang="zh-TW" dirty="0"/>
+              <a:t>The RTS/CTS is </a:t>
+            </a:r>
+            <a:r>
               <a:rPr lang="en-US" altLang="zh-TW" dirty="0"/>
-              <a:t>What is RTS/CTS</a:t>
-            </a:r>
-            <a:endParaRPr dirty="0"/>
+              <a:t>optional </a:t>
+            </a:r>
+            <a:r>
+              <a:rPr lang="zh-TW" altLang="zh-TW" dirty="0"/>
+              <a:t>mechanism</a:t>
+            </a:r>
+            <a:r>
+              <a:rPr lang="en-US" altLang="zh-TW" dirty="0"/>
+              <a:t> </a:t>
+            </a:r>
+            <a:r>
+              <a:rPr lang="zh-TW" altLang="zh-TW" dirty="0"/>
+              <a:t>used to address this problem by allowing nodes to reserve the channel before transmitting</a:t>
+            </a:r>
+            <a:r>
+              <a:rPr lang="en-US" altLang="zh-TW" dirty="0"/>
+              <a:t> in 802.11 protocol </a:t>
+            </a:r>
           </a:p>
           <a:p>
             <a:r>

</xml_diff>

<commit_message>
add CSI, hidden node, rts/cts info
</commit_message>
<xml_diff>
--- a/thesis_filled.pptx
+++ b/thesis_filled.pptx
@@ -5,7 +5,7 @@
     <p:sldMasterId id="2147483648" r:id="rId1"/>
   </p:sldMasterIdLst>
   <p:notesMasterIdLst>
-    <p:notesMasterId r:id="rId21"/>
+    <p:notesMasterId r:id="rId22"/>
   </p:notesMasterIdLst>
   <p:sldIdLst>
     <p:sldId id="256" r:id="rId2"/>
@@ -13,20 +13,21 @@
     <p:sldId id="258" r:id="rId4"/>
     <p:sldId id="260" r:id="rId5"/>
     <p:sldId id="262" r:id="rId6"/>
-    <p:sldId id="263" r:id="rId7"/>
-    <p:sldId id="264" r:id="rId8"/>
-    <p:sldId id="265" r:id="rId9"/>
-    <p:sldId id="269" r:id="rId10"/>
-    <p:sldId id="285" r:id="rId11"/>
-    <p:sldId id="266" r:id="rId12"/>
-    <p:sldId id="273" r:id="rId13"/>
-    <p:sldId id="274" r:id="rId14"/>
-    <p:sldId id="275" r:id="rId15"/>
-    <p:sldId id="277" r:id="rId16"/>
-    <p:sldId id="280" r:id="rId17"/>
-    <p:sldId id="281" r:id="rId18"/>
-    <p:sldId id="282" r:id="rId19"/>
-    <p:sldId id="283" r:id="rId20"/>
+    <p:sldId id="286" r:id="rId7"/>
+    <p:sldId id="263" r:id="rId8"/>
+    <p:sldId id="264" r:id="rId9"/>
+    <p:sldId id="265" r:id="rId10"/>
+    <p:sldId id="269" r:id="rId11"/>
+    <p:sldId id="285" r:id="rId12"/>
+    <p:sldId id="266" r:id="rId13"/>
+    <p:sldId id="273" r:id="rId14"/>
+    <p:sldId id="274" r:id="rId15"/>
+    <p:sldId id="275" r:id="rId16"/>
+    <p:sldId id="277" r:id="rId17"/>
+    <p:sldId id="280" r:id="rId18"/>
+    <p:sldId id="281" r:id="rId19"/>
+    <p:sldId id="282" r:id="rId20"/>
+    <p:sldId id="283" r:id="rId21"/>
   </p:sldIdLst>
   <p:sldSz cx="12192000" cy="6858000"/>
   <p:notesSz cx="6858000" cy="9144000"/>
@@ -7997,8 +7998,8 @@
           <a:lstStyle/>
           <a:p>
             <a:r>
-              <a:rPr lang="en-US" b="1" dirty="0"/>
-              <a:t>MUSIC</a:t>
+              <a:rPr lang="en-US" altLang="zh-TW" dirty="0"/>
+              <a:t>Spatial Spectrum Estimation</a:t>
             </a:r>
             <a:endParaRPr b="1" dirty="0"/>
           </a:p>
@@ -8025,10 +8026,7 @@
           <a:bodyPr/>
           <a:lstStyle/>
           <a:p>
-            <a:r>
-              <a:rPr dirty="0"/>
-              <a:t>Motivate MUSIC for Wi-Fi APs because it can use existing multi-antenna CSI, provide higher angular resolution than simple beam scanning, and separate signal and noise subspaces without extra localization hardware.</a:t>
-            </a:r>
+            <a:endParaRPr dirty="0"/>
           </a:p>
         </p:txBody>
       </p:sp>
@@ -8075,7 +8073,7 @@
     </p:spTree>
     <p:extLst>
       <p:ext uri="{BB962C8B-B14F-4D97-AF65-F5344CB8AC3E}">
-        <p14:creationId xmlns:p14="http://schemas.microsoft.com/office/powerpoint/2010/main" val="1037141713"/>
+        <p14:creationId xmlns:p14="http://schemas.microsoft.com/office/powerpoint/2010/main" val="3499234266"/>
       </p:ext>
     </p:extLst>
   </p:cSld>
@@ -8124,9 +8122,10 @@
           <a:lstStyle/>
           <a:p>
             <a:r>
-              <a:rPr lang="en-US" dirty="0"/>
-              <a:t>LRG1 Ability  for RTS threshold control and metric collection</a:t>
-            </a:r>
+              <a:rPr lang="en-US" b="1" dirty="0"/>
+              <a:t>MUSIC</a:t>
+            </a:r>
+            <a:endParaRPr b="1" dirty="0"/>
           </a:p>
         </p:txBody>
       </p:sp>
@@ -8153,21 +8152,7 @@
           <a:p>
             <a:r>
               <a:rPr dirty="0"/>
-              <a:t>Review the RTS threshold as the main AP-side control knob.</a:t>
-            </a:r>
-          </a:p>
-          <a:p>
-            <a:r>
-              <a:rPr dirty="0"/>
-              <a:t>Describe AP-side measurements, including retry statistics, RSSI, CSI, </a:t>
-            </a:r>
-            <a:r>
-              <a:rPr dirty="0" err="1"/>
-              <a:t>AoA</a:t>
-            </a:r>
-            <a:r>
-              <a:rPr dirty="0"/>
-              <a:t>, and MCS.</a:t>
+              <a:t>Motivate MUSIC for Wi-Fi APs because it can use existing multi-antenna CSI, provide higher angular resolution than simple beam scanning, and separate signal and noise subspaces without extra localization hardware.</a:t>
             </a:r>
           </a:p>
         </p:txBody>
@@ -8196,7 +8181,7 @@
             <a:pPr>
               <a:buNone/>
             </a:pPr>
-            <a:fld id="{30394428-F1DC-E5F6-DB0C-7DE31F3D8A23}" type="slidenum">
+            <a:fld id="{327921A4-25C4-3DB4-06B1-32693CEE2241}" type="slidenum">
               <a:rPr sz="1400">
                 <a:latin typeface="Times New Roman"/>
                 <a:ea typeface="Times New Roman"/>
@@ -8215,7 +8200,7 @@
     </p:spTree>
     <p:extLst>
       <p:ext uri="{BB962C8B-B14F-4D97-AF65-F5344CB8AC3E}">
-        <p14:creationId xmlns:p14="http://schemas.microsoft.com/office/powerpoint/2010/main" val="3499234266"/>
+        <p14:creationId xmlns:p14="http://schemas.microsoft.com/office/powerpoint/2010/main" val="1037141713"/>
       </p:ext>
     </p:extLst>
   </p:cSld>
@@ -8244,10 +8229,80 @@
       </p:grpSpPr>
       <p:sp>
         <p:nvSpPr>
-          <p:cNvPr id="2" name="?蔣?楊???ａ?蝵桀? 1">
-            <a:extLst>
-              <a:ext uri="{FF2B5EF4-FFF2-40B4-BE49-F238E27FC236}">
-                <a16:creationId xmlns:a16="http://schemas.microsoft.com/office/drawing/2014/main" id="{7C687AF8-AF63-1728-2C7B-76B8DC1837DE}"/>
+          <p:cNvPr id="2" name="標題 1">
+            <a:extLst>
+              <a:ext uri="{FF2B5EF4-FFF2-40B4-BE49-F238E27FC236}">
+                <a16:creationId xmlns:a16="http://schemas.microsoft.com/office/drawing/2014/main" id="{27A3B284-1CEC-47E9-98B8-BA58ABCB5210}"/>
+              </a:ext>
+            </a:extLst>
+          </p:cNvPr>
+          <p:cNvSpPr>
+            <a:spLocks noGrp="1"/>
+          </p:cNvSpPr>
+          <p:nvPr>
+            <p:ph type="title"/>
+          </p:nvPr>
+        </p:nvSpPr>
+        <p:spPr/>
+        <p:txBody>
+          <a:bodyPr/>
+          <a:lstStyle/>
+          <a:p>
+            <a:r>
+              <a:rPr lang="en-US" dirty="0"/>
+              <a:t>LRG1 Ability  for RTS threshold control and metric collection</a:t>
+            </a:r>
+          </a:p>
+        </p:txBody>
+      </p:sp>
+      <p:sp>
+        <p:nvSpPr>
+          <p:cNvPr id="3" name="內容版面配置區 2">
+            <a:extLst>
+              <a:ext uri="{FF2B5EF4-FFF2-40B4-BE49-F238E27FC236}">
+                <a16:creationId xmlns:a16="http://schemas.microsoft.com/office/drawing/2014/main" id="{85EB7868-0B10-4ADE-BF08-3CE42A258785}"/>
+              </a:ext>
+            </a:extLst>
+          </p:cNvPr>
+          <p:cNvSpPr>
+            <a:spLocks noGrp="1"/>
+          </p:cNvSpPr>
+          <p:nvPr>
+            <p:ph idx="1"/>
+          </p:nvPr>
+        </p:nvSpPr>
+        <p:spPr/>
+        <p:txBody>
+          <a:bodyPr/>
+          <a:lstStyle/>
+          <a:p>
+            <a:r>
+              <a:rPr dirty="0"/>
+              <a:t>Review the RTS threshold as the main AP-side control knob.</a:t>
+            </a:r>
+          </a:p>
+          <a:p>
+            <a:r>
+              <a:rPr dirty="0"/>
+              <a:t>Describe AP-side measurements, including retry statistics, RSSI, CSI, </a:t>
+            </a:r>
+            <a:r>
+              <a:rPr dirty="0" err="1"/>
+              <a:t>AoA</a:t>
+            </a:r>
+            <a:r>
+              <a:rPr dirty="0"/>
+              <a:t>, and MCS.</a:t>
+            </a:r>
+          </a:p>
+        </p:txBody>
+      </p:sp>
+      <p:sp>
+        <p:nvSpPr>
+          <p:cNvPr id="4" name="投影片編號版面配置區 3">
+            <a:extLst>
+              <a:ext uri="{FF2B5EF4-FFF2-40B4-BE49-F238E27FC236}">
+                <a16:creationId xmlns:a16="http://schemas.microsoft.com/office/drawing/2014/main" id="{C2FCD405-600C-462A-BF29-DAFF79456778}"/>
               </a:ext>
             </a:extLst>
           </p:cNvPr>
@@ -8266,7 +8321,7 @@
             <a:pPr>
               <a:buNone/>
             </a:pPr>
-            <a:fld id="{B1C6C81E-38B9-7560-621D-5A151A79DF9B}" type="slidenum">
+            <a:fld id="{30394428-F1DC-E5F6-DB0C-7DE31F3D8A23}" type="slidenum">
               <a:rPr sz="1400">
                 <a:latin typeface="Times New Roman"/>
                 <a:ea typeface="Times New Roman"/>
@@ -8282,131 +8337,10 @@
           </a:p>
         </p:txBody>
       </p:sp>
-      <p:sp>
-        <p:nvSpPr>
-          <p:cNvPr id="3" name="?批捆??蔭? 2">
-            <a:extLst>
-              <a:ext uri="{FF2B5EF4-FFF2-40B4-BE49-F238E27FC236}">
-                <a16:creationId xmlns:a16="http://schemas.microsoft.com/office/drawing/2014/main" id="{EFDF35B5-B6BD-325F-B271-EE42028230F3}"/>
-              </a:ext>
-            </a:extLst>
-          </p:cNvPr>
-          <p:cNvSpPr>
-            <a:spLocks noGrp="1"/>
-          </p:cNvSpPr>
-          <p:nvPr>
-            <p:ph idx="1"/>
-          </p:nvPr>
-        </p:nvSpPr>
-        <p:spPr/>
-        <p:txBody>
-          <a:bodyPr/>
-          <a:lstStyle/>
-          <a:p>
-            <a:r>
-              <a:rPr dirty="0">
-                <a:solidFill>
-                  <a:schemeClr val="bg1">
-                    <a:lumMod val="50000"/>
-                  </a:schemeClr>
-                </a:solidFill>
-              </a:rPr>
-              <a:t>Introduction</a:t>
-            </a:r>
-          </a:p>
-          <a:p>
-            <a:r>
-              <a:rPr dirty="0">
-                <a:solidFill>
-                  <a:schemeClr val="bg1">
-                    <a:lumMod val="50000"/>
-                  </a:schemeClr>
-                </a:solidFill>
-              </a:rPr>
-              <a:t>Background</a:t>
-            </a:r>
-          </a:p>
-          <a:p>
-            <a:r>
-              <a:rPr dirty="0" err="1"/>
-              <a:t>AoA</a:t>
-            </a:r>
-            <a:r>
-              <a:rPr dirty="0"/>
-              <a:t>-Assisted Risk Score and RTS</a:t>
-            </a:r>
-            <a:r>
-              <a:rPr dirty="0">
-                <a:solidFill>
-                  <a:schemeClr val="bg1">
-                    <a:lumMod val="50000"/>
-                  </a:schemeClr>
-                </a:solidFill>
-              </a:rPr>
-              <a:t> </a:t>
-            </a:r>
-            <a:r>
-              <a:rPr dirty="0"/>
-              <a:t>Threshold Adaptation</a:t>
-            </a:r>
-          </a:p>
-          <a:p>
-            <a:r>
-              <a:rPr dirty="0">
-                <a:solidFill>
-                  <a:schemeClr val="bg1">
-                    <a:lumMod val="50000"/>
-                  </a:schemeClr>
-                </a:solidFill>
-              </a:rPr>
-              <a:t>Evaluation</a:t>
-            </a:r>
-          </a:p>
-          <a:p>
-            <a:r>
-              <a:rPr dirty="0">
-                <a:solidFill>
-                  <a:schemeClr val="bg1">
-                    <a:lumMod val="50000"/>
-                  </a:schemeClr>
-                </a:solidFill>
-              </a:rPr>
-              <a:t>Conclusion</a:t>
-            </a:r>
-          </a:p>
-        </p:txBody>
-      </p:sp>
-      <p:sp>
-        <p:nvSpPr>
-          <p:cNvPr id="4" name="璅? 3">
-            <a:extLst>
-              <a:ext uri="{FF2B5EF4-FFF2-40B4-BE49-F238E27FC236}">
-                <a16:creationId xmlns:a16="http://schemas.microsoft.com/office/drawing/2014/main" id="{363B54DA-5A57-63A3-3957-4A5B100F1AAB}"/>
-              </a:ext>
-            </a:extLst>
-          </p:cNvPr>
-          <p:cNvSpPr>
-            <a:spLocks noGrp="1"/>
-          </p:cNvSpPr>
-          <p:nvPr>
-            <p:ph type="title"/>
-          </p:nvPr>
-        </p:nvSpPr>
-        <p:spPr/>
-        <p:txBody>
-          <a:bodyPr/>
-          <a:lstStyle/>
-          <a:p>
-            <a:r>
-              <a:t>Outline</a:t>
-            </a:r>
-          </a:p>
-        </p:txBody>
-      </p:sp>
     </p:spTree>
     <p:extLst>
       <p:ext uri="{BB962C8B-B14F-4D97-AF65-F5344CB8AC3E}">
-        <p14:creationId xmlns:p14="http://schemas.microsoft.com/office/powerpoint/2010/main" val="2663263701"/>
+        <p14:creationId xmlns:p14="http://schemas.microsoft.com/office/powerpoint/2010/main" val="3499234266"/>
       </p:ext>
     </p:extLst>
   </p:cSld>
@@ -8435,70 +8369,10 @@
       </p:grpSpPr>
       <p:sp>
         <p:nvSpPr>
-          <p:cNvPr id="2" name="標題 1">
-            <a:extLst>
-              <a:ext uri="{FF2B5EF4-FFF2-40B4-BE49-F238E27FC236}">
-                <a16:creationId xmlns:a16="http://schemas.microsoft.com/office/drawing/2014/main" id="{27A3B284-1CEC-47E9-98B8-BA58ABCB5210}"/>
-              </a:ext>
-            </a:extLst>
-          </p:cNvPr>
-          <p:cNvSpPr>
-            <a:spLocks noGrp="1"/>
-          </p:cNvSpPr>
-          <p:nvPr>
-            <p:ph type="title"/>
-          </p:nvPr>
-        </p:nvSpPr>
-        <p:spPr/>
-        <p:txBody>
-          <a:bodyPr/>
-          <a:lstStyle/>
-          <a:p>
-            <a:r>
-              <a:rPr b="1"/>
-              <a:t>Risk scoring design goal</a:t>
-            </a:r>
-          </a:p>
-        </p:txBody>
-      </p:sp>
-      <p:sp>
-        <p:nvSpPr>
-          <p:cNvPr id="3" name="內容版面配置區 2">
-            <a:extLst>
-              <a:ext uri="{FF2B5EF4-FFF2-40B4-BE49-F238E27FC236}">
-                <a16:creationId xmlns:a16="http://schemas.microsoft.com/office/drawing/2014/main" id="{85EB7868-0B10-4ADE-BF08-3CE42A258785}"/>
-              </a:ext>
-            </a:extLst>
-          </p:cNvPr>
-          <p:cNvSpPr>
-            <a:spLocks noGrp="1"/>
-          </p:cNvSpPr>
-          <p:nvPr>
-            <p:ph idx="1"/>
-          </p:nvPr>
-        </p:nvSpPr>
-        <p:spPr/>
-        <p:txBody>
-          <a:bodyPr/>
-          <a:lstStyle/>
-          <a:p>
-            <a:r>
-              <a:t>Present the overall design goal: use AP-side AoA and link observations to decide when RTS/CTS overhead is worthwhile.</a:t>
-            </a:r>
-          </a:p>
-          <a:p>
-            <a:r>
-              <a:t>Define the hidden-node risk score as the core decision variable for RTS threshold control.</a:t>
-            </a:r>
-          </a:p>
-        </p:txBody>
-      </p:sp>
-      <p:sp>
-        <p:nvSpPr>
-          <p:cNvPr id="4" name="投影片編號版面配置區 3">
-            <a:extLst>
-              <a:ext uri="{FF2B5EF4-FFF2-40B4-BE49-F238E27FC236}">
-                <a16:creationId xmlns:a16="http://schemas.microsoft.com/office/drawing/2014/main" id="{C2FCD405-600C-462A-BF29-DAFF79456778}"/>
+          <p:cNvPr id="2" name="?蔣?楊???ａ?蝵桀? 1">
+            <a:extLst>
+              <a:ext uri="{FF2B5EF4-FFF2-40B4-BE49-F238E27FC236}">
+                <a16:creationId xmlns:a16="http://schemas.microsoft.com/office/drawing/2014/main" id="{7C687AF8-AF63-1728-2C7B-76B8DC1837DE}"/>
               </a:ext>
             </a:extLst>
           </p:cNvPr>
@@ -8517,7 +8391,7 @@
             <a:pPr>
               <a:buNone/>
             </a:pPr>
-            <a:fld id="{CCF91274-D221-1BB4-3BF9-836E3AD31EBE}" type="slidenum">
+            <a:fld id="{B1C6C81E-38B9-7560-621D-5A151A79DF9B}" type="slidenum">
               <a:rPr sz="1400">
                 <a:latin typeface="Times New Roman"/>
                 <a:ea typeface="Times New Roman"/>
@@ -8533,10 +8407,131 @@
           </a:p>
         </p:txBody>
       </p:sp>
+      <p:sp>
+        <p:nvSpPr>
+          <p:cNvPr id="3" name="?批捆??蔭? 2">
+            <a:extLst>
+              <a:ext uri="{FF2B5EF4-FFF2-40B4-BE49-F238E27FC236}">
+                <a16:creationId xmlns:a16="http://schemas.microsoft.com/office/drawing/2014/main" id="{EFDF35B5-B6BD-325F-B271-EE42028230F3}"/>
+              </a:ext>
+            </a:extLst>
+          </p:cNvPr>
+          <p:cNvSpPr>
+            <a:spLocks noGrp="1"/>
+          </p:cNvSpPr>
+          <p:nvPr>
+            <p:ph idx="1"/>
+          </p:nvPr>
+        </p:nvSpPr>
+        <p:spPr/>
+        <p:txBody>
+          <a:bodyPr/>
+          <a:lstStyle/>
+          <a:p>
+            <a:r>
+              <a:rPr dirty="0">
+                <a:solidFill>
+                  <a:schemeClr val="bg1">
+                    <a:lumMod val="50000"/>
+                  </a:schemeClr>
+                </a:solidFill>
+              </a:rPr>
+              <a:t>Introduction</a:t>
+            </a:r>
+          </a:p>
+          <a:p>
+            <a:r>
+              <a:rPr dirty="0">
+                <a:solidFill>
+                  <a:schemeClr val="bg1">
+                    <a:lumMod val="50000"/>
+                  </a:schemeClr>
+                </a:solidFill>
+              </a:rPr>
+              <a:t>Background</a:t>
+            </a:r>
+          </a:p>
+          <a:p>
+            <a:r>
+              <a:rPr dirty="0" err="1"/>
+              <a:t>AoA</a:t>
+            </a:r>
+            <a:r>
+              <a:rPr dirty="0"/>
+              <a:t>-Assisted Risk Score and RTS</a:t>
+            </a:r>
+            <a:r>
+              <a:rPr dirty="0">
+                <a:solidFill>
+                  <a:schemeClr val="bg1">
+                    <a:lumMod val="50000"/>
+                  </a:schemeClr>
+                </a:solidFill>
+              </a:rPr>
+              <a:t> </a:t>
+            </a:r>
+            <a:r>
+              <a:rPr dirty="0"/>
+              <a:t>Threshold Adaptation</a:t>
+            </a:r>
+          </a:p>
+          <a:p>
+            <a:r>
+              <a:rPr dirty="0">
+                <a:solidFill>
+                  <a:schemeClr val="bg1">
+                    <a:lumMod val="50000"/>
+                  </a:schemeClr>
+                </a:solidFill>
+              </a:rPr>
+              <a:t>Evaluation</a:t>
+            </a:r>
+          </a:p>
+          <a:p>
+            <a:r>
+              <a:rPr dirty="0">
+                <a:solidFill>
+                  <a:schemeClr val="bg1">
+                    <a:lumMod val="50000"/>
+                  </a:schemeClr>
+                </a:solidFill>
+              </a:rPr>
+              <a:t>Conclusion</a:t>
+            </a:r>
+          </a:p>
+        </p:txBody>
+      </p:sp>
+      <p:sp>
+        <p:nvSpPr>
+          <p:cNvPr id="4" name="璅? 3">
+            <a:extLst>
+              <a:ext uri="{FF2B5EF4-FFF2-40B4-BE49-F238E27FC236}">
+                <a16:creationId xmlns:a16="http://schemas.microsoft.com/office/drawing/2014/main" id="{363B54DA-5A57-63A3-3957-4A5B100F1AAB}"/>
+              </a:ext>
+            </a:extLst>
+          </p:cNvPr>
+          <p:cNvSpPr>
+            <a:spLocks noGrp="1"/>
+          </p:cNvSpPr>
+          <p:nvPr>
+            <p:ph type="title"/>
+          </p:nvPr>
+        </p:nvSpPr>
+        <p:spPr/>
+        <p:txBody>
+          <a:bodyPr/>
+          <a:lstStyle/>
+          <a:p>
+            <a:r>
+              <a:t>Outline</a:t>
+            </a:r>
+          </a:p>
+        </p:txBody>
+      </p:sp>
     </p:spTree>
     <p:extLst>
       <p:ext uri="{BB962C8B-B14F-4D97-AF65-F5344CB8AC3E}">
-        <p14:creationId xmlns:p14="http://schemas.microsoft.com/office/powerpoint/2010/main" val="3499234266"/>
+        <p14:creationId xmlns:p14="http://schemas.microsoft.com/office/powerpoint/2010/main" val="2663263701"/>
       </p:ext>
     </p:extLst>
   </p:cSld>
@@ -8586,7 +8581,7 @@
           <a:p>
             <a:r>
               <a:rPr b="1"/>
-              <a:t>AoA and link features for hidden-node risk</a:t>
+              <a:t>Risk scoring design goal</a:t>
             </a:r>
           </a:p>
         </p:txBody>
@@ -8613,12 +8608,12 @@
           <a:lstStyle/>
           <a:p>
             <a:r>
-              <a:t>Use AoA estimates from AP-side multi-antenna CSI as the main spatial feature for judging whether two clients are likely to be hidden from each other.</a:t>
-            </a:r>
-          </a:p>
-          <a:p>
-            <a:r>
-              <a:t>Combine AoA-based spatial separation with retry behavior, RSSI, MCS, and traffic activity so the score reflects both geometry and observed collision symptoms.</a:t>
+              <a:t>Present the overall design goal: use AP-side AoA and link observations to decide when RTS/CTS overhead is worthwhile.</a:t>
+            </a:r>
+          </a:p>
+          <a:p>
+            <a:r>
+              <a:t>Define the hidden-node risk score as the core decision variable for RTS threshold control.</a:t>
             </a:r>
           </a:p>
         </p:txBody>
@@ -8647,7 +8642,7 @@
             <a:pPr>
               <a:buNone/>
             </a:pPr>
-            <a:fld id="{844E025A-983C-6D44-79C6-4612AACD43FC}" type="slidenum">
+            <a:fld id="{CCF91274-D221-1BB4-3BF9-836E3AD31EBE}" type="slidenum">
               <a:rPr sz="1400">
                 <a:latin typeface="Times New Roman"/>
                 <a:ea typeface="Times New Roman"/>
@@ -8716,7 +8711,7 @@
           <a:p>
             <a:r>
               <a:rPr b="1"/>
-              <a:t>RTS threshold adaptation rule</a:t>
+              <a:t>AoA and link features for hidden-node risk</a:t>
             </a:r>
           </a:p>
         </p:txBody>
@@ -8743,12 +8738,12 @@
           <a:lstStyle/>
           <a:p>
             <a:r>
-              <a:t>Present the RTS threshold adaptation rule: lower the threshold when hidden-node risk is high, and restore or raise it when risk is low to avoid unnecessary RTS/CTS overhead.</a:t>
-            </a:r>
-          </a:p>
-          <a:p>
-            <a:r>
-              <a:t>Include smoothing and hysteresis so the RTS threshold does not oscillate under noisy AoA or retry measurements.</a:t>
+              <a:t>Use AoA estimates from AP-side multi-antenna CSI as the main spatial feature for judging whether two clients are likely to be hidden from each other.</a:t>
+            </a:r>
+          </a:p>
+          <a:p>
+            <a:r>
+              <a:t>Combine AoA-based spatial separation with retry behavior, RSSI, MCS, and traffic activity so the score reflects both geometry and observed collision symptoms.</a:t>
             </a:r>
           </a:p>
         </p:txBody>
@@ -8777,7 +8772,7 @@
             <a:pPr>
               <a:buNone/>
             </a:pPr>
-            <a:fld id="{0BB18BA8-60F4-C50D-CD9B-1BB87D3E8506}" type="slidenum">
+            <a:fld id="{844E025A-983C-6D44-79C6-4612AACD43FC}" type="slidenum">
               <a:rPr sz="1400">
                 <a:latin typeface="Times New Roman"/>
                 <a:ea typeface="Times New Roman"/>
@@ -8825,10 +8820,70 @@
       </p:grpSpPr>
       <p:sp>
         <p:nvSpPr>
-          <p:cNvPr id="2" name="?蔣?楊???ａ?蝵桀? 1">
-            <a:extLst>
-              <a:ext uri="{FF2B5EF4-FFF2-40B4-BE49-F238E27FC236}">
-                <a16:creationId xmlns:a16="http://schemas.microsoft.com/office/drawing/2014/main" id="{7C687AF8-AF63-1728-2C7B-76B8DC1837DE}"/>
+          <p:cNvPr id="2" name="標題 1">
+            <a:extLst>
+              <a:ext uri="{FF2B5EF4-FFF2-40B4-BE49-F238E27FC236}">
+                <a16:creationId xmlns:a16="http://schemas.microsoft.com/office/drawing/2014/main" id="{27A3B284-1CEC-47E9-98B8-BA58ABCB5210}"/>
+              </a:ext>
+            </a:extLst>
+          </p:cNvPr>
+          <p:cNvSpPr>
+            <a:spLocks noGrp="1"/>
+          </p:cNvSpPr>
+          <p:nvPr>
+            <p:ph type="title"/>
+          </p:nvPr>
+        </p:nvSpPr>
+        <p:spPr/>
+        <p:txBody>
+          <a:bodyPr/>
+          <a:lstStyle/>
+          <a:p>
+            <a:r>
+              <a:rPr b="1"/>
+              <a:t>RTS threshold adaptation rule</a:t>
+            </a:r>
+          </a:p>
+        </p:txBody>
+      </p:sp>
+      <p:sp>
+        <p:nvSpPr>
+          <p:cNvPr id="3" name="內容版面配置區 2">
+            <a:extLst>
+              <a:ext uri="{FF2B5EF4-FFF2-40B4-BE49-F238E27FC236}">
+                <a16:creationId xmlns:a16="http://schemas.microsoft.com/office/drawing/2014/main" id="{85EB7868-0B10-4ADE-BF08-3CE42A258785}"/>
+              </a:ext>
+            </a:extLst>
+          </p:cNvPr>
+          <p:cNvSpPr>
+            <a:spLocks noGrp="1"/>
+          </p:cNvSpPr>
+          <p:nvPr>
+            <p:ph idx="1"/>
+          </p:nvPr>
+        </p:nvSpPr>
+        <p:spPr/>
+        <p:txBody>
+          <a:bodyPr/>
+          <a:lstStyle/>
+          <a:p>
+            <a:r>
+              <a:t>Present the RTS threshold adaptation rule: lower the threshold when hidden-node risk is high, and restore or raise it when risk is low to avoid unnecessary RTS/CTS overhead.</a:t>
+            </a:r>
+          </a:p>
+          <a:p>
+            <a:r>
+              <a:t>Include smoothing and hysteresis so the RTS threshold does not oscillate under noisy AoA or retry measurements.</a:t>
+            </a:r>
+          </a:p>
+        </p:txBody>
+      </p:sp>
+      <p:sp>
+        <p:nvSpPr>
+          <p:cNvPr id="4" name="投影片編號版面配置區 3">
+            <a:extLst>
+              <a:ext uri="{FF2B5EF4-FFF2-40B4-BE49-F238E27FC236}">
+                <a16:creationId xmlns:a16="http://schemas.microsoft.com/office/drawing/2014/main" id="{C2FCD405-600C-462A-BF29-DAFF79456778}"/>
               </a:ext>
             </a:extLst>
           </p:cNvPr>
@@ -8847,7 +8902,7 @@
             <a:pPr>
               <a:buNone/>
             </a:pPr>
-            <a:fld id="{F3AE1AE4-D79E-94D6-E825-3FC6C21A77D2}" type="slidenum">
+            <a:fld id="{0BB18BA8-60F4-C50D-CD9B-1BB87D3E8506}" type="slidenum">
               <a:rPr sz="1400">
                 <a:latin typeface="Times New Roman"/>
                 <a:ea typeface="Times New Roman"/>
@@ -8863,123 +8918,10 @@
           </a:p>
         </p:txBody>
       </p:sp>
-      <p:sp>
-        <p:nvSpPr>
-          <p:cNvPr id="3" name="?批捆??蔭? 2">
-            <a:extLst>
-              <a:ext uri="{FF2B5EF4-FFF2-40B4-BE49-F238E27FC236}">
-                <a16:creationId xmlns:a16="http://schemas.microsoft.com/office/drawing/2014/main" id="{EFDF35B5-B6BD-325F-B271-EE42028230F3}"/>
-              </a:ext>
-            </a:extLst>
-          </p:cNvPr>
-          <p:cNvSpPr>
-            <a:spLocks noGrp="1"/>
-          </p:cNvSpPr>
-          <p:nvPr>
-            <p:ph idx="1"/>
-          </p:nvPr>
-        </p:nvSpPr>
-        <p:spPr/>
-        <p:txBody>
-          <a:bodyPr/>
-          <a:lstStyle/>
-          <a:p>
-            <a:r>
-              <a:rPr dirty="0">
-                <a:solidFill>
-                  <a:schemeClr val="bg1">
-                    <a:lumMod val="50000"/>
-                  </a:schemeClr>
-                </a:solidFill>
-              </a:rPr>
-              <a:t>Introduction</a:t>
-            </a:r>
-          </a:p>
-          <a:p>
-            <a:r>
-              <a:rPr dirty="0">
-                <a:solidFill>
-                  <a:schemeClr val="bg1">
-                    <a:lumMod val="50000"/>
-                  </a:schemeClr>
-                </a:solidFill>
-              </a:rPr>
-              <a:t>Background</a:t>
-            </a:r>
-          </a:p>
-          <a:p>
-            <a:r>
-              <a:rPr dirty="0" err="1">
-                <a:solidFill>
-                  <a:schemeClr val="bg1">
-                    <a:lumMod val="50000"/>
-                  </a:schemeClr>
-                </a:solidFill>
-              </a:rPr>
-              <a:t>AoA</a:t>
-            </a:r>
-            <a:r>
-              <a:rPr dirty="0">
-                <a:solidFill>
-                  <a:schemeClr val="bg1">
-                    <a:lumMod val="50000"/>
-                  </a:schemeClr>
-                </a:solidFill>
-              </a:rPr>
-              <a:t>-Assisted Risk Score and RTS Threshold Adaptation</a:t>
-            </a:r>
-          </a:p>
-          <a:p>
-            <a:r>
-              <a:rPr dirty="0"/>
-              <a:t>Evaluation</a:t>
-            </a:r>
-          </a:p>
-          <a:p>
-            <a:r>
-              <a:rPr dirty="0">
-                <a:solidFill>
-                  <a:schemeClr val="bg1">
-                    <a:lumMod val="50000"/>
-                  </a:schemeClr>
-                </a:solidFill>
-              </a:rPr>
-              <a:t>Conclusion</a:t>
-            </a:r>
-          </a:p>
-        </p:txBody>
-      </p:sp>
-      <p:sp>
-        <p:nvSpPr>
-          <p:cNvPr id="4" name="璅? 3">
-            <a:extLst>
-              <a:ext uri="{FF2B5EF4-FFF2-40B4-BE49-F238E27FC236}">
-                <a16:creationId xmlns:a16="http://schemas.microsoft.com/office/drawing/2014/main" id="{363B54DA-5A57-63A3-3957-4A5B100F1AAB}"/>
-              </a:ext>
-            </a:extLst>
-          </p:cNvPr>
-          <p:cNvSpPr>
-            <a:spLocks noGrp="1"/>
-          </p:cNvSpPr>
-          <p:nvPr>
-            <p:ph type="title"/>
-          </p:nvPr>
-        </p:nvSpPr>
-        <p:spPr/>
-        <p:txBody>
-          <a:bodyPr/>
-          <a:lstStyle/>
-          <a:p>
-            <a:r>
-              <a:t>Outline</a:t>
-            </a:r>
-          </a:p>
-        </p:txBody>
-      </p:sp>
     </p:spTree>
     <p:extLst>
       <p:ext uri="{BB962C8B-B14F-4D97-AF65-F5344CB8AC3E}">
-        <p14:creationId xmlns:p14="http://schemas.microsoft.com/office/powerpoint/2010/main" val="346352892"/>
+        <p14:creationId xmlns:p14="http://schemas.microsoft.com/office/powerpoint/2010/main" val="3499234266"/>
       </p:ext>
     </p:extLst>
   </p:cSld>
@@ -9008,75 +8950,10 @@
       </p:grpSpPr>
       <p:sp>
         <p:nvSpPr>
-          <p:cNvPr id="2" name="標題 1">
-            <a:extLst>
-              <a:ext uri="{FF2B5EF4-FFF2-40B4-BE49-F238E27FC236}">
-                <a16:creationId xmlns:a16="http://schemas.microsoft.com/office/drawing/2014/main" id="{27A3B284-1CEC-47E9-98B8-BA58ABCB5210}"/>
-              </a:ext>
-            </a:extLst>
-          </p:cNvPr>
-          <p:cNvSpPr>
-            <a:spLocks noGrp="1"/>
-          </p:cNvSpPr>
-          <p:nvPr>
-            <p:ph type="title"/>
-          </p:nvPr>
-        </p:nvSpPr>
-        <p:spPr/>
-        <p:txBody>
-          <a:bodyPr/>
-          <a:lstStyle/>
-          <a:p>
-            <a:r>
-              <a:rPr b="1"/>
-              <a:t>Evaluation scenarios, baselines, and metrics</a:t>
-            </a:r>
-          </a:p>
-        </p:txBody>
-      </p:sp>
-      <p:sp>
-        <p:nvSpPr>
-          <p:cNvPr id="3" name="內容版面配置區 2">
-            <a:extLst>
-              <a:ext uri="{FF2B5EF4-FFF2-40B4-BE49-F238E27FC236}">
-                <a16:creationId xmlns:a16="http://schemas.microsoft.com/office/drawing/2014/main" id="{85EB7868-0B10-4ADE-BF08-3CE42A258785}"/>
-              </a:ext>
-            </a:extLst>
-          </p:cNvPr>
-          <p:cNvSpPr>
-            <a:spLocks noGrp="1"/>
-          </p:cNvSpPr>
-          <p:nvPr>
-            <p:ph idx="1"/>
-          </p:nvPr>
-        </p:nvSpPr>
-        <p:spPr/>
-        <p:txBody>
-          <a:bodyPr/>
-          <a:lstStyle/>
-          <a:p>
-            <a:r>
-              <a:t>Define test scenarios for hidden-node and non-hidden-node conditions.</a:t>
-            </a:r>
-          </a:p>
-          <a:p>
-            <a:r>
-              <a:t>Compare static RTS/CTS settings with the proposed AoA-assisted dynamic RTS threshold policy.</a:t>
-            </a:r>
-          </a:p>
-          <a:p>
-            <a:r>
-              <a:t>Measure throughput, retry rate, latency, MCS distribution, and fairness.</a:t>
-            </a:r>
-          </a:p>
-        </p:txBody>
-      </p:sp>
-      <p:sp>
-        <p:nvSpPr>
-          <p:cNvPr id="4" name="投影片編號版面配置區 3">
-            <a:extLst>
-              <a:ext uri="{FF2B5EF4-FFF2-40B4-BE49-F238E27FC236}">
-                <a16:creationId xmlns:a16="http://schemas.microsoft.com/office/drawing/2014/main" id="{C2FCD405-600C-462A-BF29-DAFF79456778}"/>
+          <p:cNvPr id="2" name="?蔣?楊???ａ?蝵桀? 1">
+            <a:extLst>
+              <a:ext uri="{FF2B5EF4-FFF2-40B4-BE49-F238E27FC236}">
+                <a16:creationId xmlns:a16="http://schemas.microsoft.com/office/drawing/2014/main" id="{7C687AF8-AF63-1728-2C7B-76B8DC1837DE}"/>
               </a:ext>
             </a:extLst>
           </p:cNvPr>
@@ -9095,7 +8972,7 @@
             <a:pPr>
               <a:buNone/>
             </a:pPr>
-            <a:fld id="{5AB55966-FA28-BC73-EA9E-53DF014DF033}" type="slidenum">
+            <a:fld id="{F3AE1AE4-D79E-94D6-E825-3FC6C21A77D2}" type="slidenum">
               <a:rPr sz="1400">
                 <a:latin typeface="Times New Roman"/>
                 <a:ea typeface="Times New Roman"/>
@@ -9111,10 +8988,123 @@
           </a:p>
         </p:txBody>
       </p:sp>
+      <p:sp>
+        <p:nvSpPr>
+          <p:cNvPr id="3" name="?批捆??蔭? 2">
+            <a:extLst>
+              <a:ext uri="{FF2B5EF4-FFF2-40B4-BE49-F238E27FC236}">
+                <a16:creationId xmlns:a16="http://schemas.microsoft.com/office/drawing/2014/main" id="{EFDF35B5-B6BD-325F-B271-EE42028230F3}"/>
+              </a:ext>
+            </a:extLst>
+          </p:cNvPr>
+          <p:cNvSpPr>
+            <a:spLocks noGrp="1"/>
+          </p:cNvSpPr>
+          <p:nvPr>
+            <p:ph idx="1"/>
+          </p:nvPr>
+        </p:nvSpPr>
+        <p:spPr/>
+        <p:txBody>
+          <a:bodyPr/>
+          <a:lstStyle/>
+          <a:p>
+            <a:r>
+              <a:rPr dirty="0">
+                <a:solidFill>
+                  <a:schemeClr val="bg1">
+                    <a:lumMod val="50000"/>
+                  </a:schemeClr>
+                </a:solidFill>
+              </a:rPr>
+              <a:t>Introduction</a:t>
+            </a:r>
+          </a:p>
+          <a:p>
+            <a:r>
+              <a:rPr dirty="0">
+                <a:solidFill>
+                  <a:schemeClr val="bg1">
+                    <a:lumMod val="50000"/>
+                  </a:schemeClr>
+                </a:solidFill>
+              </a:rPr>
+              <a:t>Background</a:t>
+            </a:r>
+          </a:p>
+          <a:p>
+            <a:r>
+              <a:rPr dirty="0" err="1">
+                <a:solidFill>
+                  <a:schemeClr val="bg1">
+                    <a:lumMod val="50000"/>
+                  </a:schemeClr>
+                </a:solidFill>
+              </a:rPr>
+              <a:t>AoA</a:t>
+            </a:r>
+            <a:r>
+              <a:rPr dirty="0">
+                <a:solidFill>
+                  <a:schemeClr val="bg1">
+                    <a:lumMod val="50000"/>
+                  </a:schemeClr>
+                </a:solidFill>
+              </a:rPr>
+              <a:t>-Assisted Risk Score and RTS Threshold Adaptation</a:t>
+            </a:r>
+          </a:p>
+          <a:p>
+            <a:r>
+              <a:rPr dirty="0"/>
+              <a:t>Evaluation</a:t>
+            </a:r>
+          </a:p>
+          <a:p>
+            <a:r>
+              <a:rPr dirty="0">
+                <a:solidFill>
+                  <a:schemeClr val="bg1">
+                    <a:lumMod val="50000"/>
+                  </a:schemeClr>
+                </a:solidFill>
+              </a:rPr>
+              <a:t>Conclusion</a:t>
+            </a:r>
+          </a:p>
+        </p:txBody>
+      </p:sp>
+      <p:sp>
+        <p:nvSpPr>
+          <p:cNvPr id="4" name="璅? 3">
+            <a:extLst>
+              <a:ext uri="{FF2B5EF4-FFF2-40B4-BE49-F238E27FC236}">
+                <a16:creationId xmlns:a16="http://schemas.microsoft.com/office/drawing/2014/main" id="{363B54DA-5A57-63A3-3957-4A5B100F1AAB}"/>
+              </a:ext>
+            </a:extLst>
+          </p:cNvPr>
+          <p:cNvSpPr>
+            <a:spLocks noGrp="1"/>
+          </p:cNvSpPr>
+          <p:nvPr>
+            <p:ph type="title"/>
+          </p:nvPr>
+        </p:nvSpPr>
+        <p:spPr/>
+        <p:txBody>
+          <a:bodyPr/>
+          <a:lstStyle/>
+          <a:p>
+            <a:r>
+              <a:t>Outline</a:t>
+            </a:r>
+          </a:p>
+        </p:txBody>
+      </p:sp>
     </p:spTree>
     <p:extLst>
       <p:ext uri="{BB962C8B-B14F-4D97-AF65-F5344CB8AC3E}">
-        <p14:creationId xmlns:p14="http://schemas.microsoft.com/office/powerpoint/2010/main" val="3499234266"/>
+        <p14:creationId xmlns:p14="http://schemas.microsoft.com/office/powerpoint/2010/main" val="346352892"/>
       </p:ext>
     </p:extLst>
   </p:cSld>
@@ -9164,7 +9154,7 @@
           <a:p>
             <a:r>
               <a:rPr b="1"/>
-              <a:t>Performance analysis focus</a:t>
+              <a:t>Evaluation scenarios, baselines, and metrics</a:t>
             </a:r>
           </a:p>
         </p:txBody>
@@ -9191,7 +9181,17 @@
           <a:lstStyle/>
           <a:p>
             <a:r>
-              <a:t>Analyze when the proposed method improves performance and when it has limited benefit.</a:t>
+              <a:t>Define test scenarios for hidden-node and non-hidden-node conditions.</a:t>
+            </a:r>
+          </a:p>
+          <a:p>
+            <a:r>
+              <a:t>Compare static RTS/CTS settings with the proposed AoA-assisted dynamic RTS threshold policy.</a:t>
+            </a:r>
+          </a:p>
+          <a:p>
+            <a:r>
+              <a:t>Measure throughput, retry rate, latency, MCS distribution, and fairness.</a:t>
             </a:r>
           </a:p>
         </p:txBody>
@@ -9220,7 +9220,7 @@
             <a:pPr>
               <a:buNone/>
             </a:pPr>
-            <a:fld id="{02F15020-66A7-620A-7B7A-C05C4312DEAE}" type="slidenum">
+            <a:fld id="{5AB55966-FA28-BC73-EA9E-53DF014DF033}" type="slidenum">
               <a:rPr sz="1400">
                 <a:latin typeface="Times New Roman"/>
                 <a:ea typeface="Times New Roman"/>
@@ -9268,10 +9268,65 @@
       </p:grpSpPr>
       <p:sp>
         <p:nvSpPr>
-          <p:cNvPr id="2" name="?蔣?楊???ａ?蝵桀? 1">
-            <a:extLst>
-              <a:ext uri="{FF2B5EF4-FFF2-40B4-BE49-F238E27FC236}">
-                <a16:creationId xmlns:a16="http://schemas.microsoft.com/office/drawing/2014/main" id="{7C687AF8-AF63-1728-2C7B-76B8DC1837DE}"/>
+          <p:cNvPr id="2" name="標題 1">
+            <a:extLst>
+              <a:ext uri="{FF2B5EF4-FFF2-40B4-BE49-F238E27FC236}">
+                <a16:creationId xmlns:a16="http://schemas.microsoft.com/office/drawing/2014/main" id="{27A3B284-1CEC-47E9-98B8-BA58ABCB5210}"/>
+              </a:ext>
+            </a:extLst>
+          </p:cNvPr>
+          <p:cNvSpPr>
+            <a:spLocks noGrp="1"/>
+          </p:cNvSpPr>
+          <p:nvPr>
+            <p:ph type="title"/>
+          </p:nvPr>
+        </p:nvSpPr>
+        <p:spPr/>
+        <p:txBody>
+          <a:bodyPr/>
+          <a:lstStyle/>
+          <a:p>
+            <a:r>
+              <a:rPr b="1"/>
+              <a:t>Performance analysis focus</a:t>
+            </a:r>
+          </a:p>
+        </p:txBody>
+      </p:sp>
+      <p:sp>
+        <p:nvSpPr>
+          <p:cNvPr id="3" name="內容版面配置區 2">
+            <a:extLst>
+              <a:ext uri="{FF2B5EF4-FFF2-40B4-BE49-F238E27FC236}">
+                <a16:creationId xmlns:a16="http://schemas.microsoft.com/office/drawing/2014/main" id="{85EB7868-0B10-4ADE-BF08-3CE42A258785}"/>
+              </a:ext>
+            </a:extLst>
+          </p:cNvPr>
+          <p:cNvSpPr>
+            <a:spLocks noGrp="1"/>
+          </p:cNvSpPr>
+          <p:nvPr>
+            <p:ph idx="1"/>
+          </p:nvPr>
+        </p:nvSpPr>
+        <p:spPr/>
+        <p:txBody>
+          <a:bodyPr/>
+          <a:lstStyle/>
+          <a:p>
+            <a:r>
+              <a:t>Analyze when the proposed method improves performance and when it has limited benefit.</a:t>
+            </a:r>
+          </a:p>
+        </p:txBody>
+      </p:sp>
+      <p:sp>
+        <p:nvSpPr>
+          <p:cNvPr id="4" name="投影片編號版面配置區 3">
+            <a:extLst>
+              <a:ext uri="{FF2B5EF4-FFF2-40B4-BE49-F238E27FC236}">
+                <a16:creationId xmlns:a16="http://schemas.microsoft.com/office/drawing/2014/main" id="{C2FCD405-600C-462A-BF29-DAFF79456778}"/>
               </a:ext>
             </a:extLst>
           </p:cNvPr>
@@ -9290,7 +9345,7 @@
             <a:pPr>
               <a:buNone/>
             </a:pPr>
-            <a:fld id="{68AD4375-9F50-F53A-6F9F-DD8473067C05}" type="slidenum">
+            <a:fld id="{02F15020-66A7-620A-7B7A-C05C4312DEAE}" type="slidenum">
               <a:rPr sz="1400">
                 <a:latin typeface="Times New Roman"/>
                 <a:ea typeface="Times New Roman"/>
@@ -9306,123 +9361,10 @@
           </a:p>
         </p:txBody>
       </p:sp>
-      <p:sp>
-        <p:nvSpPr>
-          <p:cNvPr id="3" name="?批捆??蔭? 2">
-            <a:extLst>
-              <a:ext uri="{FF2B5EF4-FFF2-40B4-BE49-F238E27FC236}">
-                <a16:creationId xmlns:a16="http://schemas.microsoft.com/office/drawing/2014/main" id="{EFDF35B5-B6BD-325F-B271-EE42028230F3}"/>
-              </a:ext>
-            </a:extLst>
-          </p:cNvPr>
-          <p:cNvSpPr>
-            <a:spLocks noGrp="1"/>
-          </p:cNvSpPr>
-          <p:nvPr>
-            <p:ph idx="1"/>
-          </p:nvPr>
-        </p:nvSpPr>
-        <p:spPr/>
-        <p:txBody>
-          <a:bodyPr/>
-          <a:lstStyle/>
-          <a:p>
-            <a:r>
-              <a:rPr dirty="0">
-                <a:solidFill>
-                  <a:schemeClr val="bg1">
-                    <a:lumMod val="50000"/>
-                  </a:schemeClr>
-                </a:solidFill>
-              </a:rPr>
-              <a:t>Introduction</a:t>
-            </a:r>
-          </a:p>
-          <a:p>
-            <a:r>
-              <a:rPr dirty="0">
-                <a:solidFill>
-                  <a:schemeClr val="bg1">
-                    <a:lumMod val="50000"/>
-                  </a:schemeClr>
-                </a:solidFill>
-              </a:rPr>
-              <a:t>Background</a:t>
-            </a:r>
-          </a:p>
-          <a:p>
-            <a:r>
-              <a:rPr dirty="0" err="1">
-                <a:solidFill>
-                  <a:schemeClr val="bg1">
-                    <a:lumMod val="50000"/>
-                  </a:schemeClr>
-                </a:solidFill>
-              </a:rPr>
-              <a:t>AoA</a:t>
-            </a:r>
-            <a:r>
-              <a:rPr dirty="0">
-                <a:solidFill>
-                  <a:schemeClr val="bg1">
-                    <a:lumMod val="50000"/>
-                  </a:schemeClr>
-                </a:solidFill>
-              </a:rPr>
-              <a:t>-Assisted Risk Score and RTS Threshold Adaptation</a:t>
-            </a:r>
-          </a:p>
-          <a:p>
-            <a:r>
-              <a:rPr dirty="0">
-                <a:solidFill>
-                  <a:schemeClr val="bg1">
-                    <a:lumMod val="50000"/>
-                  </a:schemeClr>
-                </a:solidFill>
-              </a:rPr>
-              <a:t>Evaluation</a:t>
-            </a:r>
-          </a:p>
-          <a:p>
-            <a:r>
-              <a:rPr dirty="0"/>
-              <a:t>Conclusion</a:t>
-            </a:r>
-          </a:p>
-        </p:txBody>
-      </p:sp>
-      <p:sp>
-        <p:nvSpPr>
-          <p:cNvPr id="4" name="璅? 3">
-            <a:extLst>
-              <a:ext uri="{FF2B5EF4-FFF2-40B4-BE49-F238E27FC236}">
-                <a16:creationId xmlns:a16="http://schemas.microsoft.com/office/drawing/2014/main" id="{363B54DA-5A57-63A3-3957-4A5B100F1AAB}"/>
-              </a:ext>
-            </a:extLst>
-          </p:cNvPr>
-          <p:cNvSpPr>
-            <a:spLocks noGrp="1"/>
-          </p:cNvSpPr>
-          <p:nvPr>
-            <p:ph type="title"/>
-          </p:nvPr>
-        </p:nvSpPr>
-        <p:spPr/>
-        <p:txBody>
-          <a:bodyPr/>
-          <a:lstStyle/>
-          <a:p>
-            <a:r>
-              <a:t>Outline</a:t>
-            </a:r>
-          </a:p>
-        </p:txBody>
-      </p:sp>
     </p:spTree>
     <p:extLst>
       <p:ext uri="{BB962C8B-B14F-4D97-AF65-F5344CB8AC3E}">
-        <p14:creationId xmlns:p14="http://schemas.microsoft.com/office/powerpoint/2010/main" val="756668717"/>
+        <p14:creationId xmlns:p14="http://schemas.microsoft.com/office/powerpoint/2010/main" val="3499234266"/>
       </p:ext>
     </p:extLst>
   </p:cSld>
@@ -9576,6 +9518,189 @@
     <p:extLst>
       <p:ext uri="{BB962C8B-B14F-4D97-AF65-F5344CB8AC3E}">
         <p14:creationId xmlns:p14="http://schemas.microsoft.com/office/powerpoint/2010/main" val="2443002048"/>
+      </p:ext>
+    </p:extLst>
+  </p:cSld>
+  <p:clrMapOvr>
+    <a:masterClrMapping/>
+  </p:clrMapOvr>
+</p:sld>
+</file>
+
+<file path=ppt/slides/slide20.xml><?xml version="1.0" encoding="utf-8"?>
+<p:sld xmlns:a="http://schemas.openxmlformats.org/drawingml/2006/main" xmlns:r="http://schemas.openxmlformats.org/officeDocument/2006/relationships" xmlns:p="http://schemas.openxmlformats.org/presentationml/2006/main">
+  <p:cSld>
+    <p:spTree>
+      <p:nvGrpSpPr>
+        <p:cNvPr id="1" name=""/>
+        <p:cNvGrpSpPr/>
+        <p:nvPr/>
+      </p:nvGrpSpPr>
+      <p:grpSpPr>
+        <a:xfrm>
+          <a:off x="0" y="0"/>
+          <a:ext cx="0" cy="0"/>
+          <a:chOff x="0" y="0"/>
+          <a:chExt cx="0" cy="0"/>
+        </a:xfrm>
+      </p:grpSpPr>
+      <p:sp>
+        <p:nvSpPr>
+          <p:cNvPr id="2" name="?蔣?楊???ａ?蝵桀? 1">
+            <a:extLst>
+              <a:ext uri="{FF2B5EF4-FFF2-40B4-BE49-F238E27FC236}">
+                <a16:creationId xmlns:a16="http://schemas.microsoft.com/office/drawing/2014/main" id="{7C687AF8-AF63-1728-2C7B-76B8DC1837DE}"/>
+              </a:ext>
+            </a:extLst>
+          </p:cNvPr>
+          <p:cNvSpPr>
+            <a:spLocks noGrp="1"/>
+          </p:cNvSpPr>
+          <p:nvPr>
+            <p:ph type="sldNum" idx="10"/>
+          </p:nvPr>
+        </p:nvSpPr>
+        <p:spPr/>
+        <p:txBody>
+          <a:bodyPr/>
+          <a:lstStyle/>
+          <a:p>
+            <a:pPr>
+              <a:buNone/>
+            </a:pPr>
+            <a:fld id="{68AD4375-9F50-F53A-6F9F-DD8473067C05}" type="slidenum">
+              <a:rPr sz="1400">
+                <a:latin typeface="Times New Roman"/>
+                <a:ea typeface="Times New Roman"/>
+                <a:cs typeface="Times New Roman"/>
+              </a:rPr>
+              <a:t>20</a:t>
+            </a:fld>
+            <a:endParaRPr sz="1400">
+              <a:latin typeface="Times New Roman"/>
+              <a:ea typeface="Times New Roman"/>
+              <a:cs typeface="Times New Roman"/>
+            </a:endParaRPr>
+          </a:p>
+        </p:txBody>
+      </p:sp>
+      <p:sp>
+        <p:nvSpPr>
+          <p:cNvPr id="3" name="?批捆??蔭? 2">
+            <a:extLst>
+              <a:ext uri="{FF2B5EF4-FFF2-40B4-BE49-F238E27FC236}">
+                <a16:creationId xmlns:a16="http://schemas.microsoft.com/office/drawing/2014/main" id="{EFDF35B5-B6BD-325F-B271-EE42028230F3}"/>
+              </a:ext>
+            </a:extLst>
+          </p:cNvPr>
+          <p:cNvSpPr>
+            <a:spLocks noGrp="1"/>
+          </p:cNvSpPr>
+          <p:nvPr>
+            <p:ph idx="1"/>
+          </p:nvPr>
+        </p:nvSpPr>
+        <p:spPr/>
+        <p:txBody>
+          <a:bodyPr/>
+          <a:lstStyle/>
+          <a:p>
+            <a:r>
+              <a:rPr dirty="0">
+                <a:solidFill>
+                  <a:schemeClr val="bg1">
+                    <a:lumMod val="50000"/>
+                  </a:schemeClr>
+                </a:solidFill>
+              </a:rPr>
+              <a:t>Introduction</a:t>
+            </a:r>
+          </a:p>
+          <a:p>
+            <a:r>
+              <a:rPr dirty="0">
+                <a:solidFill>
+                  <a:schemeClr val="bg1">
+                    <a:lumMod val="50000"/>
+                  </a:schemeClr>
+                </a:solidFill>
+              </a:rPr>
+              <a:t>Background</a:t>
+            </a:r>
+          </a:p>
+          <a:p>
+            <a:r>
+              <a:rPr dirty="0" err="1">
+                <a:solidFill>
+                  <a:schemeClr val="bg1">
+                    <a:lumMod val="50000"/>
+                  </a:schemeClr>
+                </a:solidFill>
+              </a:rPr>
+              <a:t>AoA</a:t>
+            </a:r>
+            <a:r>
+              <a:rPr dirty="0">
+                <a:solidFill>
+                  <a:schemeClr val="bg1">
+                    <a:lumMod val="50000"/>
+                  </a:schemeClr>
+                </a:solidFill>
+              </a:rPr>
+              <a:t>-Assisted Risk Score and RTS Threshold Adaptation</a:t>
+            </a:r>
+          </a:p>
+          <a:p>
+            <a:r>
+              <a:rPr dirty="0">
+                <a:solidFill>
+                  <a:schemeClr val="bg1">
+                    <a:lumMod val="50000"/>
+                  </a:schemeClr>
+                </a:solidFill>
+              </a:rPr>
+              <a:t>Evaluation</a:t>
+            </a:r>
+          </a:p>
+          <a:p>
+            <a:r>
+              <a:rPr dirty="0"/>
+              <a:t>Conclusion</a:t>
+            </a:r>
+          </a:p>
+        </p:txBody>
+      </p:sp>
+      <p:sp>
+        <p:nvSpPr>
+          <p:cNvPr id="4" name="璅? 3">
+            <a:extLst>
+              <a:ext uri="{FF2B5EF4-FFF2-40B4-BE49-F238E27FC236}">
+                <a16:creationId xmlns:a16="http://schemas.microsoft.com/office/drawing/2014/main" id="{363B54DA-5A57-63A3-3957-4A5B100F1AAB}"/>
+              </a:ext>
+            </a:extLst>
+          </p:cNvPr>
+          <p:cNvSpPr>
+            <a:spLocks noGrp="1"/>
+          </p:cNvSpPr>
+          <p:nvPr>
+            <p:ph type="title"/>
+          </p:nvPr>
+        </p:nvSpPr>
+        <p:spPr/>
+        <p:txBody>
+          <a:bodyPr/>
+          <a:lstStyle/>
+          <a:p>
+            <a:r>
+              <a:t>Outline</a:t>
+            </a:r>
+          </a:p>
+        </p:txBody>
+      </p:sp>
+    </p:spTree>
+    <p:extLst>
+      <p:ext uri="{BB962C8B-B14F-4D97-AF65-F5344CB8AC3E}">
+        <p14:creationId xmlns:p14="http://schemas.microsoft.com/office/powerpoint/2010/main" val="756668717"/>
       </p:ext>
     </p:extLst>
   </p:cSld>
@@ -10333,7 +10458,7 @@
           <a:p>
             <a:r>
               <a:rPr lang="en-US" altLang="zh-TW" dirty="0"/>
-              <a:t>RTS/CTS Mitigation with a Static RTS Threshold</a:t>
+              <a:t>RTS/CTS Mitigation</a:t>
             </a:r>
             <a:endParaRPr dirty="0"/>
           </a:p>
@@ -10362,49 +10487,81 @@
           <a:p>
             <a:r>
               <a:rPr lang="zh-TW" altLang="zh-TW" dirty="0"/>
-              <a:t>The RTS/CTS is </a:t>
+              <a:t>RTS/CTS is an optional 802.11 mechanism used before data transmission</a:t>
+            </a:r>
+            <a:endParaRPr lang="en-US" altLang="zh-TW" dirty="0"/>
+          </a:p>
+          <a:p>
+            <a:r>
+              <a:rPr lang="zh-TW" altLang="zh-TW" dirty="0"/>
+              <a:t>Sender first sends an </a:t>
+            </a:r>
+            <a:r>
+              <a:rPr lang="zh-TW" altLang="zh-TW" b="1" dirty="0"/>
+              <a:t>RTS</a:t>
+            </a:r>
+            <a:r>
+              <a:rPr lang="zh-TW" altLang="zh-TW" dirty="0"/>
+              <a:t> frame to request channel access</a:t>
+            </a:r>
+            <a:endParaRPr lang="en-US" altLang="zh-TW" dirty="0"/>
+          </a:p>
+          <a:p>
+            <a:r>
+              <a:rPr lang="zh-TW" altLang="zh-TW" dirty="0"/>
+              <a:t>Receiver replies with a </a:t>
+            </a:r>
+            <a:r>
+              <a:rPr lang="zh-TW" altLang="zh-TW" b="1" dirty="0"/>
+              <a:t>CTS</a:t>
+            </a:r>
+            <a:r>
+              <a:rPr lang="zh-TW" altLang="zh-TW" dirty="0"/>
+              <a:t> frame to grant transmission permission</a:t>
+            </a:r>
+            <a:endParaRPr lang="en-US" altLang="zh-TW" dirty="0"/>
+          </a:p>
+          <a:p>
+            <a:r>
+              <a:rPr lang="zh-TW" altLang="zh-TW" dirty="0"/>
+              <a:t>Nearby nodes that hear RTS or CTS update their </a:t>
+            </a:r>
+            <a:r>
+              <a:rPr lang="zh-TW" altLang="zh-TW" b="1" dirty="0"/>
+              <a:t>NAV</a:t>
+            </a:r>
+            <a:r>
+              <a:rPr lang="zh-TW" altLang="zh-TW" dirty="0"/>
+              <a:t> and defer transmission</a:t>
+            </a:r>
+            <a:endParaRPr lang="en-US" altLang="zh-TW" dirty="0"/>
+          </a:p>
+          <a:p>
+            <a:r>
+              <a:rPr lang="zh-TW" altLang="zh-TW" dirty="0"/>
+              <a:t>Hidden nodes that cannot hear the sender may still hear the receiver</a:t>
             </a:r>
             <a:r>
               <a:rPr lang="en-US" altLang="zh-TW" dirty="0"/>
-              <a:t>optional </a:t>
+              <a:t>’s </a:t>
             </a:r>
             <a:r>
               <a:rPr lang="zh-TW" altLang="zh-TW" dirty="0"/>
-              <a:t>mechanism</a:t>
-            </a:r>
+              <a:t>CTS, so they remain silent</a:t>
+            </a:r>
+            <a:endParaRPr lang="en-US" altLang="zh-TW" dirty="0"/>
+          </a:p>
+          <a:p>
             <a:r>
               <a:rPr lang="en-US" altLang="zh-TW" dirty="0"/>
-              <a:t> </a:t>
-            </a:r>
+              <a:t>Sender sends real data</a:t>
+            </a:r>
+          </a:p>
+          <a:p>
             <a:r>
               <a:rPr lang="zh-TW" altLang="zh-TW" dirty="0"/>
-              <a:t>used to address this problem by allowing nodes to reserve the channel before transmitting</a:t>
-            </a:r>
-            <a:r>
-              <a:rPr lang="en-US" altLang="zh-TW" dirty="0"/>
-              <a:t> in 802.11 protocol </a:t>
-            </a:r>
-          </a:p>
-          <a:p>
-            <a:r>
-              <a:rPr dirty="0"/>
-              <a:t>Describe the problem with static RTS threshold configuration: a low threshold adds unnecessary RTS/CTS overhead, while a high threshold may leave hidden-node collisions unresolved.</a:t>
-            </a:r>
-          </a:p>
-          <a:p>
-            <a:r>
-              <a:rPr lang="en-US" dirty="0"/>
-              <a:t>Static </a:t>
-            </a:r>
-            <a:r>
-              <a:rPr lang="en-US" dirty="0" err="1"/>
-              <a:t>rts</a:t>
-            </a:r>
-            <a:r>
-              <a:rPr lang="en-US" dirty="0"/>
-              <a:t> threshold setting ignores the physical location of STA</a:t>
-            </a:r>
-            <a:endParaRPr dirty="0"/>
+              <a:t>This reserves the channel around the receiver and reduces hidden-node collisions</a:t>
+            </a:r>
           </a:p>
         </p:txBody>
       </p:sp>
@@ -10448,6 +10605,42 @@
           </a:p>
         </p:txBody>
       </p:sp>
+      <p:pic>
+        <p:nvPicPr>
+          <p:cNvPr id="8" name="圖片 7">
+            <a:extLst>
+              <a:ext uri="{FF2B5EF4-FFF2-40B4-BE49-F238E27FC236}">
+                <a16:creationId xmlns:a16="http://schemas.microsoft.com/office/drawing/2014/main" id="{248C459E-E296-531E-6CCD-6F0C86BABD8B}"/>
+              </a:ext>
+            </a:extLst>
+          </p:cNvPr>
+          <p:cNvPicPr>
+            <a:picLocks noChangeAspect="1"/>
+          </p:cNvPicPr>
+          <p:nvPr/>
+        </p:nvPicPr>
+        <p:blipFill>
+          <a:blip r:embed="rId3">
+            <a:extLst>
+              <a:ext uri="{28A0092B-C50C-407E-A947-70E740481C1C}">
+                <a14:useLocalDpi xmlns:a14="http://schemas.microsoft.com/office/drawing/2010/main" val="0"/>
+              </a:ext>
+            </a:extLst>
+          </a:blip>
+          <a:stretch>
+            <a:fillRect/>
+          </a:stretch>
+        </p:blipFill>
+        <p:spPr>
+          <a:xfrm>
+            <a:off x="7482348" y="4216853"/>
+            <a:ext cx="3784424" cy="2129870"/>
+          </a:xfrm>
+          <a:prstGeom prst="rect">
+            <a:avLst/>
+          </a:prstGeom>
+        </p:spPr>
+      </p:pic>
     </p:spTree>
     <p:extLst>
       <p:ext uri="{BB962C8B-B14F-4D97-AF65-F5344CB8AC3E}">
@@ -10483,7 +10676,7 @@
           <p:cNvPr id="2" name="標題 1">
             <a:extLst>
               <a:ext uri="{FF2B5EF4-FFF2-40B4-BE49-F238E27FC236}">
-                <a16:creationId xmlns:a16="http://schemas.microsoft.com/office/drawing/2014/main" id="{D43E4731-F479-499C-B7C2-9844D12AF6ED}"/>
+                <a16:creationId xmlns:a16="http://schemas.microsoft.com/office/drawing/2014/main" id="{E6F2DD0D-1D70-1D78-D9B0-90C63959F1E3}"/>
               </a:ext>
             </a:extLst>
           </p:cNvPr>
@@ -10500,9 +10693,10 @@
           <a:lstStyle/>
           <a:p>
             <a:r>
-              <a:rPr dirty="0"/>
-              <a:t>Hidden-Node Risk-Aware RTS Threshold Control</a:t>
-            </a:r>
+              <a:rPr lang="zh-TW" altLang="zh-TW" dirty="0"/>
+              <a:t>Static RTS Threshold Limitation</a:t>
+            </a:r>
+            <a:endParaRPr lang="zh-TW" altLang="en-US" dirty="0"/>
           </a:p>
         </p:txBody>
       </p:sp>
@@ -10511,7 +10705,7 @@
           <p:cNvPr id="3" name="內容版面配置區 2">
             <a:extLst>
               <a:ext uri="{FF2B5EF4-FFF2-40B4-BE49-F238E27FC236}">
-                <a16:creationId xmlns:a16="http://schemas.microsoft.com/office/drawing/2014/main" id="{B761585F-5E53-49CE-948C-C549D563F1B7}"/>
+                <a16:creationId xmlns:a16="http://schemas.microsoft.com/office/drawing/2014/main" id="{34136766-374A-47FB-0C3F-8E137D598879}"/>
               </a:ext>
             </a:extLst>
           </p:cNvPr>
@@ -10528,33 +10722,25 @@
           <a:lstStyle/>
           <a:p>
             <a:r>
-              <a:rPr dirty="0"/>
-              <a:t>State the thesis goal early: let the AP infer hidden-node risk from </a:t>
-            </a:r>
-            <a:r>
-              <a:rPr lang="en-US" altLang="zh-TW" dirty="0"/>
-              <a:t>Angle of Arrival </a:t>
-            </a:r>
-            <a:r>
-              <a:rPr lang="zh-TW" altLang="en-US" dirty="0"/>
-              <a:t> </a:t>
-            </a:r>
-            <a:r>
-              <a:rPr lang="en-US" altLang="zh-TW" dirty="0"/>
-              <a:t>(</a:t>
-            </a:r>
-            <a:r>
-              <a:rPr dirty="0" err="1"/>
-              <a:t>AoA</a:t>
-            </a:r>
-            <a:r>
-              <a:rPr lang="en-US" altLang="zh-TW" dirty="0"/>
-              <a:t>)</a:t>
-            </a:r>
-            <a:r>
-              <a:rPr dirty="0"/>
-              <a:t> and link observations, then tune the RTS threshold dynamically.</a:t>
-            </a:r>
+              <a:rPr lang="zh-TW" altLang="zh-TW" dirty="0"/>
+              <a:t>In conventional 802.11, the RTS threshold is usually configured as a </a:t>
+            </a:r>
+            <a:r>
+              <a:rPr lang="zh-TW" altLang="zh-TW" b="1" dirty="0"/>
+              <a:t>static value</a:t>
+            </a:r>
+            <a:r>
+              <a:rPr lang="zh-TW" altLang="zh-TW" dirty="0"/>
+              <a:t>.</a:t>
+            </a:r>
+            <a:endParaRPr lang="en-US" altLang="zh-TW" dirty="0"/>
+          </a:p>
+          <a:p>
+            <a:r>
+              <a:rPr lang="zh-TW" altLang="zh-TW" dirty="0"/>
+              <a:t>Because the threshold is fixed, it cannot adapt to STA physical location or hidden-node conditions.</a:t>
+            </a:r>
+            <a:endParaRPr lang="zh-TW" altLang="en-US" dirty="0"/>
           </a:p>
         </p:txBody>
       </p:sp>
@@ -10563,7 +10749,7 @@
           <p:cNvPr id="4" name="投影片編號版面配置區 3">
             <a:extLst>
               <a:ext uri="{FF2B5EF4-FFF2-40B4-BE49-F238E27FC236}">
-                <a16:creationId xmlns:a16="http://schemas.microsoft.com/office/drawing/2014/main" id="{6AAF4DB3-7A18-4C4D-BCB8-F507050E88E2}"/>
+                <a16:creationId xmlns:a16="http://schemas.microsoft.com/office/drawing/2014/main" id="{9F806ABC-C321-A438-42AC-DBE888404EEA}"/>
               </a:ext>
             </a:extLst>
           </p:cNvPr>
@@ -10582,15 +10768,15 @@
             <a:pPr>
               <a:buNone/>
             </a:pPr>
-            <a:fld id="{BA58DA2A-B818-18A9-29C1-B697728D5BCE}" type="slidenum">
-              <a:rPr sz="1400">
+            <a:fld id="{DBC8A1ED-4F98-4D8C-81F6-271243F7D6B0}" type="slidenum">
+              <a:rPr lang="en-US" altLang="zh-TW" sz="1400" smtClean="0">
                 <a:latin typeface="Times New Roman"/>
                 <a:ea typeface="Times New Roman"/>
                 <a:cs typeface="Times New Roman"/>
               </a:rPr>
               <a:t>6</a:t>
             </a:fld>
-            <a:endParaRPr sz="1400">
+            <a:endParaRPr lang="en-US" altLang="zh-TW" sz="1400">
               <a:latin typeface="Times New Roman"/>
               <a:ea typeface="Times New Roman"/>
               <a:cs typeface="Times New Roman"/>
@@ -10601,7 +10787,7 @@
     </p:spTree>
     <p:extLst>
       <p:ext uri="{BB962C8B-B14F-4D97-AF65-F5344CB8AC3E}">
-        <p14:creationId xmlns:p14="http://schemas.microsoft.com/office/powerpoint/2010/main" val="1204145841"/>
+        <p14:creationId xmlns:p14="http://schemas.microsoft.com/office/powerpoint/2010/main" val="1435331515"/>
       </p:ext>
     </p:extLst>
   </p:cSld>
@@ -10630,10 +10816,90 @@
       </p:grpSpPr>
       <p:sp>
         <p:nvSpPr>
-          <p:cNvPr id="2" name="?蔣?楊???ａ?蝵桀? 1">
-            <a:extLst>
-              <a:ext uri="{FF2B5EF4-FFF2-40B4-BE49-F238E27FC236}">
-                <a16:creationId xmlns:a16="http://schemas.microsoft.com/office/drawing/2014/main" id="{7C687AF8-AF63-1728-2C7B-76B8DC1837DE}"/>
+          <p:cNvPr id="2" name="標題 1">
+            <a:extLst>
+              <a:ext uri="{FF2B5EF4-FFF2-40B4-BE49-F238E27FC236}">
+                <a16:creationId xmlns:a16="http://schemas.microsoft.com/office/drawing/2014/main" id="{D43E4731-F479-499C-B7C2-9844D12AF6ED}"/>
+              </a:ext>
+            </a:extLst>
+          </p:cNvPr>
+          <p:cNvSpPr>
+            <a:spLocks noGrp="1"/>
+          </p:cNvSpPr>
+          <p:nvPr>
+            <p:ph type="title"/>
+          </p:nvPr>
+        </p:nvSpPr>
+        <p:spPr/>
+        <p:txBody>
+          <a:bodyPr/>
+          <a:lstStyle/>
+          <a:p>
+            <a:r>
+              <a:rPr dirty="0"/>
+              <a:t>Hidden-Node Risk-Aware RTS Threshold Control</a:t>
+            </a:r>
+          </a:p>
+        </p:txBody>
+      </p:sp>
+      <p:sp>
+        <p:nvSpPr>
+          <p:cNvPr id="3" name="內容版面配置區 2">
+            <a:extLst>
+              <a:ext uri="{FF2B5EF4-FFF2-40B4-BE49-F238E27FC236}">
+                <a16:creationId xmlns:a16="http://schemas.microsoft.com/office/drawing/2014/main" id="{B761585F-5E53-49CE-948C-C549D563F1B7}"/>
+              </a:ext>
+            </a:extLst>
+          </p:cNvPr>
+          <p:cNvSpPr>
+            <a:spLocks noGrp="1"/>
+          </p:cNvSpPr>
+          <p:nvPr>
+            <p:ph idx="1"/>
+          </p:nvPr>
+        </p:nvSpPr>
+        <p:spPr/>
+        <p:txBody>
+          <a:bodyPr/>
+          <a:lstStyle/>
+          <a:p>
+            <a:r>
+              <a:rPr dirty="0"/>
+              <a:t>State the thesis goal early: let the AP infer hidden-node risk from </a:t>
+            </a:r>
+            <a:r>
+              <a:rPr lang="en-US" altLang="zh-TW" dirty="0"/>
+              <a:t>Angle of Arrival </a:t>
+            </a:r>
+            <a:r>
+              <a:rPr lang="zh-TW" altLang="en-US" dirty="0"/>
+              <a:t> </a:t>
+            </a:r>
+            <a:r>
+              <a:rPr lang="en-US" altLang="zh-TW" dirty="0"/>
+              <a:t>(</a:t>
+            </a:r>
+            <a:r>
+              <a:rPr dirty="0" err="1"/>
+              <a:t>AoA</a:t>
+            </a:r>
+            <a:r>
+              <a:rPr lang="en-US" altLang="zh-TW" dirty="0"/>
+              <a:t>)</a:t>
+            </a:r>
+            <a:r>
+              <a:rPr dirty="0"/>
+              <a:t> and link observations, then tune the RTS threshold dynamically.</a:t>
+            </a:r>
+          </a:p>
+        </p:txBody>
+      </p:sp>
+      <p:sp>
+        <p:nvSpPr>
+          <p:cNvPr id="4" name="投影片編號版面配置區 3">
+            <a:extLst>
+              <a:ext uri="{FF2B5EF4-FFF2-40B4-BE49-F238E27FC236}">
+                <a16:creationId xmlns:a16="http://schemas.microsoft.com/office/drawing/2014/main" id="{6AAF4DB3-7A18-4C4D-BCB8-F507050E88E2}"/>
               </a:ext>
             </a:extLst>
           </p:cNvPr>
@@ -10652,7 +10918,7 @@
             <a:pPr>
               <a:buNone/>
             </a:pPr>
-            <a:fld id="{388657AE-30A1-5A7A-6A7F-315D84436430}" type="slidenum">
+            <a:fld id="{BA58DA2A-B818-18A9-29C1-B697728D5BCE}" type="slidenum">
               <a:rPr sz="1400">
                 <a:latin typeface="Times New Roman"/>
                 <a:ea typeface="Times New Roman"/>
@@ -10668,123 +10934,10 @@
           </a:p>
         </p:txBody>
       </p:sp>
-      <p:sp>
-        <p:nvSpPr>
-          <p:cNvPr id="3" name="?批捆??蔭? 2">
-            <a:extLst>
-              <a:ext uri="{FF2B5EF4-FFF2-40B4-BE49-F238E27FC236}">
-                <a16:creationId xmlns:a16="http://schemas.microsoft.com/office/drawing/2014/main" id="{EFDF35B5-B6BD-325F-B271-EE42028230F3}"/>
-              </a:ext>
-            </a:extLst>
-          </p:cNvPr>
-          <p:cNvSpPr>
-            <a:spLocks noGrp="1"/>
-          </p:cNvSpPr>
-          <p:nvPr>
-            <p:ph idx="1"/>
-          </p:nvPr>
-        </p:nvSpPr>
-        <p:spPr/>
-        <p:txBody>
-          <a:bodyPr/>
-          <a:lstStyle/>
-          <a:p>
-            <a:r>
-              <a:rPr dirty="0">
-                <a:solidFill>
-                  <a:schemeClr val="bg1">
-                    <a:lumMod val="50000"/>
-                  </a:schemeClr>
-                </a:solidFill>
-              </a:rPr>
-              <a:t>Introduction</a:t>
-            </a:r>
-          </a:p>
-          <a:p>
-            <a:r>
-              <a:rPr dirty="0"/>
-              <a:t>Background</a:t>
-            </a:r>
-          </a:p>
-          <a:p>
-            <a:r>
-              <a:rPr dirty="0" err="1">
-                <a:solidFill>
-                  <a:schemeClr val="bg1">
-                    <a:lumMod val="50000"/>
-                  </a:schemeClr>
-                </a:solidFill>
-              </a:rPr>
-              <a:t>AoA</a:t>
-            </a:r>
-            <a:r>
-              <a:rPr dirty="0">
-                <a:solidFill>
-                  <a:schemeClr val="bg1">
-                    <a:lumMod val="50000"/>
-                  </a:schemeClr>
-                </a:solidFill>
-              </a:rPr>
-              <a:t>-Assisted Risk Score and RTS Threshold Adaptation</a:t>
-            </a:r>
-          </a:p>
-          <a:p>
-            <a:r>
-              <a:rPr dirty="0">
-                <a:solidFill>
-                  <a:schemeClr val="bg1">
-                    <a:lumMod val="50000"/>
-                  </a:schemeClr>
-                </a:solidFill>
-              </a:rPr>
-              <a:t>Evaluation</a:t>
-            </a:r>
-          </a:p>
-          <a:p>
-            <a:r>
-              <a:rPr dirty="0">
-                <a:solidFill>
-                  <a:schemeClr val="bg1">
-                    <a:lumMod val="50000"/>
-                  </a:schemeClr>
-                </a:solidFill>
-              </a:rPr>
-              <a:t>Conclusion</a:t>
-            </a:r>
-          </a:p>
-        </p:txBody>
-      </p:sp>
-      <p:sp>
-        <p:nvSpPr>
-          <p:cNvPr id="4" name="璅? 3">
-            <a:extLst>
-              <a:ext uri="{FF2B5EF4-FFF2-40B4-BE49-F238E27FC236}">
-                <a16:creationId xmlns:a16="http://schemas.microsoft.com/office/drawing/2014/main" id="{363B54DA-5A57-63A3-3957-4A5B100F1AAB}"/>
-              </a:ext>
-            </a:extLst>
-          </p:cNvPr>
-          <p:cNvSpPr>
-            <a:spLocks noGrp="1"/>
-          </p:cNvSpPr>
-          <p:nvPr>
-            <p:ph type="title"/>
-          </p:nvPr>
-        </p:nvSpPr>
-        <p:spPr/>
-        <p:txBody>
-          <a:bodyPr/>
-          <a:lstStyle/>
-          <a:p>
-            <a:r>
-              <a:t>Outline</a:t>
-            </a:r>
-          </a:p>
-        </p:txBody>
-      </p:sp>
     </p:spTree>
     <p:extLst>
       <p:ext uri="{BB962C8B-B14F-4D97-AF65-F5344CB8AC3E}">
-        <p14:creationId xmlns:p14="http://schemas.microsoft.com/office/powerpoint/2010/main" val="3201065849"/>
+        <p14:creationId xmlns:p14="http://schemas.microsoft.com/office/powerpoint/2010/main" val="1204145841"/>
       </p:ext>
     </p:extLst>
   </p:cSld>
@@ -10813,38 +10966,10 @@
       </p:grpSpPr>
       <p:sp>
         <p:nvSpPr>
-          <p:cNvPr id="2" name="標題 1">
-            <a:extLst>
-              <a:ext uri="{FF2B5EF4-FFF2-40B4-BE49-F238E27FC236}">
-                <a16:creationId xmlns:a16="http://schemas.microsoft.com/office/drawing/2014/main" id="{27A3B284-1CEC-47E9-98B8-BA58ABCB5210}"/>
-              </a:ext>
-            </a:extLst>
-          </p:cNvPr>
-          <p:cNvSpPr>
-            <a:spLocks noGrp="1"/>
-          </p:cNvSpPr>
-          <p:nvPr>
-            <p:ph type="title"/>
-          </p:nvPr>
-        </p:nvSpPr>
-        <p:spPr/>
-        <p:txBody>
-          <a:bodyPr/>
-          <a:lstStyle/>
-          <a:p>
-            <a:r>
-              <a:rPr b="1"/>
-              <a:t>CSI</a:t>
-            </a:r>
-          </a:p>
-        </p:txBody>
-      </p:sp>
-      <p:sp>
-        <p:nvSpPr>
-          <p:cNvPr id="4" name="投影片編號版面配置區 3">
-            <a:extLst>
-              <a:ext uri="{FF2B5EF4-FFF2-40B4-BE49-F238E27FC236}">
-                <a16:creationId xmlns:a16="http://schemas.microsoft.com/office/drawing/2014/main" id="{C2FCD405-600C-462A-BF29-DAFF79456778}"/>
+          <p:cNvPr id="2" name="?蔣?楊???ａ?蝵桀? 1">
+            <a:extLst>
+              <a:ext uri="{FF2B5EF4-FFF2-40B4-BE49-F238E27FC236}">
+                <a16:creationId xmlns:a16="http://schemas.microsoft.com/office/drawing/2014/main" id="{7C687AF8-AF63-1728-2C7B-76B8DC1837DE}"/>
               </a:ext>
             </a:extLst>
           </p:cNvPr>
@@ -10863,7 +10988,7 @@
             <a:pPr>
               <a:buNone/>
             </a:pPr>
-            <a:fld id="{DB7BEEEC-A170-5376-2B6E-CB54687B0CB1}" type="slidenum">
+            <a:fld id="{388657AE-30A1-5A7A-6A7F-315D84436430}" type="slidenum">
               <a:rPr sz="1400">
                 <a:latin typeface="Times New Roman"/>
                 <a:ea typeface="Times New Roman"/>
@@ -10879,10 +11004,123 @@
           </a:p>
         </p:txBody>
       </p:sp>
+      <p:sp>
+        <p:nvSpPr>
+          <p:cNvPr id="3" name="?批捆??蔭? 2">
+            <a:extLst>
+              <a:ext uri="{FF2B5EF4-FFF2-40B4-BE49-F238E27FC236}">
+                <a16:creationId xmlns:a16="http://schemas.microsoft.com/office/drawing/2014/main" id="{EFDF35B5-B6BD-325F-B271-EE42028230F3}"/>
+              </a:ext>
+            </a:extLst>
+          </p:cNvPr>
+          <p:cNvSpPr>
+            <a:spLocks noGrp="1"/>
+          </p:cNvSpPr>
+          <p:nvPr>
+            <p:ph idx="1"/>
+          </p:nvPr>
+        </p:nvSpPr>
+        <p:spPr/>
+        <p:txBody>
+          <a:bodyPr/>
+          <a:lstStyle/>
+          <a:p>
+            <a:r>
+              <a:rPr dirty="0">
+                <a:solidFill>
+                  <a:schemeClr val="bg1">
+                    <a:lumMod val="50000"/>
+                  </a:schemeClr>
+                </a:solidFill>
+              </a:rPr>
+              <a:t>Introduction</a:t>
+            </a:r>
+          </a:p>
+          <a:p>
+            <a:r>
+              <a:rPr dirty="0"/>
+              <a:t>Background</a:t>
+            </a:r>
+          </a:p>
+          <a:p>
+            <a:r>
+              <a:rPr dirty="0" err="1">
+                <a:solidFill>
+                  <a:schemeClr val="bg1">
+                    <a:lumMod val="50000"/>
+                  </a:schemeClr>
+                </a:solidFill>
+              </a:rPr>
+              <a:t>AoA</a:t>
+            </a:r>
+            <a:r>
+              <a:rPr dirty="0">
+                <a:solidFill>
+                  <a:schemeClr val="bg1">
+                    <a:lumMod val="50000"/>
+                  </a:schemeClr>
+                </a:solidFill>
+              </a:rPr>
+              <a:t>-Assisted Risk Score and RTS Threshold Adaptation</a:t>
+            </a:r>
+          </a:p>
+          <a:p>
+            <a:r>
+              <a:rPr dirty="0">
+                <a:solidFill>
+                  <a:schemeClr val="bg1">
+                    <a:lumMod val="50000"/>
+                  </a:schemeClr>
+                </a:solidFill>
+              </a:rPr>
+              <a:t>Evaluation</a:t>
+            </a:r>
+          </a:p>
+          <a:p>
+            <a:r>
+              <a:rPr dirty="0">
+                <a:solidFill>
+                  <a:schemeClr val="bg1">
+                    <a:lumMod val="50000"/>
+                  </a:schemeClr>
+                </a:solidFill>
+              </a:rPr>
+              <a:t>Conclusion</a:t>
+            </a:r>
+          </a:p>
+        </p:txBody>
+      </p:sp>
+      <p:sp>
+        <p:nvSpPr>
+          <p:cNvPr id="4" name="璅? 3">
+            <a:extLst>
+              <a:ext uri="{FF2B5EF4-FFF2-40B4-BE49-F238E27FC236}">
+                <a16:creationId xmlns:a16="http://schemas.microsoft.com/office/drawing/2014/main" id="{363B54DA-5A57-63A3-3957-4A5B100F1AAB}"/>
+              </a:ext>
+            </a:extLst>
+          </p:cNvPr>
+          <p:cNvSpPr>
+            <a:spLocks noGrp="1"/>
+          </p:cNvSpPr>
+          <p:nvPr>
+            <p:ph type="title"/>
+          </p:nvPr>
+        </p:nvSpPr>
+        <p:spPr/>
+        <p:txBody>
+          <a:bodyPr/>
+          <a:lstStyle/>
+          <a:p>
+            <a:r>
+              <a:t>Outline</a:t>
+            </a:r>
+          </a:p>
+        </p:txBody>
+      </p:sp>
     </p:spTree>
     <p:extLst>
       <p:ext uri="{BB962C8B-B14F-4D97-AF65-F5344CB8AC3E}">
-        <p14:creationId xmlns:p14="http://schemas.microsoft.com/office/powerpoint/2010/main" val="3663342643"/>
+        <p14:creationId xmlns:p14="http://schemas.microsoft.com/office/powerpoint/2010/main" val="3201065849"/>
       </p:ext>
     </p:extLst>
   </p:cSld>
@@ -10931,35 +11169,17 @@
           <a:lstStyle/>
           <a:p>
             <a:r>
+              <a:rPr lang="zh-TW" altLang="zh-TW" dirty="0"/>
+              <a:t>WiFi OFDM</a:t>
+            </a:r>
+            <a:r>
               <a:rPr lang="en-US" altLang="zh-TW" dirty="0"/>
-              <a:t>Spatial Spectrum Estimation</a:t>
-            </a:r>
-            <a:endParaRPr b="1" dirty="0"/>
-          </a:p>
-        </p:txBody>
-      </p:sp>
-      <p:sp>
-        <p:nvSpPr>
-          <p:cNvPr id="3" name="內容版面配置區 2">
-            <a:extLst>
-              <a:ext uri="{FF2B5EF4-FFF2-40B4-BE49-F238E27FC236}">
-                <a16:creationId xmlns:a16="http://schemas.microsoft.com/office/drawing/2014/main" id="{85EB7868-0B10-4ADE-BF08-3CE42A258785}"/>
-              </a:ext>
-            </a:extLst>
-          </p:cNvPr>
-          <p:cNvSpPr>
-            <a:spLocks noGrp="1"/>
-          </p:cNvSpPr>
-          <p:nvPr>
-            <p:ph idx="1"/>
-          </p:nvPr>
-        </p:nvSpPr>
-        <p:spPr/>
-        <p:txBody>
-          <a:bodyPr/>
-          <a:lstStyle/>
-          <a:p>
-            <a:endParaRPr dirty="0"/>
+              <a:t> </a:t>
+            </a:r>
+            <a:r>
+              <a:rPr b="1" dirty="0"/>
+              <a:t>CSI</a:t>
+            </a:r>
           </a:p>
         </p:txBody>
       </p:sp>
@@ -10987,7 +11207,7 @@
             <a:pPr>
               <a:buNone/>
             </a:pPr>
-            <a:fld id="{327921A4-25C4-3DB4-06B1-32693CEE2241}" type="slidenum">
+            <a:fld id="{DB7BEEEC-A170-5376-2B6E-CB54687B0CB1}" type="slidenum">
               <a:rPr sz="1400">
                 <a:latin typeface="Times New Roman"/>
                 <a:ea typeface="Times New Roman"/>
@@ -11003,10 +11223,151 @@
           </a:p>
         </p:txBody>
       </p:sp>
+      <p:sp>
+        <p:nvSpPr>
+          <p:cNvPr id="3" name="內容版面配置區 2">
+            <a:extLst>
+              <a:ext uri="{FF2B5EF4-FFF2-40B4-BE49-F238E27FC236}">
+                <a16:creationId xmlns:a16="http://schemas.microsoft.com/office/drawing/2014/main" id="{66361893-5D2A-0C1F-46D0-78D0A5600AB7}"/>
+              </a:ext>
+            </a:extLst>
+          </p:cNvPr>
+          <p:cNvSpPr>
+            <a:spLocks noGrp="1"/>
+          </p:cNvSpPr>
+          <p:nvPr>
+            <p:ph idx="1"/>
+          </p:nvPr>
+        </p:nvSpPr>
+        <p:spPr>
+          <a:xfrm>
+            <a:off x="640613" y="1073275"/>
+            <a:ext cx="10916870" cy="5413072"/>
+          </a:xfrm>
+        </p:spPr>
+        <p:txBody>
+          <a:bodyPr/>
+          <a:lstStyle/>
+          <a:p>
+            <a:r>
+              <a:rPr lang="zh-TW" altLang="zh-TW" b="1" dirty="0"/>
+              <a:t>CSI means Channel State Information</a:t>
+            </a:r>
+            <a:endParaRPr lang="en-US" altLang="zh-TW" b="1" dirty="0"/>
+          </a:p>
+          <a:p>
+            <a:r>
+              <a:rPr lang="zh-TW" altLang="zh-TW" dirty="0"/>
+              <a:t>It describes how a WiFi signal changes from transmitter to receiver</a:t>
+            </a:r>
+            <a:endParaRPr lang="en-US" altLang="zh-TW" dirty="0"/>
+          </a:p>
+          <a:p>
+            <a:r>
+              <a:rPr lang="zh-TW" altLang="zh-TW" dirty="0"/>
+              <a:t>CSI is not measured directly from random data.</a:t>
+            </a:r>
+          </a:p>
+          <a:p>
+            <a:r>
+              <a:rPr lang="zh-TW" altLang="zh-TW" dirty="0"/>
+              <a:t>The sender first sends a </a:t>
+            </a:r>
+            <a:r>
+              <a:rPr lang="zh-TW" altLang="zh-TW" b="1" dirty="0"/>
+              <a:t>known signal pattern</a:t>
+            </a:r>
+            <a:endParaRPr lang="en-US" altLang="zh-TW" b="1" dirty="0"/>
+          </a:p>
+          <a:p>
+            <a:r>
+              <a:rPr lang="en-US" altLang="zh-TW" dirty="0"/>
+              <a:t>Receiver </a:t>
+            </a:r>
+            <a:r>
+              <a:rPr lang="zh-TW" altLang="zh-TW" dirty="0"/>
+              <a:t>measure</a:t>
+            </a:r>
+            <a:r>
+              <a:rPr lang="en-US" altLang="zh-TW" dirty="0"/>
+              <a:t> CSI</a:t>
+            </a:r>
+            <a:r>
+              <a:rPr lang="zh-TW" altLang="zh-TW" dirty="0"/>
+              <a:t> on </a:t>
+            </a:r>
+            <a:r>
+              <a:rPr lang="en-US" altLang="zh-TW" dirty="0"/>
+              <a:t>each subcarrier and each transmit-receiver antenna pair</a:t>
+            </a:r>
+            <a:endParaRPr lang="zh-TW" altLang="zh-TW" dirty="0"/>
+          </a:p>
+          <a:p>
+            <a:r>
+              <a:rPr lang="zh-TW" altLang="zh-TW" dirty="0"/>
+              <a:t>Each CSI value is complex:</a:t>
+            </a:r>
+          </a:p>
+          <a:p>
+            <a:pPr lvl="1"/>
+            <a:r>
+              <a:rPr lang="zh-TW" altLang="zh-TW" b="1" dirty="0"/>
+              <a:t>Amplitude</a:t>
+            </a:r>
+            <a:r>
+              <a:rPr lang="zh-TW" altLang="zh-TW" dirty="0"/>
+              <a:t>:</a:t>
+            </a:r>
+            <a:endParaRPr lang="en-US" altLang="zh-TW" dirty="0"/>
+          </a:p>
+          <a:p>
+            <a:pPr lvl="2"/>
+            <a:r>
+              <a:rPr lang="zh-TW" altLang="zh-TW" dirty="0"/>
+              <a:t> how strong the signal is</a:t>
+            </a:r>
+            <a:endParaRPr lang="en-US" altLang="zh-TW" dirty="0"/>
+          </a:p>
+          <a:p>
+            <a:pPr lvl="2"/>
+            <a:r>
+              <a:rPr lang="zh-TW" altLang="zh-TW" dirty="0"/>
+              <a:t>A larger amplitude means the signal is stronger</a:t>
+            </a:r>
+          </a:p>
+          <a:p>
+            <a:pPr lvl="1"/>
+            <a:r>
+              <a:rPr lang="zh-TW" altLang="zh-TW" b="1" dirty="0"/>
+              <a:t>Phase</a:t>
+            </a:r>
+            <a:r>
+              <a:rPr lang="zh-TW" altLang="zh-TW" dirty="0"/>
+              <a:t>: </a:t>
+            </a:r>
+            <a:endParaRPr lang="en-US" altLang="zh-TW" dirty="0"/>
+          </a:p>
+          <a:p>
+            <a:pPr lvl="2"/>
+            <a:r>
+              <a:rPr lang="zh-TW" altLang="zh-TW" dirty="0"/>
+              <a:t>how much the signal is shifted</a:t>
+            </a:r>
+            <a:endParaRPr lang="en-US" altLang="zh-TW" dirty="0"/>
+          </a:p>
+          <a:p>
+            <a:pPr lvl="2"/>
+            <a:r>
+              <a:rPr lang="zh-TW" altLang="zh-TW" dirty="0"/>
+              <a:t>Different paths or arrival directions create different phase shifts</a:t>
+            </a:r>
+          </a:p>
+        </p:txBody>
+      </p:sp>
     </p:spTree>
     <p:extLst>
       <p:ext uri="{BB962C8B-B14F-4D97-AF65-F5344CB8AC3E}">
-        <p14:creationId xmlns:p14="http://schemas.microsoft.com/office/powerpoint/2010/main" val="3499234266"/>
+        <p14:creationId xmlns:p14="http://schemas.microsoft.com/office/powerpoint/2010/main" val="3663342643"/>
       </p:ext>
     </p:extLst>
   </p:cSld>

</xml_diff>

<commit_message>
add picture of steering vector
</commit_message>
<xml_diff>
--- a/thesis_filled.pptx
+++ b/thesis_filled.pptx
@@ -5,7 +5,7 @@
     <p:sldMasterId id="2147483648" r:id="rId1"/>
   </p:sldMasterIdLst>
   <p:notesMasterIdLst>
-    <p:notesMasterId r:id="rId22"/>
+    <p:notesMasterId r:id="rId24"/>
   </p:notesMasterIdLst>
   <p:sldIdLst>
     <p:sldId id="256" r:id="rId2"/>
@@ -19,15 +19,17 @@
     <p:sldId id="265" r:id="rId10"/>
     <p:sldId id="269" r:id="rId11"/>
     <p:sldId id="285" r:id="rId12"/>
-    <p:sldId id="266" r:id="rId13"/>
-    <p:sldId id="273" r:id="rId14"/>
-    <p:sldId id="274" r:id="rId15"/>
-    <p:sldId id="275" r:id="rId16"/>
-    <p:sldId id="277" r:id="rId17"/>
-    <p:sldId id="280" r:id="rId18"/>
-    <p:sldId id="281" r:id="rId19"/>
-    <p:sldId id="282" r:id="rId20"/>
-    <p:sldId id="283" r:id="rId21"/>
+    <p:sldId id="287" r:id="rId13"/>
+    <p:sldId id="288" r:id="rId14"/>
+    <p:sldId id="266" r:id="rId15"/>
+    <p:sldId id="273" r:id="rId16"/>
+    <p:sldId id="274" r:id="rId17"/>
+    <p:sldId id="275" r:id="rId18"/>
+    <p:sldId id="277" r:id="rId19"/>
+    <p:sldId id="280" r:id="rId20"/>
+    <p:sldId id="281" r:id="rId21"/>
+    <p:sldId id="282" r:id="rId22"/>
+    <p:sldId id="283" r:id="rId23"/>
   </p:sldIdLst>
   <p:sldSz cx="12192000" cy="6858000"/>
   <p:notesSz cx="6858000" cy="9144000"/>
@@ -8152,7 +8154,15 @@
           <a:p>
             <a:r>
               <a:rPr dirty="0"/>
-              <a:t>Motivate MUSIC for Wi-Fi APs because it can use existing multi-antenna CSI, provide higher angular resolution than simple beam scanning, and separate signal and noise subspaces without extra localization hardware.</a:t>
+              <a:t>Motivate MUSIC for Wi-Fi APs because it can use existing multi-antenna CSI, provide higher angular resolution than other </a:t>
+            </a:r>
+            <a:r>
+              <a:rPr lang="en-US" altLang="zh-TW" dirty="0"/>
+              <a:t>Spatial Spectrum Estimation algorithm </a:t>
+            </a:r>
+            <a:r>
+              <a:rPr dirty="0"/>
+              <a:t>without extra localization hardware</a:t>
             </a:r>
           </a:p>
         </p:txBody>
@@ -8232,7 +8242,7 @@
           <p:cNvPr id="2" name="標題 1">
             <a:extLst>
               <a:ext uri="{FF2B5EF4-FFF2-40B4-BE49-F238E27FC236}">
-                <a16:creationId xmlns:a16="http://schemas.microsoft.com/office/drawing/2014/main" id="{27A3B284-1CEC-47E9-98B8-BA58ABCB5210}"/>
+                <a16:creationId xmlns:a16="http://schemas.microsoft.com/office/drawing/2014/main" id="{155386B2-4D86-418A-841B-0E5321F04EE6}"/>
               </a:ext>
             </a:extLst>
           </p:cNvPr>
@@ -8249,9 +8259,10 @@
           <a:lstStyle/>
           <a:p>
             <a:r>
-              <a:rPr lang="en-US" dirty="0"/>
-              <a:t>LRG1 Ability  for RTS threshold control and metric collection</a:t>
-            </a:r>
+              <a:rPr lang="en-US" altLang="zh-TW" dirty="0"/>
+              <a:t>Steering Vector</a:t>
+            </a:r>
+            <a:endParaRPr lang="zh-TW" altLang="en-US" dirty="0"/>
           </a:p>
         </p:txBody>
       </p:sp>
@@ -8260,7 +8271,7 @@
           <p:cNvPr id="3" name="內容版面配置區 2">
             <a:extLst>
               <a:ext uri="{FF2B5EF4-FFF2-40B4-BE49-F238E27FC236}">
-                <a16:creationId xmlns:a16="http://schemas.microsoft.com/office/drawing/2014/main" id="{85EB7868-0B10-4ADE-BF08-3CE42A258785}"/>
+                <a16:creationId xmlns:a16="http://schemas.microsoft.com/office/drawing/2014/main" id="{D6A93578-5499-48CF-8E24-075DF5B181B9}"/>
               </a:ext>
             </a:extLst>
           </p:cNvPr>
@@ -8277,23 +8288,60 @@
           <a:lstStyle/>
           <a:p>
             <a:r>
-              <a:rPr dirty="0"/>
-              <a:t>Review the RTS threshold as the main AP-side control knob.</a:t>
-            </a:r>
-          </a:p>
-          <a:p>
-            <a:r>
-              <a:rPr dirty="0"/>
-              <a:t>Describe AP-side measurements, including retry statistics, RSSI, CSI, </a:t>
-            </a:r>
-            <a:r>
-              <a:rPr dirty="0" err="1"/>
-              <a:t>AoA</a:t>
-            </a:r>
-            <a:r>
-              <a:rPr dirty="0"/>
-              <a:t>, and MCS.</a:t>
-            </a:r>
+              <a:rPr lang="en-US" altLang="zh-TW" dirty="0"/>
+              <a:t>phase pattern across antenna array</a:t>
+            </a:r>
+            <a:r>
+              <a:rPr lang="zh-TW" altLang="en-US" dirty="0"/>
+              <a:t> </a:t>
+            </a:r>
+            <a:r>
+              <a:rPr lang="en-US" altLang="zh-TW" dirty="0"/>
+              <a:t>when signal arrives from</a:t>
+            </a:r>
+            <a:r>
+              <a:rPr lang="zh-TW" altLang="en-US" dirty="0"/>
+              <a:t> </a:t>
+            </a:r>
+            <a:r>
+              <a:rPr lang="en-US" altLang="zh-TW" dirty="0"/>
+              <a:t>specific angle</a:t>
+            </a:r>
+            <a:r>
+              <a:rPr lang="zh-TW" altLang="en-US" dirty="0"/>
+              <a:t> </a:t>
+            </a:r>
+            <a:r>
+              <a:rPr lang="el-GR" altLang="zh-TW" dirty="0"/>
+              <a:t>θ</a:t>
+            </a:r>
+            <a:endParaRPr lang="zh-TW" altLang="en-US" sz="2400" dirty="0">
+              <a:latin typeface="Calibri" panose="020F0502020204030204" pitchFamily="34" charset="0"/>
+              <a:cs typeface="Calibri" panose="020F0502020204030204" pitchFamily="34" charset="0"/>
+            </a:endParaRPr>
+          </a:p>
+          <a:p>
+            <a:r>
+              <a:rPr lang="en-US" altLang="zh-TW" dirty="0"/>
+              <a:t>Physical origin</a:t>
+            </a:r>
+            <a:r>
+              <a:rPr lang="zh-TW" altLang="en-US" dirty="0"/>
+              <a:t> </a:t>
+            </a:r>
+            <a:r>
+              <a:rPr lang="en-US" altLang="zh-TW" dirty="0"/>
+              <a:t>from a plane wave reaches different antennas with different propagation distances </a:t>
+            </a:r>
+            <a:r>
+              <a:rPr lang="en-US" altLang="zh-TW" dirty="0" err="1"/>
+              <a:t>dsin</a:t>
+            </a:r>
+            <a:r>
+              <a:rPr lang="el-GR" altLang="zh-TW" dirty="0"/>
+              <a:t>θ</a:t>
+            </a:r>
+            <a:endParaRPr lang="zh-TW" altLang="en-US" dirty="0"/>
           </a:p>
         </p:txBody>
       </p:sp>
@@ -8302,7 +8350,7 @@
           <p:cNvPr id="4" name="投影片編號版面配置區 3">
             <a:extLst>
               <a:ext uri="{FF2B5EF4-FFF2-40B4-BE49-F238E27FC236}">
-                <a16:creationId xmlns:a16="http://schemas.microsoft.com/office/drawing/2014/main" id="{C2FCD405-600C-462A-BF29-DAFF79456778}"/>
+                <a16:creationId xmlns:a16="http://schemas.microsoft.com/office/drawing/2014/main" id="{C66C22A3-9C71-4255-9FC7-490F79952140}"/>
               </a:ext>
             </a:extLst>
           </p:cNvPr>
@@ -8321,15 +8369,15 @@
             <a:pPr>
               <a:buNone/>
             </a:pPr>
-            <a:fld id="{30394428-F1DC-E5F6-DB0C-7DE31F3D8A23}" type="slidenum">
-              <a:rPr sz="1400">
+            <a:fld id="{DBC8A1ED-4F98-4D8C-81F6-271243F7D6B0}" type="slidenum">
+              <a:rPr lang="en-US" altLang="zh-TW" sz="1400" smtClean="0">
                 <a:latin typeface="Times New Roman"/>
                 <a:ea typeface="Times New Roman"/>
                 <a:cs typeface="Times New Roman"/>
               </a:rPr>
               <a:t>12</a:t>
             </a:fld>
-            <a:endParaRPr sz="1400">
+            <a:endParaRPr lang="en-US" altLang="zh-TW" sz="1400">
               <a:latin typeface="Times New Roman"/>
               <a:ea typeface="Times New Roman"/>
               <a:cs typeface="Times New Roman"/>
@@ -8337,10 +8385,648 @@
           </a:p>
         </p:txBody>
       </p:sp>
+      <p:grpSp>
+        <p:nvGrpSpPr>
+          <p:cNvPr id="43" name="群組 42">
+            <a:extLst>
+              <a:ext uri="{FF2B5EF4-FFF2-40B4-BE49-F238E27FC236}">
+                <a16:creationId xmlns:a16="http://schemas.microsoft.com/office/drawing/2014/main" id="{3DAD3106-B511-445E-A7D5-CD1A30115821}"/>
+              </a:ext>
+            </a:extLst>
+          </p:cNvPr>
+          <p:cNvGrpSpPr/>
+          <p:nvPr/>
+        </p:nvGrpSpPr>
+        <p:grpSpPr>
+          <a:xfrm>
+            <a:off x="3546935" y="3137919"/>
+            <a:ext cx="4333010" cy="3197244"/>
+            <a:chOff x="2992580" y="1973964"/>
+            <a:chExt cx="4333010" cy="3197244"/>
+          </a:xfrm>
+        </p:grpSpPr>
+        <p:pic>
+          <p:nvPicPr>
+            <p:cNvPr id="6" name="圖片 5">
+              <a:extLst>
+                <a:ext uri="{FF2B5EF4-FFF2-40B4-BE49-F238E27FC236}">
+                  <a16:creationId xmlns:a16="http://schemas.microsoft.com/office/drawing/2014/main" id="{9280B86F-59F2-4358-BE59-D7B56947E447}"/>
+                </a:ext>
+              </a:extLst>
+            </p:cNvPr>
+            <p:cNvPicPr>
+              <a:picLocks noChangeAspect="1"/>
+            </p:cNvPicPr>
+            <p:nvPr/>
+          </p:nvPicPr>
+          <p:blipFill>
+            <a:blip r:embed="rId2"/>
+            <a:stretch>
+              <a:fillRect/>
+            </a:stretch>
+          </p:blipFill>
+          <p:spPr>
+            <a:xfrm>
+              <a:off x="3976254" y="4582391"/>
+              <a:ext cx="588817" cy="588817"/>
+            </a:xfrm>
+            <a:prstGeom prst="rect">
+              <a:avLst/>
+            </a:prstGeom>
+          </p:spPr>
+        </p:pic>
+        <p:pic>
+          <p:nvPicPr>
+            <p:cNvPr id="7" name="圖片 6">
+              <a:extLst>
+                <a:ext uri="{FF2B5EF4-FFF2-40B4-BE49-F238E27FC236}">
+                  <a16:creationId xmlns:a16="http://schemas.microsoft.com/office/drawing/2014/main" id="{7991B78D-C694-4413-8027-C7A8ABC61438}"/>
+                </a:ext>
+              </a:extLst>
+            </p:cNvPr>
+            <p:cNvPicPr>
+              <a:picLocks noChangeAspect="1"/>
+            </p:cNvPicPr>
+            <p:nvPr/>
+          </p:nvPicPr>
+          <p:blipFill>
+            <a:blip r:embed="rId2"/>
+            <a:stretch>
+              <a:fillRect/>
+            </a:stretch>
+          </p:blipFill>
+          <p:spPr>
+            <a:xfrm>
+              <a:off x="6736773" y="4582391"/>
+              <a:ext cx="588817" cy="588817"/>
+            </a:xfrm>
+            <a:prstGeom prst="rect">
+              <a:avLst/>
+            </a:prstGeom>
+          </p:spPr>
+        </p:pic>
+        <p:cxnSp>
+          <p:nvCxnSpPr>
+            <p:cNvPr id="9" name="直線單箭頭接點 8">
+              <a:extLst>
+                <a:ext uri="{FF2B5EF4-FFF2-40B4-BE49-F238E27FC236}">
+                  <a16:creationId xmlns:a16="http://schemas.microsoft.com/office/drawing/2014/main" id="{A347363D-0293-4A51-A44B-DF7BB910E65A}"/>
+                </a:ext>
+              </a:extLst>
+            </p:cNvPr>
+            <p:cNvCxnSpPr>
+              <a:cxnSpLocks/>
+              <a:endCxn id="7" idx="0"/>
+            </p:cNvCxnSpPr>
+            <p:nvPr/>
+          </p:nvCxnSpPr>
+          <p:spPr>
+            <a:xfrm>
+              <a:off x="4270662" y="4559531"/>
+              <a:ext cx="2760520" cy="22860"/>
+            </a:xfrm>
+            <a:prstGeom prst="straightConnector1">
+              <a:avLst/>
+            </a:prstGeom>
+            <a:ln w="12700">
+              <a:solidFill>
+                <a:schemeClr val="tx1"/>
+              </a:solidFill>
+              <a:headEnd type="none" w="med" len="med"/>
+              <a:tailEnd type="none" w="med" len="med"/>
+            </a:ln>
+          </p:spPr>
+          <p:style>
+            <a:lnRef idx="1">
+              <a:schemeClr val="accent1"/>
+            </a:lnRef>
+            <a:fillRef idx="0">
+              <a:schemeClr val="accent1"/>
+            </a:fillRef>
+            <a:effectRef idx="0">
+              <a:schemeClr val="accent1"/>
+            </a:effectRef>
+            <a:fontRef idx="minor">
+              <a:schemeClr val="tx1"/>
+            </a:fontRef>
+          </p:style>
+        </p:cxnSp>
+        <p:sp>
+          <p:nvSpPr>
+            <p:cNvPr id="11" name="文字方塊 10">
+              <a:extLst>
+                <a:ext uri="{FF2B5EF4-FFF2-40B4-BE49-F238E27FC236}">
+                  <a16:creationId xmlns:a16="http://schemas.microsoft.com/office/drawing/2014/main" id="{D9EB25E0-9122-4661-95C0-82F190E87EE9}"/>
+                </a:ext>
+              </a:extLst>
+            </p:cNvPr>
+            <p:cNvSpPr txBox="1"/>
+            <p:nvPr/>
+          </p:nvSpPr>
+          <p:spPr>
+            <a:xfrm>
+              <a:off x="5516684" y="4514461"/>
+              <a:ext cx="348096" cy="461665"/>
+            </a:xfrm>
+            <a:prstGeom prst="rect">
+              <a:avLst/>
+            </a:prstGeom>
+            <a:noFill/>
+          </p:spPr>
+          <p:txBody>
+            <a:bodyPr wrap="square" rtlCol="0">
+              <a:spAutoFit/>
+            </a:bodyPr>
+            <a:lstStyle/>
+            <a:p>
+              <a:r>
+                <a:rPr lang="en-US" altLang="zh-TW" sz="2400" dirty="0">
+                  <a:latin typeface="Calibri" panose="020F0502020204030204" pitchFamily="34" charset="0"/>
+                  <a:ea typeface="Calibri" panose="020F0502020204030204" pitchFamily="34" charset="0"/>
+                  <a:cs typeface="Calibri" panose="020F0502020204030204" pitchFamily="34" charset="0"/>
+                </a:rPr>
+                <a:t>d</a:t>
+              </a:r>
+              <a:endParaRPr lang="zh-TW" altLang="en-US" sz="2400" dirty="0">
+                <a:latin typeface="Calibri" panose="020F0502020204030204" pitchFamily="34" charset="0"/>
+                <a:cs typeface="Calibri" panose="020F0502020204030204" pitchFamily="34" charset="0"/>
+              </a:endParaRPr>
+            </a:p>
+          </p:txBody>
+        </p:sp>
+        <p:cxnSp>
+          <p:nvCxnSpPr>
+            <p:cNvPr id="13" name="直線單箭頭接點 12">
+              <a:extLst>
+                <a:ext uri="{FF2B5EF4-FFF2-40B4-BE49-F238E27FC236}">
+                  <a16:creationId xmlns:a16="http://schemas.microsoft.com/office/drawing/2014/main" id="{6DD2B31A-D3FE-476F-95EC-AF9E5AC58250}"/>
+                </a:ext>
+              </a:extLst>
+            </p:cNvPr>
+            <p:cNvCxnSpPr>
+              <a:cxnSpLocks/>
+            </p:cNvCxnSpPr>
+            <p:nvPr/>
+          </p:nvCxnSpPr>
+          <p:spPr>
+            <a:xfrm>
+              <a:off x="2992580" y="3138055"/>
+              <a:ext cx="1278082" cy="1444336"/>
+            </a:xfrm>
+            <a:prstGeom prst="straightConnector1">
+              <a:avLst/>
+            </a:prstGeom>
+            <a:ln w="19050">
+              <a:tailEnd type="triangle"/>
+            </a:ln>
+          </p:spPr>
+          <p:style>
+            <a:lnRef idx="1">
+              <a:schemeClr val="accent1"/>
+            </a:lnRef>
+            <a:fillRef idx="0">
+              <a:schemeClr val="accent1"/>
+            </a:fillRef>
+            <a:effectRef idx="0">
+              <a:schemeClr val="accent1"/>
+            </a:effectRef>
+            <a:fontRef idx="minor">
+              <a:schemeClr val="tx1"/>
+            </a:fontRef>
+          </p:style>
+        </p:cxnSp>
+        <p:cxnSp>
+          <p:nvCxnSpPr>
+            <p:cNvPr id="15" name="直線接點 14">
+              <a:extLst>
+                <a:ext uri="{FF2B5EF4-FFF2-40B4-BE49-F238E27FC236}">
+                  <a16:creationId xmlns:a16="http://schemas.microsoft.com/office/drawing/2014/main" id="{59904E5F-5D86-40CC-B5E8-5BA0EB02523D}"/>
+                </a:ext>
+              </a:extLst>
+            </p:cNvPr>
+            <p:cNvCxnSpPr>
+              <a:cxnSpLocks/>
+              <a:stCxn id="6" idx="0"/>
+            </p:cNvCxnSpPr>
+            <p:nvPr/>
+          </p:nvCxnSpPr>
+          <p:spPr>
+            <a:xfrm flipV="1">
+              <a:off x="4270663" y="3138055"/>
+              <a:ext cx="0" cy="1444336"/>
+            </a:xfrm>
+            <a:prstGeom prst="line">
+              <a:avLst/>
+            </a:prstGeom>
+            <a:ln w="12700">
+              <a:solidFill>
+                <a:schemeClr val="tx1"/>
+              </a:solidFill>
+            </a:ln>
+          </p:spPr>
+          <p:style>
+            <a:lnRef idx="1">
+              <a:schemeClr val="accent1"/>
+            </a:lnRef>
+            <a:fillRef idx="0">
+              <a:schemeClr val="accent1"/>
+            </a:fillRef>
+            <a:effectRef idx="0">
+              <a:schemeClr val="accent1"/>
+            </a:effectRef>
+            <a:fontRef idx="minor">
+              <a:schemeClr val="tx1"/>
+            </a:fontRef>
+          </p:style>
+        </p:cxnSp>
+        <p:cxnSp>
+          <p:nvCxnSpPr>
+            <p:cNvPr id="18" name="直線接點 17">
+              <a:extLst>
+                <a:ext uri="{FF2B5EF4-FFF2-40B4-BE49-F238E27FC236}">
+                  <a16:creationId xmlns:a16="http://schemas.microsoft.com/office/drawing/2014/main" id="{3E5496BA-FF98-415A-A9C7-8B7535B7A85A}"/>
+                </a:ext>
+              </a:extLst>
+            </p:cNvPr>
+            <p:cNvCxnSpPr>
+              <a:cxnSpLocks/>
+              <a:stCxn id="7" idx="0"/>
+            </p:cNvCxnSpPr>
+            <p:nvPr/>
+          </p:nvCxnSpPr>
+          <p:spPr>
+            <a:xfrm flipV="1">
+              <a:off x="7031182" y="3138055"/>
+              <a:ext cx="0" cy="1444336"/>
+            </a:xfrm>
+            <a:prstGeom prst="line">
+              <a:avLst/>
+            </a:prstGeom>
+            <a:ln w="12700">
+              <a:solidFill>
+                <a:schemeClr val="tx1"/>
+              </a:solidFill>
+            </a:ln>
+          </p:spPr>
+          <p:style>
+            <a:lnRef idx="1">
+              <a:schemeClr val="accent1"/>
+            </a:lnRef>
+            <a:fillRef idx="0">
+              <a:schemeClr val="accent1"/>
+            </a:fillRef>
+            <a:effectRef idx="0">
+              <a:schemeClr val="accent1"/>
+            </a:effectRef>
+            <a:fontRef idx="minor">
+              <a:schemeClr val="tx1"/>
+            </a:fontRef>
+          </p:style>
+        </p:cxnSp>
+        <p:cxnSp>
+          <p:nvCxnSpPr>
+            <p:cNvPr id="20" name="直線單箭頭接點 19">
+              <a:extLst>
+                <a:ext uri="{FF2B5EF4-FFF2-40B4-BE49-F238E27FC236}">
+                  <a16:creationId xmlns:a16="http://schemas.microsoft.com/office/drawing/2014/main" id="{4074F5E6-307D-4F7A-8D8E-F32546B814E2}"/>
+                </a:ext>
+              </a:extLst>
+            </p:cNvPr>
+            <p:cNvCxnSpPr>
+              <a:cxnSpLocks/>
+            </p:cNvCxnSpPr>
+            <p:nvPr/>
+          </p:nvCxnSpPr>
+          <p:spPr>
+            <a:xfrm>
+              <a:off x="4717472" y="1973964"/>
+              <a:ext cx="2308177" cy="2608427"/>
+            </a:xfrm>
+            <a:prstGeom prst="straightConnector1">
+              <a:avLst/>
+            </a:prstGeom>
+            <a:ln w="19050">
+              <a:tailEnd type="triangle"/>
+            </a:ln>
+          </p:spPr>
+          <p:style>
+            <a:lnRef idx="1">
+              <a:schemeClr val="accent1"/>
+            </a:lnRef>
+            <a:fillRef idx="0">
+              <a:schemeClr val="accent1"/>
+            </a:fillRef>
+            <a:effectRef idx="0">
+              <a:schemeClr val="accent1"/>
+            </a:effectRef>
+            <a:fontRef idx="minor">
+              <a:schemeClr val="tx1"/>
+            </a:fontRef>
+          </p:style>
+        </p:cxnSp>
+        <p:cxnSp>
+          <p:nvCxnSpPr>
+            <p:cNvPr id="24" name="直線接點 23">
+              <a:extLst>
+                <a:ext uri="{FF2B5EF4-FFF2-40B4-BE49-F238E27FC236}">
+                  <a16:creationId xmlns:a16="http://schemas.microsoft.com/office/drawing/2014/main" id="{0ABF4525-4FF2-4A36-A0E0-C13AEC2A111F}"/>
+                </a:ext>
+              </a:extLst>
+            </p:cNvPr>
+            <p:cNvCxnSpPr>
+              <a:stCxn id="6" idx="0"/>
+            </p:cNvCxnSpPr>
+            <p:nvPr/>
+          </p:nvCxnSpPr>
+          <p:spPr>
+            <a:xfrm flipV="1">
+              <a:off x="4270663" y="3278177"/>
+              <a:ext cx="1600897" cy="1304214"/>
+            </a:xfrm>
+            <a:prstGeom prst="line">
+              <a:avLst/>
+            </a:prstGeom>
+            <a:ln w="12700">
+              <a:solidFill>
+                <a:schemeClr val="tx1"/>
+              </a:solidFill>
+            </a:ln>
+          </p:spPr>
+          <p:style>
+            <a:lnRef idx="1">
+              <a:schemeClr val="accent1"/>
+            </a:lnRef>
+            <a:fillRef idx="0">
+              <a:schemeClr val="accent1"/>
+            </a:fillRef>
+            <a:effectRef idx="0">
+              <a:schemeClr val="accent1"/>
+            </a:effectRef>
+            <a:fontRef idx="minor">
+              <a:schemeClr val="tx1"/>
+            </a:fontRef>
+          </p:style>
+        </p:cxnSp>
+        <p:sp>
+          <p:nvSpPr>
+            <p:cNvPr id="36" name="L 圖案 35">
+              <a:extLst>
+                <a:ext uri="{FF2B5EF4-FFF2-40B4-BE49-F238E27FC236}">
+                  <a16:creationId xmlns:a16="http://schemas.microsoft.com/office/drawing/2014/main" id="{8AE751F1-DA3A-421B-B199-44EF09DCC82A}"/>
+                </a:ext>
+              </a:extLst>
+            </p:cNvPr>
+            <p:cNvSpPr/>
+            <p:nvPr/>
+          </p:nvSpPr>
+          <p:spPr>
+            <a:xfrm rot="19381622">
+              <a:off x="5773722" y="3317462"/>
+              <a:ext cx="182117" cy="184893"/>
+            </a:xfrm>
+            <a:prstGeom prst="corner">
+              <a:avLst>
+                <a:gd name="adj1" fmla="val 0"/>
+                <a:gd name="adj2" fmla="val 0"/>
+              </a:avLst>
+            </a:prstGeom>
+            <a:solidFill>
+              <a:srgbClr val="FF0000"/>
+            </a:solidFill>
+            <a:ln w="3175">
+              <a:solidFill>
+                <a:schemeClr val="tx1"/>
+              </a:solidFill>
+            </a:ln>
+          </p:spPr>
+          <p:style>
+            <a:lnRef idx="2">
+              <a:schemeClr val="accent1">
+                <a:shade val="50000"/>
+              </a:schemeClr>
+            </a:lnRef>
+            <a:fillRef idx="1">
+              <a:schemeClr val="accent1"/>
+            </a:fillRef>
+            <a:effectRef idx="0">
+              <a:schemeClr val="accent1"/>
+            </a:effectRef>
+            <a:fontRef idx="minor">
+              <a:schemeClr val="lt1"/>
+            </a:fontRef>
+          </p:style>
+          <p:txBody>
+            <a:bodyPr rtlCol="0" anchor="ctr"/>
+            <a:lstStyle/>
+            <a:p>
+              <a:pPr algn="ctr"/>
+              <a:endParaRPr lang="zh-TW" altLang="en-US"/>
+            </a:p>
+          </p:txBody>
+        </p:sp>
+        <p:sp>
+          <p:nvSpPr>
+            <p:cNvPr id="38" name="文字方塊 37">
+              <a:extLst>
+                <a:ext uri="{FF2B5EF4-FFF2-40B4-BE49-F238E27FC236}">
+                  <a16:creationId xmlns:a16="http://schemas.microsoft.com/office/drawing/2014/main" id="{D4B25BA2-5813-4C8D-9D08-1BD12C7361A8}"/>
+                </a:ext>
+              </a:extLst>
+            </p:cNvPr>
+            <p:cNvSpPr txBox="1"/>
+            <p:nvPr/>
+          </p:nvSpPr>
+          <p:spPr>
+            <a:xfrm>
+              <a:off x="5638726" y="3752015"/>
+              <a:ext cx="870046" cy="461665"/>
+            </a:xfrm>
+            <a:prstGeom prst="rect">
+              <a:avLst/>
+            </a:prstGeom>
+            <a:noFill/>
+          </p:spPr>
+          <p:txBody>
+            <a:bodyPr wrap="square" rtlCol="0">
+              <a:spAutoFit/>
+            </a:bodyPr>
+            <a:lstStyle/>
+            <a:p>
+              <a:r>
+                <a:rPr lang="en-US" altLang="zh-TW" sz="2400" dirty="0" err="1">
+                  <a:solidFill>
+                    <a:srgbClr val="FF0000"/>
+                  </a:solidFill>
+                  <a:latin typeface="Calibri" panose="020F0502020204030204" pitchFamily="34" charset="0"/>
+                  <a:ea typeface="Calibri" panose="020F0502020204030204" pitchFamily="34" charset="0"/>
+                  <a:cs typeface="Calibri" panose="020F0502020204030204" pitchFamily="34" charset="0"/>
+                </a:rPr>
+                <a:t>dsin</a:t>
+              </a:r>
+              <a:r>
+                <a:rPr lang="el-GR" altLang="zh-TW" sz="2400" dirty="0">
+                  <a:solidFill>
+                    <a:srgbClr val="FF0000"/>
+                  </a:solidFill>
+                  <a:latin typeface="Calibri" panose="020F0502020204030204" pitchFamily="34" charset="0"/>
+                  <a:ea typeface="Calibri" panose="020F0502020204030204" pitchFamily="34" charset="0"/>
+                  <a:cs typeface="Calibri" panose="020F0502020204030204" pitchFamily="34" charset="0"/>
+                </a:rPr>
+                <a:t>θ</a:t>
+              </a:r>
+              <a:endParaRPr lang="zh-TW" altLang="en-US" sz="2400" dirty="0">
+                <a:solidFill>
+                  <a:srgbClr val="FF0000"/>
+                </a:solidFill>
+                <a:latin typeface="Calibri" panose="020F0502020204030204" pitchFamily="34" charset="0"/>
+                <a:cs typeface="Calibri" panose="020F0502020204030204" pitchFamily="34" charset="0"/>
+              </a:endParaRPr>
+            </a:p>
+          </p:txBody>
+        </p:sp>
+        <p:sp>
+          <p:nvSpPr>
+            <p:cNvPr id="39" name="文字方塊 38">
+              <a:extLst>
+                <a:ext uri="{FF2B5EF4-FFF2-40B4-BE49-F238E27FC236}">
+                  <a16:creationId xmlns:a16="http://schemas.microsoft.com/office/drawing/2014/main" id="{37FA17A4-A4B0-4E85-A16C-99439F452005}"/>
+                </a:ext>
+              </a:extLst>
+            </p:cNvPr>
+            <p:cNvSpPr txBox="1"/>
+            <p:nvPr/>
+          </p:nvSpPr>
+          <p:spPr>
+            <a:xfrm>
+              <a:off x="3649807" y="3273995"/>
+              <a:ext cx="348096" cy="461665"/>
+            </a:xfrm>
+            <a:prstGeom prst="rect">
+              <a:avLst/>
+            </a:prstGeom>
+            <a:noFill/>
+          </p:spPr>
+          <p:txBody>
+            <a:bodyPr wrap="square" rtlCol="0">
+              <a:spAutoFit/>
+            </a:bodyPr>
+            <a:lstStyle/>
+            <a:p>
+              <a:r>
+                <a:rPr lang="el-GR" altLang="zh-TW" sz="2400" dirty="0">
+                  <a:latin typeface="Calibri" panose="020F0502020204030204" pitchFamily="34" charset="0"/>
+                  <a:cs typeface="Calibri" panose="020F0502020204030204" pitchFamily="34" charset="0"/>
+                </a:rPr>
+                <a:t>θ</a:t>
+              </a:r>
+              <a:endParaRPr lang="zh-TW" altLang="en-US" sz="2400" dirty="0">
+                <a:latin typeface="Calibri" panose="020F0502020204030204" pitchFamily="34" charset="0"/>
+                <a:cs typeface="Calibri" panose="020F0502020204030204" pitchFamily="34" charset="0"/>
+              </a:endParaRPr>
+            </a:p>
+          </p:txBody>
+        </p:sp>
+        <p:cxnSp>
+          <p:nvCxnSpPr>
+            <p:cNvPr id="42" name="直線單箭頭接點 41">
+              <a:extLst>
+                <a:ext uri="{FF2B5EF4-FFF2-40B4-BE49-F238E27FC236}">
+                  <a16:creationId xmlns:a16="http://schemas.microsoft.com/office/drawing/2014/main" id="{0BF44F4A-6F25-415D-A27F-6F39896AB33A}"/>
+                </a:ext>
+              </a:extLst>
+            </p:cNvPr>
+            <p:cNvCxnSpPr>
+              <a:endCxn id="7" idx="0"/>
+            </p:cNvCxnSpPr>
+            <p:nvPr/>
+          </p:nvCxnSpPr>
+          <p:spPr>
+            <a:xfrm>
+              <a:off x="5864780" y="3278177"/>
+              <a:ext cx="1166402" cy="1304214"/>
+            </a:xfrm>
+            <a:prstGeom prst="straightConnector1">
+              <a:avLst/>
+            </a:prstGeom>
+            <a:ln w="38100">
+              <a:solidFill>
+                <a:srgbClr val="FF0000"/>
+              </a:solidFill>
+              <a:tailEnd type="triangle"/>
+            </a:ln>
+          </p:spPr>
+          <p:style>
+            <a:lnRef idx="1">
+              <a:schemeClr val="accent2"/>
+            </a:lnRef>
+            <a:fillRef idx="0">
+              <a:schemeClr val="accent2"/>
+            </a:fillRef>
+            <a:effectRef idx="0">
+              <a:schemeClr val="accent2"/>
+            </a:effectRef>
+            <a:fontRef idx="minor">
+              <a:schemeClr val="tx1"/>
+            </a:fontRef>
+          </p:style>
+        </p:cxnSp>
+      </p:grpSp>
+      <p:sp>
+        <p:nvSpPr>
+          <p:cNvPr id="44" name="弧形 43">
+            <a:extLst>
+              <a:ext uri="{FF2B5EF4-FFF2-40B4-BE49-F238E27FC236}">
+                <a16:creationId xmlns:a16="http://schemas.microsoft.com/office/drawing/2014/main" id="{2F604DA9-8BA2-4B31-BDB9-A9E821837C39}"/>
+              </a:ext>
+            </a:extLst>
+          </p:cNvPr>
+          <p:cNvSpPr/>
+          <p:nvPr/>
+        </p:nvSpPr>
+        <p:spPr>
+          <a:xfrm>
+            <a:off x="4218189" y="4881265"/>
+            <a:ext cx="624840" cy="381000"/>
+          </a:xfrm>
+          <a:prstGeom prst="arc">
+            <a:avLst>
+              <a:gd name="adj1" fmla="val 11099362"/>
+              <a:gd name="adj2" fmla="val 20898044"/>
+            </a:avLst>
+          </a:prstGeom>
+          <a:ln>
+            <a:solidFill>
+              <a:schemeClr val="tx1"/>
+            </a:solidFill>
+          </a:ln>
+        </p:spPr>
+        <p:style>
+          <a:lnRef idx="1">
+            <a:schemeClr val="accent1"/>
+          </a:lnRef>
+          <a:fillRef idx="0">
+            <a:schemeClr val="accent1"/>
+          </a:fillRef>
+          <a:effectRef idx="0">
+            <a:schemeClr val="accent1"/>
+          </a:effectRef>
+          <a:fontRef idx="minor">
+            <a:schemeClr val="tx1"/>
+          </a:fontRef>
+        </p:style>
+        <p:txBody>
+          <a:bodyPr rtlCol="0" anchor="ctr"/>
+          <a:lstStyle/>
+          <a:p>
+            <a:pPr algn="ctr"/>
+            <a:endParaRPr lang="zh-TW" altLang="en-US"/>
+          </a:p>
+        </p:txBody>
+      </p:sp>
     </p:spTree>
     <p:extLst>
       <p:ext uri="{BB962C8B-B14F-4D97-AF65-F5344CB8AC3E}">
-        <p14:creationId xmlns:p14="http://schemas.microsoft.com/office/powerpoint/2010/main" val="3499234266"/>
+        <p14:creationId xmlns:p14="http://schemas.microsoft.com/office/powerpoint/2010/main" val="2205973827"/>
       </p:ext>
     </p:extLst>
   </p:cSld>
@@ -8369,10 +9055,10 @@
       </p:grpSpPr>
       <p:sp>
         <p:nvSpPr>
-          <p:cNvPr id="2" name="?蔣?楊???ａ?蝵桀? 1">
+          <p:cNvPr id="2" name="標題 1">
             <a:extLst>
               <a:ext uri="{FF2B5EF4-FFF2-40B4-BE49-F238E27FC236}">
-                <a16:creationId xmlns:a16="http://schemas.microsoft.com/office/drawing/2014/main" id="{7C687AF8-AF63-1728-2C7B-76B8DC1837DE}"/>
+                <a16:creationId xmlns:a16="http://schemas.microsoft.com/office/drawing/2014/main" id="{155386B2-4D86-418A-841B-0E5321F04EE6}"/>
               </a:ext>
             </a:extLst>
           </p:cNvPr>
@@ -8380,6 +9066,96 @@
             <a:spLocks noGrp="1"/>
           </p:cNvSpPr>
           <p:nvPr>
+            <p:ph type="title"/>
+          </p:nvPr>
+        </p:nvSpPr>
+        <p:spPr/>
+        <p:txBody>
+          <a:bodyPr/>
+          <a:lstStyle/>
+          <a:p>
+            <a:r>
+              <a:rPr lang="en-US" altLang="zh-TW" dirty="0"/>
+              <a:t>Steer Vector Math Presentation  from antenna array</a:t>
+            </a:r>
+            <a:endParaRPr lang="zh-TW" altLang="en-US" dirty="0"/>
+          </a:p>
+        </p:txBody>
+      </p:sp>
+      <p:sp>
+        <p:nvSpPr>
+          <p:cNvPr id="3" name="內容版面配置區 2">
+            <a:extLst>
+              <a:ext uri="{FF2B5EF4-FFF2-40B4-BE49-F238E27FC236}">
+                <a16:creationId xmlns:a16="http://schemas.microsoft.com/office/drawing/2014/main" id="{D6A93578-5499-48CF-8E24-075DF5B181B9}"/>
+              </a:ext>
+            </a:extLst>
+          </p:cNvPr>
+          <p:cNvSpPr>
+            <a:spLocks noGrp="1"/>
+          </p:cNvSpPr>
+          <p:nvPr>
+            <p:ph idx="1"/>
+          </p:nvPr>
+        </p:nvSpPr>
+        <p:spPr/>
+        <p:txBody>
+          <a:bodyPr/>
+          <a:lstStyle/>
+          <a:p>
+            <a:r>
+              <a:rPr lang="en-US" altLang="zh-TW" dirty="0"/>
+              <a:t>a(</a:t>
+            </a:r>
+            <a:r>
+              <a:rPr lang="el-GR" altLang="zh-TW" dirty="0"/>
+              <a:t>θ)=[1,</a:t>
+            </a:r>
+            <a:r>
+              <a:rPr lang="en-US" altLang="zh-TW" dirty="0"/>
+              <a:t>e−j</a:t>
+            </a:r>
+            <a:r>
+              <a:rPr lang="el-GR" altLang="zh-TW" dirty="0"/>
+              <a:t>Δϕ,</a:t>
+            </a:r>
+            <a:r>
+              <a:rPr lang="en-US" altLang="zh-TW" dirty="0"/>
+              <a:t>e−j2</a:t>
+            </a:r>
+            <a:r>
+              <a:rPr lang="el-GR" altLang="zh-TW" dirty="0"/>
+              <a:t>Δϕ,...,</a:t>
+            </a:r>
+            <a:r>
+              <a:rPr lang="en-US" altLang="zh-TW" dirty="0"/>
+              <a:t>e−j(M−1)</a:t>
+            </a:r>
+            <a:r>
+              <a:rPr lang="el-GR" altLang="zh-TW" dirty="0"/>
+              <a:t>Δϕ]</a:t>
+            </a:r>
+            <a:r>
+              <a:rPr lang="en-US" altLang="zh-TW" dirty="0"/>
+              <a:t>T</a:t>
+            </a:r>
+            <a:endParaRPr lang="zh-TW" altLang="en-US" dirty="0"/>
+          </a:p>
+        </p:txBody>
+      </p:sp>
+      <p:sp>
+        <p:nvSpPr>
+          <p:cNvPr id="4" name="投影片編號版面配置區 3">
+            <a:extLst>
+              <a:ext uri="{FF2B5EF4-FFF2-40B4-BE49-F238E27FC236}">
+                <a16:creationId xmlns:a16="http://schemas.microsoft.com/office/drawing/2014/main" id="{C66C22A3-9C71-4255-9FC7-490F79952140}"/>
+              </a:ext>
+            </a:extLst>
+          </p:cNvPr>
+          <p:cNvSpPr>
+            <a:spLocks noGrp="1"/>
+          </p:cNvSpPr>
+          <p:nvPr>
             <p:ph type="sldNum" idx="10"/>
           </p:nvPr>
         </p:nvSpPr>
@@ -8391,15 +9167,15 @@
             <a:pPr>
               <a:buNone/>
             </a:pPr>
-            <a:fld id="{B1C6C81E-38B9-7560-621D-5A151A79DF9B}" type="slidenum">
-              <a:rPr sz="1400">
+            <a:fld id="{DBC8A1ED-4F98-4D8C-81F6-271243F7D6B0}" type="slidenum">
+              <a:rPr lang="en-US" altLang="zh-TW" sz="1400" smtClean="0">
                 <a:latin typeface="Times New Roman"/>
                 <a:ea typeface="Times New Roman"/>
                 <a:cs typeface="Times New Roman"/>
               </a:rPr>
               <a:t>13</a:t>
             </a:fld>
-            <a:endParaRPr sz="1400">
+            <a:endParaRPr lang="en-US" altLang="zh-TW" sz="1400">
               <a:latin typeface="Times New Roman"/>
               <a:ea typeface="Times New Roman"/>
               <a:cs typeface="Times New Roman"/>
@@ -8407,131 +9183,648 @@
           </a:p>
         </p:txBody>
       </p:sp>
-      <p:sp>
-        <p:nvSpPr>
-          <p:cNvPr id="3" name="?批捆??蔭? 2">
+      <p:grpSp>
+        <p:nvGrpSpPr>
+          <p:cNvPr id="43" name="群組 42">
             <a:extLst>
               <a:ext uri="{FF2B5EF4-FFF2-40B4-BE49-F238E27FC236}">
-                <a16:creationId xmlns:a16="http://schemas.microsoft.com/office/drawing/2014/main" id="{EFDF35B5-B6BD-325F-B271-EE42028230F3}"/>
+                <a16:creationId xmlns:a16="http://schemas.microsoft.com/office/drawing/2014/main" id="{3DAD3106-B511-445E-A7D5-CD1A30115821}"/>
               </a:ext>
             </a:extLst>
           </p:cNvPr>
-          <p:cNvSpPr>
-            <a:spLocks noGrp="1"/>
-          </p:cNvSpPr>
-          <p:nvPr>
-            <p:ph idx="1"/>
-          </p:nvPr>
-        </p:nvSpPr>
-        <p:spPr/>
-        <p:txBody>
-          <a:bodyPr/>
-          <a:lstStyle/>
-          <a:p>
-            <a:r>
-              <a:rPr dirty="0">
+          <p:cNvGrpSpPr/>
+          <p:nvPr/>
+        </p:nvGrpSpPr>
+        <p:grpSpPr>
+          <a:xfrm>
+            <a:off x="3546935" y="3137919"/>
+            <a:ext cx="4333010" cy="3197244"/>
+            <a:chOff x="2992580" y="1973964"/>
+            <a:chExt cx="4333010" cy="3197244"/>
+          </a:xfrm>
+        </p:grpSpPr>
+        <p:pic>
+          <p:nvPicPr>
+            <p:cNvPr id="6" name="圖片 5">
+              <a:extLst>
+                <a:ext uri="{FF2B5EF4-FFF2-40B4-BE49-F238E27FC236}">
+                  <a16:creationId xmlns:a16="http://schemas.microsoft.com/office/drawing/2014/main" id="{9280B86F-59F2-4358-BE59-D7B56947E447}"/>
+                </a:ext>
+              </a:extLst>
+            </p:cNvPr>
+            <p:cNvPicPr>
+              <a:picLocks noChangeAspect="1"/>
+            </p:cNvPicPr>
+            <p:nvPr/>
+          </p:nvPicPr>
+          <p:blipFill>
+            <a:blip r:embed="rId2"/>
+            <a:stretch>
+              <a:fillRect/>
+            </a:stretch>
+          </p:blipFill>
+          <p:spPr>
+            <a:xfrm>
+              <a:off x="3976254" y="4582391"/>
+              <a:ext cx="588817" cy="588817"/>
+            </a:xfrm>
+            <a:prstGeom prst="rect">
+              <a:avLst/>
+            </a:prstGeom>
+          </p:spPr>
+        </p:pic>
+        <p:pic>
+          <p:nvPicPr>
+            <p:cNvPr id="7" name="圖片 6">
+              <a:extLst>
+                <a:ext uri="{FF2B5EF4-FFF2-40B4-BE49-F238E27FC236}">
+                  <a16:creationId xmlns:a16="http://schemas.microsoft.com/office/drawing/2014/main" id="{7991B78D-C694-4413-8027-C7A8ABC61438}"/>
+                </a:ext>
+              </a:extLst>
+            </p:cNvPr>
+            <p:cNvPicPr>
+              <a:picLocks noChangeAspect="1"/>
+            </p:cNvPicPr>
+            <p:nvPr/>
+          </p:nvPicPr>
+          <p:blipFill>
+            <a:blip r:embed="rId2"/>
+            <a:stretch>
+              <a:fillRect/>
+            </a:stretch>
+          </p:blipFill>
+          <p:spPr>
+            <a:xfrm>
+              <a:off x="6736773" y="4582391"/>
+              <a:ext cx="588817" cy="588817"/>
+            </a:xfrm>
+            <a:prstGeom prst="rect">
+              <a:avLst/>
+            </a:prstGeom>
+          </p:spPr>
+        </p:pic>
+        <p:cxnSp>
+          <p:nvCxnSpPr>
+            <p:cNvPr id="9" name="直線單箭頭接點 8">
+              <a:extLst>
+                <a:ext uri="{FF2B5EF4-FFF2-40B4-BE49-F238E27FC236}">
+                  <a16:creationId xmlns:a16="http://schemas.microsoft.com/office/drawing/2014/main" id="{A347363D-0293-4A51-A44B-DF7BB910E65A}"/>
+                </a:ext>
+              </a:extLst>
+            </p:cNvPr>
+            <p:cNvCxnSpPr>
+              <a:cxnSpLocks/>
+              <a:endCxn id="7" idx="0"/>
+            </p:cNvCxnSpPr>
+            <p:nvPr/>
+          </p:nvCxnSpPr>
+          <p:spPr>
+            <a:xfrm>
+              <a:off x="4270662" y="4559531"/>
+              <a:ext cx="2760520" cy="22860"/>
+            </a:xfrm>
+            <a:prstGeom prst="straightConnector1">
+              <a:avLst/>
+            </a:prstGeom>
+            <a:ln w="12700">
+              <a:solidFill>
+                <a:schemeClr val="tx1"/>
+              </a:solidFill>
+              <a:headEnd type="none" w="med" len="med"/>
+              <a:tailEnd type="none" w="med" len="med"/>
+            </a:ln>
+          </p:spPr>
+          <p:style>
+            <a:lnRef idx="1">
+              <a:schemeClr val="accent1"/>
+            </a:lnRef>
+            <a:fillRef idx="0">
+              <a:schemeClr val="accent1"/>
+            </a:fillRef>
+            <a:effectRef idx="0">
+              <a:schemeClr val="accent1"/>
+            </a:effectRef>
+            <a:fontRef idx="minor">
+              <a:schemeClr val="tx1"/>
+            </a:fontRef>
+          </p:style>
+        </p:cxnSp>
+        <p:sp>
+          <p:nvSpPr>
+            <p:cNvPr id="11" name="文字方塊 10">
+              <a:extLst>
+                <a:ext uri="{FF2B5EF4-FFF2-40B4-BE49-F238E27FC236}">
+                  <a16:creationId xmlns:a16="http://schemas.microsoft.com/office/drawing/2014/main" id="{D9EB25E0-9122-4661-95C0-82F190E87EE9}"/>
+                </a:ext>
+              </a:extLst>
+            </p:cNvPr>
+            <p:cNvSpPr txBox="1"/>
+            <p:nvPr/>
+          </p:nvSpPr>
+          <p:spPr>
+            <a:xfrm>
+              <a:off x="5516684" y="4514461"/>
+              <a:ext cx="348096" cy="461665"/>
+            </a:xfrm>
+            <a:prstGeom prst="rect">
+              <a:avLst/>
+            </a:prstGeom>
+            <a:noFill/>
+          </p:spPr>
+          <p:txBody>
+            <a:bodyPr wrap="square" rtlCol="0">
+              <a:spAutoFit/>
+            </a:bodyPr>
+            <a:lstStyle/>
+            <a:p>
+              <a:r>
+                <a:rPr lang="en-US" altLang="zh-TW" sz="2400" dirty="0">
+                  <a:latin typeface="Calibri" panose="020F0502020204030204" pitchFamily="34" charset="0"/>
+                  <a:ea typeface="Calibri" panose="020F0502020204030204" pitchFamily="34" charset="0"/>
+                  <a:cs typeface="Calibri" panose="020F0502020204030204" pitchFamily="34" charset="0"/>
+                </a:rPr>
+                <a:t>d</a:t>
+              </a:r>
+              <a:endParaRPr lang="zh-TW" altLang="en-US" sz="2400" dirty="0">
+                <a:latin typeface="Calibri" panose="020F0502020204030204" pitchFamily="34" charset="0"/>
+                <a:cs typeface="Calibri" panose="020F0502020204030204" pitchFamily="34" charset="0"/>
+              </a:endParaRPr>
+            </a:p>
+          </p:txBody>
+        </p:sp>
+        <p:cxnSp>
+          <p:nvCxnSpPr>
+            <p:cNvPr id="13" name="直線單箭頭接點 12">
+              <a:extLst>
+                <a:ext uri="{FF2B5EF4-FFF2-40B4-BE49-F238E27FC236}">
+                  <a16:creationId xmlns:a16="http://schemas.microsoft.com/office/drawing/2014/main" id="{6DD2B31A-D3FE-476F-95EC-AF9E5AC58250}"/>
+                </a:ext>
+              </a:extLst>
+            </p:cNvPr>
+            <p:cNvCxnSpPr>
+              <a:cxnSpLocks/>
+            </p:cNvCxnSpPr>
+            <p:nvPr/>
+          </p:nvCxnSpPr>
+          <p:spPr>
+            <a:xfrm>
+              <a:off x="2992580" y="3138055"/>
+              <a:ext cx="1278082" cy="1444336"/>
+            </a:xfrm>
+            <a:prstGeom prst="straightConnector1">
+              <a:avLst/>
+            </a:prstGeom>
+            <a:ln w="19050">
+              <a:tailEnd type="triangle"/>
+            </a:ln>
+          </p:spPr>
+          <p:style>
+            <a:lnRef idx="1">
+              <a:schemeClr val="accent1"/>
+            </a:lnRef>
+            <a:fillRef idx="0">
+              <a:schemeClr val="accent1"/>
+            </a:fillRef>
+            <a:effectRef idx="0">
+              <a:schemeClr val="accent1"/>
+            </a:effectRef>
+            <a:fontRef idx="minor">
+              <a:schemeClr val="tx1"/>
+            </a:fontRef>
+          </p:style>
+        </p:cxnSp>
+        <p:cxnSp>
+          <p:nvCxnSpPr>
+            <p:cNvPr id="15" name="直線接點 14">
+              <a:extLst>
+                <a:ext uri="{FF2B5EF4-FFF2-40B4-BE49-F238E27FC236}">
+                  <a16:creationId xmlns:a16="http://schemas.microsoft.com/office/drawing/2014/main" id="{59904E5F-5D86-40CC-B5E8-5BA0EB02523D}"/>
+                </a:ext>
+              </a:extLst>
+            </p:cNvPr>
+            <p:cNvCxnSpPr>
+              <a:cxnSpLocks/>
+              <a:stCxn id="6" idx="0"/>
+            </p:cNvCxnSpPr>
+            <p:nvPr/>
+          </p:nvCxnSpPr>
+          <p:spPr>
+            <a:xfrm flipV="1">
+              <a:off x="4270663" y="3138055"/>
+              <a:ext cx="0" cy="1444336"/>
+            </a:xfrm>
+            <a:prstGeom prst="line">
+              <a:avLst/>
+            </a:prstGeom>
+            <a:ln w="12700">
+              <a:solidFill>
+                <a:schemeClr val="tx1"/>
+              </a:solidFill>
+            </a:ln>
+          </p:spPr>
+          <p:style>
+            <a:lnRef idx="1">
+              <a:schemeClr val="accent1"/>
+            </a:lnRef>
+            <a:fillRef idx="0">
+              <a:schemeClr val="accent1"/>
+            </a:fillRef>
+            <a:effectRef idx="0">
+              <a:schemeClr val="accent1"/>
+            </a:effectRef>
+            <a:fontRef idx="minor">
+              <a:schemeClr val="tx1"/>
+            </a:fontRef>
+          </p:style>
+        </p:cxnSp>
+        <p:cxnSp>
+          <p:nvCxnSpPr>
+            <p:cNvPr id="18" name="直線接點 17">
+              <a:extLst>
+                <a:ext uri="{FF2B5EF4-FFF2-40B4-BE49-F238E27FC236}">
+                  <a16:creationId xmlns:a16="http://schemas.microsoft.com/office/drawing/2014/main" id="{3E5496BA-FF98-415A-A9C7-8B7535B7A85A}"/>
+                </a:ext>
+              </a:extLst>
+            </p:cNvPr>
+            <p:cNvCxnSpPr>
+              <a:cxnSpLocks/>
+              <a:stCxn id="7" idx="0"/>
+            </p:cNvCxnSpPr>
+            <p:nvPr/>
+          </p:nvCxnSpPr>
+          <p:spPr>
+            <a:xfrm flipV="1">
+              <a:off x="7031182" y="3138055"/>
+              <a:ext cx="0" cy="1444336"/>
+            </a:xfrm>
+            <a:prstGeom prst="line">
+              <a:avLst/>
+            </a:prstGeom>
+            <a:ln w="12700">
+              <a:solidFill>
+                <a:schemeClr val="tx1"/>
+              </a:solidFill>
+            </a:ln>
+          </p:spPr>
+          <p:style>
+            <a:lnRef idx="1">
+              <a:schemeClr val="accent1"/>
+            </a:lnRef>
+            <a:fillRef idx="0">
+              <a:schemeClr val="accent1"/>
+            </a:fillRef>
+            <a:effectRef idx="0">
+              <a:schemeClr val="accent1"/>
+            </a:effectRef>
+            <a:fontRef idx="minor">
+              <a:schemeClr val="tx1"/>
+            </a:fontRef>
+          </p:style>
+        </p:cxnSp>
+        <p:cxnSp>
+          <p:nvCxnSpPr>
+            <p:cNvPr id="20" name="直線單箭頭接點 19">
+              <a:extLst>
+                <a:ext uri="{FF2B5EF4-FFF2-40B4-BE49-F238E27FC236}">
+                  <a16:creationId xmlns:a16="http://schemas.microsoft.com/office/drawing/2014/main" id="{4074F5E6-307D-4F7A-8D8E-F32546B814E2}"/>
+                </a:ext>
+              </a:extLst>
+            </p:cNvPr>
+            <p:cNvCxnSpPr>
+              <a:cxnSpLocks/>
+            </p:cNvCxnSpPr>
+            <p:nvPr/>
+          </p:nvCxnSpPr>
+          <p:spPr>
+            <a:xfrm>
+              <a:off x="4717472" y="1973964"/>
+              <a:ext cx="2308177" cy="2608427"/>
+            </a:xfrm>
+            <a:prstGeom prst="straightConnector1">
+              <a:avLst/>
+            </a:prstGeom>
+            <a:ln w="19050">
+              <a:tailEnd type="triangle"/>
+            </a:ln>
+          </p:spPr>
+          <p:style>
+            <a:lnRef idx="1">
+              <a:schemeClr val="accent1"/>
+            </a:lnRef>
+            <a:fillRef idx="0">
+              <a:schemeClr val="accent1"/>
+            </a:fillRef>
+            <a:effectRef idx="0">
+              <a:schemeClr val="accent1"/>
+            </a:effectRef>
+            <a:fontRef idx="minor">
+              <a:schemeClr val="tx1"/>
+            </a:fontRef>
+          </p:style>
+        </p:cxnSp>
+        <p:cxnSp>
+          <p:nvCxnSpPr>
+            <p:cNvPr id="24" name="直線接點 23">
+              <a:extLst>
+                <a:ext uri="{FF2B5EF4-FFF2-40B4-BE49-F238E27FC236}">
+                  <a16:creationId xmlns:a16="http://schemas.microsoft.com/office/drawing/2014/main" id="{0ABF4525-4FF2-4A36-A0E0-C13AEC2A111F}"/>
+                </a:ext>
+              </a:extLst>
+            </p:cNvPr>
+            <p:cNvCxnSpPr>
+              <a:stCxn id="6" idx="0"/>
+            </p:cNvCxnSpPr>
+            <p:nvPr/>
+          </p:nvCxnSpPr>
+          <p:spPr>
+            <a:xfrm flipV="1">
+              <a:off x="4270663" y="3278177"/>
+              <a:ext cx="1600897" cy="1304214"/>
+            </a:xfrm>
+            <a:prstGeom prst="line">
+              <a:avLst/>
+            </a:prstGeom>
+            <a:ln w="12700">
+              <a:solidFill>
+                <a:schemeClr val="tx1"/>
+              </a:solidFill>
+            </a:ln>
+          </p:spPr>
+          <p:style>
+            <a:lnRef idx="1">
+              <a:schemeClr val="accent1"/>
+            </a:lnRef>
+            <a:fillRef idx="0">
+              <a:schemeClr val="accent1"/>
+            </a:fillRef>
+            <a:effectRef idx="0">
+              <a:schemeClr val="accent1"/>
+            </a:effectRef>
+            <a:fontRef idx="minor">
+              <a:schemeClr val="tx1"/>
+            </a:fontRef>
+          </p:style>
+        </p:cxnSp>
+        <p:sp>
+          <p:nvSpPr>
+            <p:cNvPr id="36" name="L 圖案 35">
+              <a:extLst>
+                <a:ext uri="{FF2B5EF4-FFF2-40B4-BE49-F238E27FC236}">
+                  <a16:creationId xmlns:a16="http://schemas.microsoft.com/office/drawing/2014/main" id="{8AE751F1-DA3A-421B-B199-44EF09DCC82A}"/>
+                </a:ext>
+              </a:extLst>
+            </p:cNvPr>
+            <p:cNvSpPr/>
+            <p:nvPr/>
+          </p:nvSpPr>
+          <p:spPr>
+            <a:xfrm rot="19381622">
+              <a:off x="5773722" y="3317462"/>
+              <a:ext cx="182117" cy="184893"/>
+            </a:xfrm>
+            <a:prstGeom prst="corner">
+              <a:avLst>
+                <a:gd name="adj1" fmla="val 0"/>
+                <a:gd name="adj2" fmla="val 0"/>
+              </a:avLst>
+            </a:prstGeom>
+            <a:solidFill>
+              <a:srgbClr val="FF0000"/>
+            </a:solidFill>
+            <a:ln w="3175">
+              <a:solidFill>
+                <a:schemeClr val="tx1"/>
+              </a:solidFill>
+            </a:ln>
+          </p:spPr>
+          <p:style>
+            <a:lnRef idx="2">
+              <a:schemeClr val="accent1">
+                <a:shade val="50000"/>
+              </a:schemeClr>
+            </a:lnRef>
+            <a:fillRef idx="1">
+              <a:schemeClr val="accent1"/>
+            </a:fillRef>
+            <a:effectRef idx="0">
+              <a:schemeClr val="accent1"/>
+            </a:effectRef>
+            <a:fontRef idx="minor">
+              <a:schemeClr val="lt1"/>
+            </a:fontRef>
+          </p:style>
+          <p:txBody>
+            <a:bodyPr rtlCol="0" anchor="ctr"/>
+            <a:lstStyle/>
+            <a:p>
+              <a:pPr algn="ctr"/>
+              <a:endParaRPr lang="zh-TW" altLang="en-US"/>
+            </a:p>
+          </p:txBody>
+        </p:sp>
+        <p:sp>
+          <p:nvSpPr>
+            <p:cNvPr id="38" name="文字方塊 37">
+              <a:extLst>
+                <a:ext uri="{FF2B5EF4-FFF2-40B4-BE49-F238E27FC236}">
+                  <a16:creationId xmlns:a16="http://schemas.microsoft.com/office/drawing/2014/main" id="{D4B25BA2-5813-4C8D-9D08-1BD12C7361A8}"/>
+                </a:ext>
+              </a:extLst>
+            </p:cNvPr>
+            <p:cNvSpPr txBox="1"/>
+            <p:nvPr/>
+          </p:nvSpPr>
+          <p:spPr>
+            <a:xfrm>
+              <a:off x="5638726" y="3752015"/>
+              <a:ext cx="870046" cy="461665"/>
+            </a:xfrm>
+            <a:prstGeom prst="rect">
+              <a:avLst/>
+            </a:prstGeom>
+            <a:noFill/>
+          </p:spPr>
+          <p:txBody>
+            <a:bodyPr wrap="square" rtlCol="0">
+              <a:spAutoFit/>
+            </a:bodyPr>
+            <a:lstStyle/>
+            <a:p>
+              <a:r>
+                <a:rPr lang="en-US" altLang="zh-TW" sz="2400" dirty="0" err="1">
+                  <a:solidFill>
+                    <a:srgbClr val="FF0000"/>
+                  </a:solidFill>
+                  <a:latin typeface="Calibri" panose="020F0502020204030204" pitchFamily="34" charset="0"/>
+                  <a:ea typeface="Calibri" panose="020F0502020204030204" pitchFamily="34" charset="0"/>
+                  <a:cs typeface="Calibri" panose="020F0502020204030204" pitchFamily="34" charset="0"/>
+                </a:rPr>
+                <a:t>dsin</a:t>
+              </a:r>
+              <a:r>
+                <a:rPr lang="el-GR" altLang="zh-TW" sz="2400" dirty="0">
+                  <a:solidFill>
+                    <a:srgbClr val="FF0000"/>
+                  </a:solidFill>
+                  <a:latin typeface="Calibri" panose="020F0502020204030204" pitchFamily="34" charset="0"/>
+                  <a:ea typeface="Calibri" panose="020F0502020204030204" pitchFamily="34" charset="0"/>
+                  <a:cs typeface="Calibri" panose="020F0502020204030204" pitchFamily="34" charset="0"/>
+                </a:rPr>
+                <a:t>θ</a:t>
+              </a:r>
+              <a:endParaRPr lang="zh-TW" altLang="en-US" sz="2400" dirty="0">
                 <a:solidFill>
-                  <a:schemeClr val="bg1">
-                    <a:lumMod val="50000"/>
-                  </a:schemeClr>
+                  <a:srgbClr val="FF0000"/>
                 </a:solidFill>
-              </a:rPr>
-              <a:t>Introduction</a:t>
-            </a:r>
-          </a:p>
-          <a:p>
-            <a:r>
-              <a:rPr dirty="0">
-                <a:solidFill>
-                  <a:schemeClr val="bg1">
-                    <a:lumMod val="50000"/>
-                  </a:schemeClr>
-                </a:solidFill>
-              </a:rPr>
-              <a:t>Background</a:t>
-            </a:r>
-          </a:p>
-          <a:p>
-            <a:r>
-              <a:rPr dirty="0" err="1"/>
-              <a:t>AoA</a:t>
-            </a:r>
-            <a:r>
-              <a:rPr dirty="0"/>
-              <a:t>-Assisted Risk Score and RTS</a:t>
-            </a:r>
-            <a:r>
-              <a:rPr dirty="0">
-                <a:solidFill>
-                  <a:schemeClr val="bg1">
-                    <a:lumMod val="50000"/>
-                  </a:schemeClr>
-                </a:solidFill>
-              </a:rPr>
-              <a:t> </a:t>
-            </a:r>
-            <a:r>
-              <a:rPr dirty="0"/>
-              <a:t>Threshold Adaptation</a:t>
-            </a:r>
-          </a:p>
-          <a:p>
-            <a:r>
-              <a:rPr dirty="0">
-                <a:solidFill>
-                  <a:schemeClr val="bg1">
-                    <a:lumMod val="50000"/>
-                  </a:schemeClr>
-                </a:solidFill>
-              </a:rPr>
-              <a:t>Evaluation</a:t>
-            </a:r>
-          </a:p>
-          <a:p>
-            <a:r>
-              <a:rPr dirty="0">
-                <a:solidFill>
-                  <a:schemeClr val="bg1">
-                    <a:lumMod val="50000"/>
-                  </a:schemeClr>
-                </a:solidFill>
-              </a:rPr>
-              <a:t>Conclusion</a:t>
-            </a:r>
-          </a:p>
-        </p:txBody>
-      </p:sp>
-      <p:sp>
-        <p:nvSpPr>
-          <p:cNvPr id="4" name="璅? 3">
+                <a:latin typeface="Calibri" panose="020F0502020204030204" pitchFamily="34" charset="0"/>
+                <a:cs typeface="Calibri" panose="020F0502020204030204" pitchFamily="34" charset="0"/>
+              </a:endParaRPr>
+            </a:p>
+          </p:txBody>
+        </p:sp>
+        <p:sp>
+          <p:nvSpPr>
+            <p:cNvPr id="39" name="文字方塊 38">
+              <a:extLst>
+                <a:ext uri="{FF2B5EF4-FFF2-40B4-BE49-F238E27FC236}">
+                  <a16:creationId xmlns:a16="http://schemas.microsoft.com/office/drawing/2014/main" id="{37FA17A4-A4B0-4E85-A16C-99439F452005}"/>
+                </a:ext>
+              </a:extLst>
+            </p:cNvPr>
+            <p:cNvSpPr txBox="1"/>
+            <p:nvPr/>
+          </p:nvSpPr>
+          <p:spPr>
+            <a:xfrm>
+              <a:off x="3649807" y="3273995"/>
+              <a:ext cx="348096" cy="461665"/>
+            </a:xfrm>
+            <a:prstGeom prst="rect">
+              <a:avLst/>
+            </a:prstGeom>
+            <a:noFill/>
+          </p:spPr>
+          <p:txBody>
+            <a:bodyPr wrap="square" rtlCol="0">
+              <a:spAutoFit/>
+            </a:bodyPr>
+            <a:lstStyle/>
+            <a:p>
+              <a:r>
+                <a:rPr lang="el-GR" altLang="zh-TW" sz="2400" dirty="0">
+                  <a:latin typeface="Calibri" panose="020F0502020204030204" pitchFamily="34" charset="0"/>
+                  <a:cs typeface="Calibri" panose="020F0502020204030204" pitchFamily="34" charset="0"/>
+                </a:rPr>
+                <a:t>θ</a:t>
+              </a:r>
+              <a:endParaRPr lang="zh-TW" altLang="en-US" sz="2400" dirty="0">
+                <a:latin typeface="Calibri" panose="020F0502020204030204" pitchFamily="34" charset="0"/>
+                <a:cs typeface="Calibri" panose="020F0502020204030204" pitchFamily="34" charset="0"/>
+              </a:endParaRPr>
+            </a:p>
+          </p:txBody>
+        </p:sp>
+        <p:cxnSp>
+          <p:nvCxnSpPr>
+            <p:cNvPr id="42" name="直線單箭頭接點 41">
+              <a:extLst>
+                <a:ext uri="{FF2B5EF4-FFF2-40B4-BE49-F238E27FC236}">
+                  <a16:creationId xmlns:a16="http://schemas.microsoft.com/office/drawing/2014/main" id="{0BF44F4A-6F25-415D-A27F-6F39896AB33A}"/>
+                </a:ext>
+              </a:extLst>
+            </p:cNvPr>
+            <p:cNvCxnSpPr>
+              <a:endCxn id="7" idx="0"/>
+            </p:cNvCxnSpPr>
+            <p:nvPr/>
+          </p:nvCxnSpPr>
+          <p:spPr>
+            <a:xfrm>
+              <a:off x="5864780" y="3278177"/>
+              <a:ext cx="1166402" cy="1304214"/>
+            </a:xfrm>
+            <a:prstGeom prst="straightConnector1">
+              <a:avLst/>
+            </a:prstGeom>
+            <a:ln w="38100">
+              <a:solidFill>
+                <a:srgbClr val="FF0000"/>
+              </a:solidFill>
+              <a:tailEnd type="triangle"/>
+            </a:ln>
+          </p:spPr>
+          <p:style>
+            <a:lnRef idx="1">
+              <a:schemeClr val="accent2"/>
+            </a:lnRef>
+            <a:fillRef idx="0">
+              <a:schemeClr val="accent2"/>
+            </a:fillRef>
+            <a:effectRef idx="0">
+              <a:schemeClr val="accent2"/>
+            </a:effectRef>
+            <a:fontRef idx="minor">
+              <a:schemeClr val="tx1"/>
+            </a:fontRef>
+          </p:style>
+        </p:cxnSp>
+      </p:grpSp>
+      <p:sp>
+        <p:nvSpPr>
+          <p:cNvPr id="44" name="弧形 43">
             <a:extLst>
               <a:ext uri="{FF2B5EF4-FFF2-40B4-BE49-F238E27FC236}">
-                <a16:creationId xmlns:a16="http://schemas.microsoft.com/office/drawing/2014/main" id="{363B54DA-5A57-63A3-3957-4A5B100F1AAB}"/>
+                <a16:creationId xmlns:a16="http://schemas.microsoft.com/office/drawing/2014/main" id="{2F604DA9-8BA2-4B31-BDB9-A9E821837C39}"/>
               </a:ext>
             </a:extLst>
           </p:cNvPr>
-          <p:cNvSpPr>
-            <a:spLocks noGrp="1"/>
-          </p:cNvSpPr>
-          <p:nvPr>
-            <p:ph type="title"/>
-          </p:nvPr>
-        </p:nvSpPr>
-        <p:spPr/>
-        <p:txBody>
-          <a:bodyPr/>
-          <a:lstStyle/>
-          <a:p>
-            <a:r>
-              <a:t>Outline</a:t>
-            </a:r>
+          <p:cNvSpPr/>
+          <p:nvPr/>
+        </p:nvSpPr>
+        <p:spPr>
+          <a:xfrm>
+            <a:off x="4218189" y="4881265"/>
+            <a:ext cx="624840" cy="381000"/>
+          </a:xfrm>
+          <a:prstGeom prst="arc">
+            <a:avLst>
+              <a:gd name="adj1" fmla="val 11099362"/>
+              <a:gd name="adj2" fmla="val 20898044"/>
+            </a:avLst>
+          </a:prstGeom>
+          <a:ln>
+            <a:solidFill>
+              <a:schemeClr val="tx1"/>
+            </a:solidFill>
+          </a:ln>
+        </p:spPr>
+        <p:style>
+          <a:lnRef idx="1">
+            <a:schemeClr val="accent1"/>
+          </a:lnRef>
+          <a:fillRef idx="0">
+            <a:schemeClr val="accent1"/>
+          </a:fillRef>
+          <a:effectRef idx="0">
+            <a:schemeClr val="accent1"/>
+          </a:effectRef>
+          <a:fontRef idx="minor">
+            <a:schemeClr val="tx1"/>
+          </a:fontRef>
+        </p:style>
+        <p:txBody>
+          <a:bodyPr rtlCol="0" anchor="ctr"/>
+          <a:lstStyle/>
+          <a:p>
+            <a:pPr algn="ctr"/>
+            <a:endParaRPr lang="zh-TW" altLang="en-US"/>
           </a:p>
         </p:txBody>
       </p:sp>
     </p:spTree>
     <p:extLst>
       <p:ext uri="{BB962C8B-B14F-4D97-AF65-F5344CB8AC3E}">
-        <p14:creationId xmlns:p14="http://schemas.microsoft.com/office/powerpoint/2010/main" val="2663263701"/>
+        <p14:creationId xmlns:p14="http://schemas.microsoft.com/office/powerpoint/2010/main" val="1210139893"/>
       </p:ext>
     </p:extLst>
   </p:cSld>
@@ -8580,8 +9873,8 @@
           <a:lstStyle/>
           <a:p>
             <a:r>
-              <a:rPr b="1"/>
-              <a:t>Risk scoring design goal</a:t>
+              <a:rPr lang="en-US" dirty="0"/>
+              <a:t>LRG1 Ability  for RTS threshold control and metric collection</a:t>
             </a:r>
           </a:p>
         </p:txBody>
@@ -8608,12 +9901,22 @@
           <a:lstStyle/>
           <a:p>
             <a:r>
-              <a:t>Present the overall design goal: use AP-side AoA and link observations to decide when RTS/CTS overhead is worthwhile.</a:t>
-            </a:r>
-          </a:p>
-          <a:p>
-            <a:r>
-              <a:t>Define the hidden-node risk score as the core decision variable for RTS threshold control.</a:t>
+              <a:rPr dirty="0"/>
+              <a:t>Review the RTS threshold as the main AP-side control knob.</a:t>
+            </a:r>
+          </a:p>
+          <a:p>
+            <a:r>
+              <a:rPr dirty="0"/>
+              <a:t>Describe AP-side measurements, including retry statistics, RSSI, CSI, </a:t>
+            </a:r>
+            <a:r>
+              <a:rPr dirty="0" err="1"/>
+              <a:t>AoA</a:t>
+            </a:r>
+            <a:r>
+              <a:rPr dirty="0"/>
+              <a:t>, and MCS.</a:t>
             </a:r>
           </a:p>
         </p:txBody>
@@ -8642,7 +9945,7 @@
             <a:pPr>
               <a:buNone/>
             </a:pPr>
-            <a:fld id="{CCF91274-D221-1BB4-3BF9-836E3AD31EBE}" type="slidenum">
+            <a:fld id="{30394428-F1DC-E5F6-DB0C-7DE31F3D8A23}" type="slidenum">
               <a:rPr sz="1400">
                 <a:latin typeface="Times New Roman"/>
                 <a:ea typeface="Times New Roman"/>
@@ -8690,10 +9993,10 @@
       </p:grpSpPr>
       <p:sp>
         <p:nvSpPr>
-          <p:cNvPr id="2" name="標題 1">
+          <p:cNvPr id="2" name="?蔣?楊???ａ?蝵桀? 1">
             <a:extLst>
               <a:ext uri="{FF2B5EF4-FFF2-40B4-BE49-F238E27FC236}">
-                <a16:creationId xmlns:a16="http://schemas.microsoft.com/office/drawing/2014/main" id="{27A3B284-1CEC-47E9-98B8-BA58ABCB5210}"/>
+                <a16:creationId xmlns:a16="http://schemas.microsoft.com/office/drawing/2014/main" id="{7C687AF8-AF63-1728-2C7B-76B8DC1837DE}"/>
               </a:ext>
             </a:extLst>
           </p:cNvPr>
@@ -8701,66 +10004,6 @@
             <a:spLocks noGrp="1"/>
           </p:cNvSpPr>
           <p:nvPr>
-            <p:ph type="title"/>
-          </p:nvPr>
-        </p:nvSpPr>
-        <p:spPr/>
-        <p:txBody>
-          <a:bodyPr/>
-          <a:lstStyle/>
-          <a:p>
-            <a:r>
-              <a:rPr b="1"/>
-              <a:t>AoA and link features for hidden-node risk</a:t>
-            </a:r>
-          </a:p>
-        </p:txBody>
-      </p:sp>
-      <p:sp>
-        <p:nvSpPr>
-          <p:cNvPr id="3" name="內容版面配置區 2">
-            <a:extLst>
-              <a:ext uri="{FF2B5EF4-FFF2-40B4-BE49-F238E27FC236}">
-                <a16:creationId xmlns:a16="http://schemas.microsoft.com/office/drawing/2014/main" id="{85EB7868-0B10-4ADE-BF08-3CE42A258785}"/>
-              </a:ext>
-            </a:extLst>
-          </p:cNvPr>
-          <p:cNvSpPr>
-            <a:spLocks noGrp="1"/>
-          </p:cNvSpPr>
-          <p:nvPr>
-            <p:ph idx="1"/>
-          </p:nvPr>
-        </p:nvSpPr>
-        <p:spPr/>
-        <p:txBody>
-          <a:bodyPr/>
-          <a:lstStyle/>
-          <a:p>
-            <a:r>
-              <a:t>Use AoA estimates from AP-side multi-antenna CSI as the main spatial feature for judging whether two clients are likely to be hidden from each other.</a:t>
-            </a:r>
-          </a:p>
-          <a:p>
-            <a:r>
-              <a:t>Combine AoA-based spatial separation with retry behavior, RSSI, MCS, and traffic activity so the score reflects both geometry and observed collision symptoms.</a:t>
-            </a:r>
-          </a:p>
-        </p:txBody>
-      </p:sp>
-      <p:sp>
-        <p:nvSpPr>
-          <p:cNvPr id="4" name="投影片編號版面配置區 3">
-            <a:extLst>
-              <a:ext uri="{FF2B5EF4-FFF2-40B4-BE49-F238E27FC236}">
-                <a16:creationId xmlns:a16="http://schemas.microsoft.com/office/drawing/2014/main" id="{C2FCD405-600C-462A-BF29-DAFF79456778}"/>
-              </a:ext>
-            </a:extLst>
-          </p:cNvPr>
-          <p:cNvSpPr>
-            <a:spLocks noGrp="1"/>
-          </p:cNvSpPr>
-          <p:nvPr>
             <p:ph type="sldNum" idx="10"/>
           </p:nvPr>
         </p:nvSpPr>
@@ -8772,7 +10015,7 @@
             <a:pPr>
               <a:buNone/>
             </a:pPr>
-            <a:fld id="{844E025A-983C-6D44-79C6-4612AACD43FC}" type="slidenum">
+            <a:fld id="{B1C6C81E-38B9-7560-621D-5A151A79DF9B}" type="slidenum">
               <a:rPr sz="1400">
                 <a:latin typeface="Times New Roman"/>
                 <a:ea typeface="Times New Roman"/>
@@ -8788,10 +10031,131 @@
           </a:p>
         </p:txBody>
       </p:sp>
+      <p:sp>
+        <p:nvSpPr>
+          <p:cNvPr id="3" name="?批捆??蔭? 2">
+            <a:extLst>
+              <a:ext uri="{FF2B5EF4-FFF2-40B4-BE49-F238E27FC236}">
+                <a16:creationId xmlns:a16="http://schemas.microsoft.com/office/drawing/2014/main" id="{EFDF35B5-B6BD-325F-B271-EE42028230F3}"/>
+              </a:ext>
+            </a:extLst>
+          </p:cNvPr>
+          <p:cNvSpPr>
+            <a:spLocks noGrp="1"/>
+          </p:cNvSpPr>
+          <p:nvPr>
+            <p:ph idx="1"/>
+          </p:nvPr>
+        </p:nvSpPr>
+        <p:spPr/>
+        <p:txBody>
+          <a:bodyPr/>
+          <a:lstStyle/>
+          <a:p>
+            <a:r>
+              <a:rPr dirty="0">
+                <a:solidFill>
+                  <a:schemeClr val="bg1">
+                    <a:lumMod val="50000"/>
+                  </a:schemeClr>
+                </a:solidFill>
+              </a:rPr>
+              <a:t>Introduction</a:t>
+            </a:r>
+          </a:p>
+          <a:p>
+            <a:r>
+              <a:rPr dirty="0">
+                <a:solidFill>
+                  <a:schemeClr val="bg1">
+                    <a:lumMod val="50000"/>
+                  </a:schemeClr>
+                </a:solidFill>
+              </a:rPr>
+              <a:t>Background</a:t>
+            </a:r>
+          </a:p>
+          <a:p>
+            <a:r>
+              <a:rPr dirty="0" err="1"/>
+              <a:t>AoA</a:t>
+            </a:r>
+            <a:r>
+              <a:rPr dirty="0"/>
+              <a:t>-Assisted Risk Score and RTS</a:t>
+            </a:r>
+            <a:r>
+              <a:rPr dirty="0">
+                <a:solidFill>
+                  <a:schemeClr val="bg1">
+                    <a:lumMod val="50000"/>
+                  </a:schemeClr>
+                </a:solidFill>
+              </a:rPr>
+              <a:t> </a:t>
+            </a:r>
+            <a:r>
+              <a:rPr dirty="0"/>
+              <a:t>Threshold Adaptation</a:t>
+            </a:r>
+          </a:p>
+          <a:p>
+            <a:r>
+              <a:rPr dirty="0">
+                <a:solidFill>
+                  <a:schemeClr val="bg1">
+                    <a:lumMod val="50000"/>
+                  </a:schemeClr>
+                </a:solidFill>
+              </a:rPr>
+              <a:t>Evaluation</a:t>
+            </a:r>
+          </a:p>
+          <a:p>
+            <a:r>
+              <a:rPr dirty="0">
+                <a:solidFill>
+                  <a:schemeClr val="bg1">
+                    <a:lumMod val="50000"/>
+                  </a:schemeClr>
+                </a:solidFill>
+              </a:rPr>
+              <a:t>Conclusion</a:t>
+            </a:r>
+          </a:p>
+        </p:txBody>
+      </p:sp>
+      <p:sp>
+        <p:nvSpPr>
+          <p:cNvPr id="4" name="璅? 3">
+            <a:extLst>
+              <a:ext uri="{FF2B5EF4-FFF2-40B4-BE49-F238E27FC236}">
+                <a16:creationId xmlns:a16="http://schemas.microsoft.com/office/drawing/2014/main" id="{363B54DA-5A57-63A3-3957-4A5B100F1AAB}"/>
+              </a:ext>
+            </a:extLst>
+          </p:cNvPr>
+          <p:cNvSpPr>
+            <a:spLocks noGrp="1"/>
+          </p:cNvSpPr>
+          <p:nvPr>
+            <p:ph type="title"/>
+          </p:nvPr>
+        </p:nvSpPr>
+        <p:spPr/>
+        <p:txBody>
+          <a:bodyPr/>
+          <a:lstStyle/>
+          <a:p>
+            <a:r>
+              <a:t>Outline</a:t>
+            </a:r>
+          </a:p>
+        </p:txBody>
+      </p:sp>
     </p:spTree>
     <p:extLst>
       <p:ext uri="{BB962C8B-B14F-4D97-AF65-F5344CB8AC3E}">
-        <p14:creationId xmlns:p14="http://schemas.microsoft.com/office/powerpoint/2010/main" val="3499234266"/>
+        <p14:creationId xmlns:p14="http://schemas.microsoft.com/office/powerpoint/2010/main" val="2663263701"/>
       </p:ext>
     </p:extLst>
   </p:cSld>
@@ -8841,7 +10205,7 @@
           <a:p>
             <a:r>
               <a:rPr b="1"/>
-              <a:t>RTS threshold adaptation rule</a:t>
+              <a:t>Risk scoring design goal</a:t>
             </a:r>
           </a:p>
         </p:txBody>
@@ -8868,12 +10232,12 @@
           <a:lstStyle/>
           <a:p>
             <a:r>
-              <a:t>Present the RTS threshold adaptation rule: lower the threshold when hidden-node risk is high, and restore or raise it when risk is low to avoid unnecessary RTS/CTS overhead.</a:t>
-            </a:r>
-          </a:p>
-          <a:p>
-            <a:r>
-              <a:t>Include smoothing and hysteresis so the RTS threshold does not oscillate under noisy AoA or retry measurements.</a:t>
+              <a:t>Present the overall design goal: use AP-side AoA and link observations to decide when RTS/CTS overhead is worthwhile.</a:t>
+            </a:r>
+          </a:p>
+          <a:p>
+            <a:r>
+              <a:t>Define the hidden-node risk score as the core decision variable for RTS threshold control.</a:t>
             </a:r>
           </a:p>
         </p:txBody>
@@ -8902,7 +10266,7 @@
             <a:pPr>
               <a:buNone/>
             </a:pPr>
-            <a:fld id="{0BB18BA8-60F4-C50D-CD9B-1BB87D3E8506}" type="slidenum">
+            <a:fld id="{CCF91274-D221-1BB4-3BF9-836E3AD31EBE}" type="slidenum">
               <a:rPr sz="1400">
                 <a:latin typeface="Times New Roman"/>
                 <a:ea typeface="Times New Roman"/>
@@ -8950,10 +10314,10 @@
       </p:grpSpPr>
       <p:sp>
         <p:nvSpPr>
-          <p:cNvPr id="2" name="?蔣?楊???ａ?蝵桀? 1">
+          <p:cNvPr id="2" name="標題 1">
             <a:extLst>
               <a:ext uri="{FF2B5EF4-FFF2-40B4-BE49-F238E27FC236}">
-                <a16:creationId xmlns:a16="http://schemas.microsoft.com/office/drawing/2014/main" id="{7C687AF8-AF63-1728-2C7B-76B8DC1837DE}"/>
+                <a16:creationId xmlns:a16="http://schemas.microsoft.com/office/drawing/2014/main" id="{27A3B284-1CEC-47E9-98B8-BA58ABCB5210}"/>
               </a:ext>
             </a:extLst>
           </p:cNvPr>
@@ -8961,6 +10325,66 @@
             <a:spLocks noGrp="1"/>
           </p:cNvSpPr>
           <p:nvPr>
+            <p:ph type="title"/>
+          </p:nvPr>
+        </p:nvSpPr>
+        <p:spPr/>
+        <p:txBody>
+          <a:bodyPr/>
+          <a:lstStyle/>
+          <a:p>
+            <a:r>
+              <a:rPr b="1"/>
+              <a:t>AoA and link features for hidden-node risk</a:t>
+            </a:r>
+          </a:p>
+        </p:txBody>
+      </p:sp>
+      <p:sp>
+        <p:nvSpPr>
+          <p:cNvPr id="3" name="內容版面配置區 2">
+            <a:extLst>
+              <a:ext uri="{FF2B5EF4-FFF2-40B4-BE49-F238E27FC236}">
+                <a16:creationId xmlns:a16="http://schemas.microsoft.com/office/drawing/2014/main" id="{85EB7868-0B10-4ADE-BF08-3CE42A258785}"/>
+              </a:ext>
+            </a:extLst>
+          </p:cNvPr>
+          <p:cNvSpPr>
+            <a:spLocks noGrp="1"/>
+          </p:cNvSpPr>
+          <p:nvPr>
+            <p:ph idx="1"/>
+          </p:nvPr>
+        </p:nvSpPr>
+        <p:spPr/>
+        <p:txBody>
+          <a:bodyPr/>
+          <a:lstStyle/>
+          <a:p>
+            <a:r>
+              <a:t>Use AoA estimates from AP-side multi-antenna CSI as the main spatial feature for judging whether two clients are likely to be hidden from each other.</a:t>
+            </a:r>
+          </a:p>
+          <a:p>
+            <a:r>
+              <a:t>Combine AoA-based spatial separation with retry behavior, RSSI, MCS, and traffic activity so the score reflects both geometry and observed collision symptoms.</a:t>
+            </a:r>
+          </a:p>
+        </p:txBody>
+      </p:sp>
+      <p:sp>
+        <p:nvSpPr>
+          <p:cNvPr id="4" name="投影片編號版面配置區 3">
+            <a:extLst>
+              <a:ext uri="{FF2B5EF4-FFF2-40B4-BE49-F238E27FC236}">
+                <a16:creationId xmlns:a16="http://schemas.microsoft.com/office/drawing/2014/main" id="{C2FCD405-600C-462A-BF29-DAFF79456778}"/>
+              </a:ext>
+            </a:extLst>
+          </p:cNvPr>
+          <p:cNvSpPr>
+            <a:spLocks noGrp="1"/>
+          </p:cNvSpPr>
+          <p:nvPr>
             <p:ph type="sldNum" idx="10"/>
           </p:nvPr>
         </p:nvSpPr>
@@ -8972,7 +10396,7 @@
             <a:pPr>
               <a:buNone/>
             </a:pPr>
-            <a:fld id="{F3AE1AE4-D79E-94D6-E825-3FC6C21A77D2}" type="slidenum">
+            <a:fld id="{844E025A-983C-6D44-79C6-4612AACD43FC}" type="slidenum">
               <a:rPr sz="1400">
                 <a:latin typeface="Times New Roman"/>
                 <a:ea typeface="Times New Roman"/>
@@ -8988,123 +10412,10 @@
           </a:p>
         </p:txBody>
       </p:sp>
-      <p:sp>
-        <p:nvSpPr>
-          <p:cNvPr id="3" name="?批捆??蔭? 2">
-            <a:extLst>
-              <a:ext uri="{FF2B5EF4-FFF2-40B4-BE49-F238E27FC236}">
-                <a16:creationId xmlns:a16="http://schemas.microsoft.com/office/drawing/2014/main" id="{EFDF35B5-B6BD-325F-B271-EE42028230F3}"/>
-              </a:ext>
-            </a:extLst>
-          </p:cNvPr>
-          <p:cNvSpPr>
-            <a:spLocks noGrp="1"/>
-          </p:cNvSpPr>
-          <p:nvPr>
-            <p:ph idx="1"/>
-          </p:nvPr>
-        </p:nvSpPr>
-        <p:spPr/>
-        <p:txBody>
-          <a:bodyPr/>
-          <a:lstStyle/>
-          <a:p>
-            <a:r>
-              <a:rPr dirty="0">
-                <a:solidFill>
-                  <a:schemeClr val="bg1">
-                    <a:lumMod val="50000"/>
-                  </a:schemeClr>
-                </a:solidFill>
-              </a:rPr>
-              <a:t>Introduction</a:t>
-            </a:r>
-          </a:p>
-          <a:p>
-            <a:r>
-              <a:rPr dirty="0">
-                <a:solidFill>
-                  <a:schemeClr val="bg1">
-                    <a:lumMod val="50000"/>
-                  </a:schemeClr>
-                </a:solidFill>
-              </a:rPr>
-              <a:t>Background</a:t>
-            </a:r>
-          </a:p>
-          <a:p>
-            <a:r>
-              <a:rPr dirty="0" err="1">
-                <a:solidFill>
-                  <a:schemeClr val="bg1">
-                    <a:lumMod val="50000"/>
-                  </a:schemeClr>
-                </a:solidFill>
-              </a:rPr>
-              <a:t>AoA</a:t>
-            </a:r>
-            <a:r>
-              <a:rPr dirty="0">
-                <a:solidFill>
-                  <a:schemeClr val="bg1">
-                    <a:lumMod val="50000"/>
-                  </a:schemeClr>
-                </a:solidFill>
-              </a:rPr>
-              <a:t>-Assisted Risk Score and RTS Threshold Adaptation</a:t>
-            </a:r>
-          </a:p>
-          <a:p>
-            <a:r>
-              <a:rPr dirty="0"/>
-              <a:t>Evaluation</a:t>
-            </a:r>
-          </a:p>
-          <a:p>
-            <a:r>
-              <a:rPr dirty="0">
-                <a:solidFill>
-                  <a:schemeClr val="bg1">
-                    <a:lumMod val="50000"/>
-                  </a:schemeClr>
-                </a:solidFill>
-              </a:rPr>
-              <a:t>Conclusion</a:t>
-            </a:r>
-          </a:p>
-        </p:txBody>
-      </p:sp>
-      <p:sp>
-        <p:nvSpPr>
-          <p:cNvPr id="4" name="璅? 3">
-            <a:extLst>
-              <a:ext uri="{FF2B5EF4-FFF2-40B4-BE49-F238E27FC236}">
-                <a16:creationId xmlns:a16="http://schemas.microsoft.com/office/drawing/2014/main" id="{363B54DA-5A57-63A3-3957-4A5B100F1AAB}"/>
-              </a:ext>
-            </a:extLst>
-          </p:cNvPr>
-          <p:cNvSpPr>
-            <a:spLocks noGrp="1"/>
-          </p:cNvSpPr>
-          <p:nvPr>
-            <p:ph type="title"/>
-          </p:nvPr>
-        </p:nvSpPr>
-        <p:spPr/>
-        <p:txBody>
-          <a:bodyPr/>
-          <a:lstStyle/>
-          <a:p>
-            <a:r>
-              <a:t>Outline</a:t>
-            </a:r>
-          </a:p>
-        </p:txBody>
-      </p:sp>
     </p:spTree>
     <p:extLst>
       <p:ext uri="{BB962C8B-B14F-4D97-AF65-F5344CB8AC3E}">
-        <p14:creationId xmlns:p14="http://schemas.microsoft.com/office/powerpoint/2010/main" val="346352892"/>
+        <p14:creationId xmlns:p14="http://schemas.microsoft.com/office/powerpoint/2010/main" val="3499234266"/>
       </p:ext>
     </p:extLst>
   </p:cSld>
@@ -9154,7 +10465,7 @@
           <a:p>
             <a:r>
               <a:rPr b="1"/>
-              <a:t>Evaluation scenarios, baselines, and metrics</a:t>
+              <a:t>RTS threshold adaptation rule</a:t>
             </a:r>
           </a:p>
         </p:txBody>
@@ -9181,17 +10492,12 @@
           <a:lstStyle/>
           <a:p>
             <a:r>
-              <a:t>Define test scenarios for hidden-node and non-hidden-node conditions.</a:t>
-            </a:r>
-          </a:p>
-          <a:p>
-            <a:r>
-              <a:t>Compare static RTS/CTS settings with the proposed AoA-assisted dynamic RTS threshold policy.</a:t>
-            </a:r>
-          </a:p>
-          <a:p>
-            <a:r>
-              <a:t>Measure throughput, retry rate, latency, MCS distribution, and fairness.</a:t>
+              <a:t>Present the RTS threshold adaptation rule: lower the threshold when hidden-node risk is high, and restore or raise it when risk is low to avoid unnecessary RTS/CTS overhead.</a:t>
+            </a:r>
+          </a:p>
+          <a:p>
+            <a:r>
+              <a:t>Include smoothing and hysteresis so the RTS threshold does not oscillate under noisy AoA or retry measurements.</a:t>
             </a:r>
           </a:p>
         </p:txBody>
@@ -9220,7 +10526,7 @@
             <a:pPr>
               <a:buNone/>
             </a:pPr>
-            <a:fld id="{5AB55966-FA28-BC73-EA9E-53DF014DF033}" type="slidenum">
+            <a:fld id="{0BB18BA8-60F4-C50D-CD9B-1BB87D3E8506}" type="slidenum">
               <a:rPr sz="1400">
                 <a:latin typeface="Times New Roman"/>
                 <a:ea typeface="Times New Roman"/>
@@ -9268,10 +10574,10 @@
       </p:grpSpPr>
       <p:sp>
         <p:nvSpPr>
-          <p:cNvPr id="2" name="標題 1">
+          <p:cNvPr id="2" name="?蔣?楊???ａ?蝵桀? 1">
             <a:extLst>
               <a:ext uri="{FF2B5EF4-FFF2-40B4-BE49-F238E27FC236}">
-                <a16:creationId xmlns:a16="http://schemas.microsoft.com/office/drawing/2014/main" id="{27A3B284-1CEC-47E9-98B8-BA58ABCB5210}"/>
+                <a16:creationId xmlns:a16="http://schemas.microsoft.com/office/drawing/2014/main" id="{7C687AF8-AF63-1728-2C7B-76B8DC1837DE}"/>
               </a:ext>
             </a:extLst>
           </p:cNvPr>
@@ -9279,61 +10585,6 @@
             <a:spLocks noGrp="1"/>
           </p:cNvSpPr>
           <p:nvPr>
-            <p:ph type="title"/>
-          </p:nvPr>
-        </p:nvSpPr>
-        <p:spPr/>
-        <p:txBody>
-          <a:bodyPr/>
-          <a:lstStyle/>
-          <a:p>
-            <a:r>
-              <a:rPr b="1"/>
-              <a:t>Performance analysis focus</a:t>
-            </a:r>
-          </a:p>
-        </p:txBody>
-      </p:sp>
-      <p:sp>
-        <p:nvSpPr>
-          <p:cNvPr id="3" name="內容版面配置區 2">
-            <a:extLst>
-              <a:ext uri="{FF2B5EF4-FFF2-40B4-BE49-F238E27FC236}">
-                <a16:creationId xmlns:a16="http://schemas.microsoft.com/office/drawing/2014/main" id="{85EB7868-0B10-4ADE-BF08-3CE42A258785}"/>
-              </a:ext>
-            </a:extLst>
-          </p:cNvPr>
-          <p:cNvSpPr>
-            <a:spLocks noGrp="1"/>
-          </p:cNvSpPr>
-          <p:nvPr>
-            <p:ph idx="1"/>
-          </p:nvPr>
-        </p:nvSpPr>
-        <p:spPr/>
-        <p:txBody>
-          <a:bodyPr/>
-          <a:lstStyle/>
-          <a:p>
-            <a:r>
-              <a:t>Analyze when the proposed method improves performance and when it has limited benefit.</a:t>
-            </a:r>
-          </a:p>
-        </p:txBody>
-      </p:sp>
-      <p:sp>
-        <p:nvSpPr>
-          <p:cNvPr id="4" name="投影片編號版面配置區 3">
-            <a:extLst>
-              <a:ext uri="{FF2B5EF4-FFF2-40B4-BE49-F238E27FC236}">
-                <a16:creationId xmlns:a16="http://schemas.microsoft.com/office/drawing/2014/main" id="{C2FCD405-600C-462A-BF29-DAFF79456778}"/>
-              </a:ext>
-            </a:extLst>
-          </p:cNvPr>
-          <p:cNvSpPr>
-            <a:spLocks noGrp="1"/>
-          </p:cNvSpPr>
-          <p:nvPr>
             <p:ph type="sldNum" idx="10"/>
           </p:nvPr>
         </p:nvSpPr>
@@ -9345,7 +10596,7 @@
             <a:pPr>
               <a:buNone/>
             </a:pPr>
-            <a:fld id="{02F15020-66A7-620A-7B7A-C05C4312DEAE}" type="slidenum">
+            <a:fld id="{F3AE1AE4-D79E-94D6-E825-3FC6C21A77D2}" type="slidenum">
               <a:rPr sz="1400">
                 <a:latin typeface="Times New Roman"/>
                 <a:ea typeface="Times New Roman"/>
@@ -9361,10 +10612,123 @@
           </a:p>
         </p:txBody>
       </p:sp>
+      <p:sp>
+        <p:nvSpPr>
+          <p:cNvPr id="3" name="?批捆??蔭? 2">
+            <a:extLst>
+              <a:ext uri="{FF2B5EF4-FFF2-40B4-BE49-F238E27FC236}">
+                <a16:creationId xmlns:a16="http://schemas.microsoft.com/office/drawing/2014/main" id="{EFDF35B5-B6BD-325F-B271-EE42028230F3}"/>
+              </a:ext>
+            </a:extLst>
+          </p:cNvPr>
+          <p:cNvSpPr>
+            <a:spLocks noGrp="1"/>
+          </p:cNvSpPr>
+          <p:nvPr>
+            <p:ph idx="1"/>
+          </p:nvPr>
+        </p:nvSpPr>
+        <p:spPr/>
+        <p:txBody>
+          <a:bodyPr/>
+          <a:lstStyle/>
+          <a:p>
+            <a:r>
+              <a:rPr dirty="0">
+                <a:solidFill>
+                  <a:schemeClr val="bg1">
+                    <a:lumMod val="50000"/>
+                  </a:schemeClr>
+                </a:solidFill>
+              </a:rPr>
+              <a:t>Introduction</a:t>
+            </a:r>
+          </a:p>
+          <a:p>
+            <a:r>
+              <a:rPr dirty="0">
+                <a:solidFill>
+                  <a:schemeClr val="bg1">
+                    <a:lumMod val="50000"/>
+                  </a:schemeClr>
+                </a:solidFill>
+              </a:rPr>
+              <a:t>Background</a:t>
+            </a:r>
+          </a:p>
+          <a:p>
+            <a:r>
+              <a:rPr dirty="0" err="1">
+                <a:solidFill>
+                  <a:schemeClr val="bg1">
+                    <a:lumMod val="50000"/>
+                  </a:schemeClr>
+                </a:solidFill>
+              </a:rPr>
+              <a:t>AoA</a:t>
+            </a:r>
+            <a:r>
+              <a:rPr dirty="0">
+                <a:solidFill>
+                  <a:schemeClr val="bg1">
+                    <a:lumMod val="50000"/>
+                  </a:schemeClr>
+                </a:solidFill>
+              </a:rPr>
+              <a:t>-Assisted Risk Score and RTS Threshold Adaptation</a:t>
+            </a:r>
+          </a:p>
+          <a:p>
+            <a:r>
+              <a:rPr dirty="0"/>
+              <a:t>Evaluation</a:t>
+            </a:r>
+          </a:p>
+          <a:p>
+            <a:r>
+              <a:rPr dirty="0">
+                <a:solidFill>
+                  <a:schemeClr val="bg1">
+                    <a:lumMod val="50000"/>
+                  </a:schemeClr>
+                </a:solidFill>
+              </a:rPr>
+              <a:t>Conclusion</a:t>
+            </a:r>
+          </a:p>
+        </p:txBody>
+      </p:sp>
+      <p:sp>
+        <p:nvSpPr>
+          <p:cNvPr id="4" name="璅? 3">
+            <a:extLst>
+              <a:ext uri="{FF2B5EF4-FFF2-40B4-BE49-F238E27FC236}">
+                <a16:creationId xmlns:a16="http://schemas.microsoft.com/office/drawing/2014/main" id="{363B54DA-5A57-63A3-3957-4A5B100F1AAB}"/>
+              </a:ext>
+            </a:extLst>
+          </p:cNvPr>
+          <p:cNvSpPr>
+            <a:spLocks noGrp="1"/>
+          </p:cNvSpPr>
+          <p:nvPr>
+            <p:ph type="title"/>
+          </p:nvPr>
+        </p:nvSpPr>
+        <p:spPr/>
+        <p:txBody>
+          <a:bodyPr/>
+          <a:lstStyle/>
+          <a:p>
+            <a:r>
+              <a:t>Outline</a:t>
+            </a:r>
+          </a:p>
+        </p:txBody>
+      </p:sp>
     </p:spTree>
     <p:extLst>
       <p:ext uri="{BB962C8B-B14F-4D97-AF65-F5344CB8AC3E}">
-        <p14:creationId xmlns:p14="http://schemas.microsoft.com/office/powerpoint/2010/main" val="3499234266"/>
+        <p14:creationId xmlns:p14="http://schemas.microsoft.com/office/powerpoint/2010/main" val="346352892"/>
       </p:ext>
     </p:extLst>
   </p:cSld>
@@ -9546,6 +10910,266 @@
       </p:grpSpPr>
       <p:sp>
         <p:nvSpPr>
+          <p:cNvPr id="2" name="標題 1">
+            <a:extLst>
+              <a:ext uri="{FF2B5EF4-FFF2-40B4-BE49-F238E27FC236}">
+                <a16:creationId xmlns:a16="http://schemas.microsoft.com/office/drawing/2014/main" id="{27A3B284-1CEC-47E9-98B8-BA58ABCB5210}"/>
+              </a:ext>
+            </a:extLst>
+          </p:cNvPr>
+          <p:cNvSpPr>
+            <a:spLocks noGrp="1"/>
+          </p:cNvSpPr>
+          <p:nvPr>
+            <p:ph type="title"/>
+          </p:nvPr>
+        </p:nvSpPr>
+        <p:spPr/>
+        <p:txBody>
+          <a:bodyPr/>
+          <a:lstStyle/>
+          <a:p>
+            <a:r>
+              <a:rPr b="1"/>
+              <a:t>Evaluation scenarios, baselines, and metrics</a:t>
+            </a:r>
+          </a:p>
+        </p:txBody>
+      </p:sp>
+      <p:sp>
+        <p:nvSpPr>
+          <p:cNvPr id="3" name="內容版面配置區 2">
+            <a:extLst>
+              <a:ext uri="{FF2B5EF4-FFF2-40B4-BE49-F238E27FC236}">
+                <a16:creationId xmlns:a16="http://schemas.microsoft.com/office/drawing/2014/main" id="{85EB7868-0B10-4ADE-BF08-3CE42A258785}"/>
+              </a:ext>
+            </a:extLst>
+          </p:cNvPr>
+          <p:cNvSpPr>
+            <a:spLocks noGrp="1"/>
+          </p:cNvSpPr>
+          <p:nvPr>
+            <p:ph idx="1"/>
+          </p:nvPr>
+        </p:nvSpPr>
+        <p:spPr/>
+        <p:txBody>
+          <a:bodyPr/>
+          <a:lstStyle/>
+          <a:p>
+            <a:r>
+              <a:t>Define test scenarios for hidden-node and non-hidden-node conditions.</a:t>
+            </a:r>
+          </a:p>
+          <a:p>
+            <a:r>
+              <a:t>Compare static RTS/CTS settings with the proposed AoA-assisted dynamic RTS threshold policy.</a:t>
+            </a:r>
+          </a:p>
+          <a:p>
+            <a:r>
+              <a:t>Measure throughput, retry rate, latency, MCS distribution, and fairness.</a:t>
+            </a:r>
+          </a:p>
+        </p:txBody>
+      </p:sp>
+      <p:sp>
+        <p:nvSpPr>
+          <p:cNvPr id="4" name="投影片編號版面配置區 3">
+            <a:extLst>
+              <a:ext uri="{FF2B5EF4-FFF2-40B4-BE49-F238E27FC236}">
+                <a16:creationId xmlns:a16="http://schemas.microsoft.com/office/drawing/2014/main" id="{C2FCD405-600C-462A-BF29-DAFF79456778}"/>
+              </a:ext>
+            </a:extLst>
+          </p:cNvPr>
+          <p:cNvSpPr>
+            <a:spLocks noGrp="1"/>
+          </p:cNvSpPr>
+          <p:nvPr>
+            <p:ph type="sldNum" idx="10"/>
+          </p:nvPr>
+        </p:nvSpPr>
+        <p:spPr/>
+        <p:txBody>
+          <a:bodyPr/>
+          <a:lstStyle/>
+          <a:p>
+            <a:pPr>
+              <a:buNone/>
+            </a:pPr>
+            <a:fld id="{5AB55966-FA28-BC73-EA9E-53DF014DF033}" type="slidenum">
+              <a:rPr sz="1400">
+                <a:latin typeface="Times New Roman"/>
+                <a:ea typeface="Times New Roman"/>
+                <a:cs typeface="Times New Roman"/>
+              </a:rPr>
+              <a:t>20</a:t>
+            </a:fld>
+            <a:endParaRPr sz="1400">
+              <a:latin typeface="Times New Roman"/>
+              <a:ea typeface="Times New Roman"/>
+              <a:cs typeface="Times New Roman"/>
+            </a:endParaRPr>
+          </a:p>
+        </p:txBody>
+      </p:sp>
+    </p:spTree>
+    <p:extLst>
+      <p:ext uri="{BB962C8B-B14F-4D97-AF65-F5344CB8AC3E}">
+        <p14:creationId xmlns:p14="http://schemas.microsoft.com/office/powerpoint/2010/main" val="3499234266"/>
+      </p:ext>
+    </p:extLst>
+  </p:cSld>
+  <p:clrMapOvr>
+    <a:masterClrMapping/>
+  </p:clrMapOvr>
+</p:sld>
+</file>
+
+<file path=ppt/slides/slide21.xml><?xml version="1.0" encoding="utf-8"?>
+<p:sld xmlns:a="http://schemas.openxmlformats.org/drawingml/2006/main" xmlns:r="http://schemas.openxmlformats.org/officeDocument/2006/relationships" xmlns:p="http://schemas.openxmlformats.org/presentationml/2006/main">
+  <p:cSld>
+    <p:spTree>
+      <p:nvGrpSpPr>
+        <p:cNvPr id="1" name=""/>
+        <p:cNvGrpSpPr/>
+        <p:nvPr/>
+      </p:nvGrpSpPr>
+      <p:grpSpPr>
+        <a:xfrm>
+          <a:off x="0" y="0"/>
+          <a:ext cx="0" cy="0"/>
+          <a:chOff x="0" y="0"/>
+          <a:chExt cx="0" cy="0"/>
+        </a:xfrm>
+      </p:grpSpPr>
+      <p:sp>
+        <p:nvSpPr>
+          <p:cNvPr id="2" name="標題 1">
+            <a:extLst>
+              <a:ext uri="{FF2B5EF4-FFF2-40B4-BE49-F238E27FC236}">
+                <a16:creationId xmlns:a16="http://schemas.microsoft.com/office/drawing/2014/main" id="{27A3B284-1CEC-47E9-98B8-BA58ABCB5210}"/>
+              </a:ext>
+            </a:extLst>
+          </p:cNvPr>
+          <p:cNvSpPr>
+            <a:spLocks noGrp="1"/>
+          </p:cNvSpPr>
+          <p:nvPr>
+            <p:ph type="title"/>
+          </p:nvPr>
+        </p:nvSpPr>
+        <p:spPr/>
+        <p:txBody>
+          <a:bodyPr/>
+          <a:lstStyle/>
+          <a:p>
+            <a:r>
+              <a:rPr b="1"/>
+              <a:t>Performance analysis focus</a:t>
+            </a:r>
+          </a:p>
+        </p:txBody>
+      </p:sp>
+      <p:sp>
+        <p:nvSpPr>
+          <p:cNvPr id="3" name="內容版面配置區 2">
+            <a:extLst>
+              <a:ext uri="{FF2B5EF4-FFF2-40B4-BE49-F238E27FC236}">
+                <a16:creationId xmlns:a16="http://schemas.microsoft.com/office/drawing/2014/main" id="{85EB7868-0B10-4ADE-BF08-3CE42A258785}"/>
+              </a:ext>
+            </a:extLst>
+          </p:cNvPr>
+          <p:cNvSpPr>
+            <a:spLocks noGrp="1"/>
+          </p:cNvSpPr>
+          <p:nvPr>
+            <p:ph idx="1"/>
+          </p:nvPr>
+        </p:nvSpPr>
+        <p:spPr/>
+        <p:txBody>
+          <a:bodyPr/>
+          <a:lstStyle/>
+          <a:p>
+            <a:r>
+              <a:t>Analyze when the proposed method improves performance and when it has limited benefit.</a:t>
+            </a:r>
+          </a:p>
+        </p:txBody>
+      </p:sp>
+      <p:sp>
+        <p:nvSpPr>
+          <p:cNvPr id="4" name="投影片編號版面配置區 3">
+            <a:extLst>
+              <a:ext uri="{FF2B5EF4-FFF2-40B4-BE49-F238E27FC236}">
+                <a16:creationId xmlns:a16="http://schemas.microsoft.com/office/drawing/2014/main" id="{C2FCD405-600C-462A-BF29-DAFF79456778}"/>
+              </a:ext>
+            </a:extLst>
+          </p:cNvPr>
+          <p:cNvSpPr>
+            <a:spLocks noGrp="1"/>
+          </p:cNvSpPr>
+          <p:nvPr>
+            <p:ph type="sldNum" idx="10"/>
+          </p:nvPr>
+        </p:nvSpPr>
+        <p:spPr/>
+        <p:txBody>
+          <a:bodyPr/>
+          <a:lstStyle/>
+          <a:p>
+            <a:pPr>
+              <a:buNone/>
+            </a:pPr>
+            <a:fld id="{02F15020-66A7-620A-7B7A-C05C4312DEAE}" type="slidenum">
+              <a:rPr sz="1400">
+                <a:latin typeface="Times New Roman"/>
+                <a:ea typeface="Times New Roman"/>
+                <a:cs typeface="Times New Roman"/>
+              </a:rPr>
+              <a:t>21</a:t>
+            </a:fld>
+            <a:endParaRPr sz="1400">
+              <a:latin typeface="Times New Roman"/>
+              <a:ea typeface="Times New Roman"/>
+              <a:cs typeface="Times New Roman"/>
+            </a:endParaRPr>
+          </a:p>
+        </p:txBody>
+      </p:sp>
+    </p:spTree>
+    <p:extLst>
+      <p:ext uri="{BB962C8B-B14F-4D97-AF65-F5344CB8AC3E}">
+        <p14:creationId xmlns:p14="http://schemas.microsoft.com/office/powerpoint/2010/main" val="3499234266"/>
+      </p:ext>
+    </p:extLst>
+  </p:cSld>
+  <p:clrMapOvr>
+    <a:masterClrMapping/>
+  </p:clrMapOvr>
+</p:sld>
+</file>
+
+<file path=ppt/slides/slide22.xml><?xml version="1.0" encoding="utf-8"?>
+<p:sld xmlns:a="http://schemas.openxmlformats.org/drawingml/2006/main" xmlns:r="http://schemas.openxmlformats.org/officeDocument/2006/relationships" xmlns:p="http://schemas.openxmlformats.org/presentationml/2006/main">
+  <p:cSld>
+    <p:spTree>
+      <p:nvGrpSpPr>
+        <p:cNvPr id="1" name=""/>
+        <p:cNvGrpSpPr/>
+        <p:nvPr/>
+      </p:nvGrpSpPr>
+      <p:grpSpPr>
+        <a:xfrm>
+          <a:off x="0" y="0"/>
+          <a:ext cx="0" cy="0"/>
+          <a:chOff x="0" y="0"/>
+          <a:chExt cx="0" cy="0"/>
+        </a:xfrm>
+      </p:grpSpPr>
+      <p:sp>
+        <p:nvSpPr>
           <p:cNvPr id="2" name="?蔣?楊???ａ?蝵桀? 1">
             <a:extLst>
               <a:ext uri="{FF2B5EF4-FFF2-40B4-BE49-F238E27FC236}">
@@ -9574,7 +11198,7 @@
                 <a:ea typeface="Times New Roman"/>
                 <a:cs typeface="Times New Roman"/>
               </a:rPr>
-              <a:t>20</a:t>
+              <a:t>22</a:t>
             </a:fld>
             <a:endParaRPr sz="1400">
               <a:latin typeface="Times New Roman"/>
@@ -11361,6 +12985,14 @@
               <a:rPr lang="zh-TW" altLang="zh-TW" dirty="0"/>
               <a:t>Different paths or arrival directions create different phase shifts</a:t>
             </a:r>
+            <a:endParaRPr lang="en-US" altLang="zh-TW" dirty="0"/>
+          </a:p>
+          <a:p>
+            <a:r>
+              <a:rPr lang="en-US" altLang="zh-TW" dirty="0"/>
+              <a:t>Represent in e </a:t>
+            </a:r>
+            <a:endParaRPr lang="zh-TW" altLang="zh-TW" dirty="0"/>
           </a:p>
         </p:txBody>
       </p:sp>

</xml_diff>

<commit_message>
update thesis deck and repository guidelines
</commit_message>
<xml_diff>
--- a/thesis_filled.pptx
+++ b/thesis_filled.pptx
@@ -5,7 +5,7 @@
     <p:sldMasterId id="2147483648" r:id="rId1"/>
   </p:sldMasterIdLst>
   <p:notesMasterIdLst>
-    <p:notesMasterId r:id="rId24"/>
+    <p:notesMasterId r:id="rId25"/>
   </p:notesMasterIdLst>
   <p:sldIdLst>
     <p:sldId id="256" r:id="rId2"/>
@@ -17,19 +17,20 @@
     <p:sldId id="263" r:id="rId8"/>
     <p:sldId id="264" r:id="rId9"/>
     <p:sldId id="265" r:id="rId10"/>
-    <p:sldId id="269" r:id="rId11"/>
-    <p:sldId id="287" r:id="rId12"/>
-    <p:sldId id="285" r:id="rId13"/>
-    <p:sldId id="288" r:id="rId14"/>
-    <p:sldId id="266" r:id="rId15"/>
-    <p:sldId id="273" r:id="rId16"/>
-    <p:sldId id="274" r:id="rId17"/>
-    <p:sldId id="275" r:id="rId18"/>
-    <p:sldId id="277" r:id="rId19"/>
-    <p:sldId id="280" r:id="rId20"/>
-    <p:sldId id="281" r:id="rId21"/>
-    <p:sldId id="282" r:id="rId22"/>
-    <p:sldId id="283" r:id="rId23"/>
+    <p:sldId id="289" r:id="rId11"/>
+    <p:sldId id="269" r:id="rId12"/>
+    <p:sldId id="287" r:id="rId13"/>
+    <p:sldId id="285" r:id="rId14"/>
+    <p:sldId id="288" r:id="rId15"/>
+    <p:sldId id="266" r:id="rId16"/>
+    <p:sldId id="273" r:id="rId17"/>
+    <p:sldId id="274" r:id="rId18"/>
+    <p:sldId id="275" r:id="rId19"/>
+    <p:sldId id="277" r:id="rId20"/>
+    <p:sldId id="280" r:id="rId21"/>
+    <p:sldId id="281" r:id="rId22"/>
+    <p:sldId id="282" r:id="rId23"/>
+    <p:sldId id="283" r:id="rId24"/>
   </p:sldIdLst>
   <p:sldSz cx="12192000" cy="6858000"/>
   <p:notesSz cx="6858000" cy="9144000"/>
@@ -450,11 +451,6 @@
         </p:txBody>
       </p:sp>
     </p:spTree>
-    <p:extLst>
-      <p:ext uri="{BB962C8B-B14F-4D97-AF65-F5344CB8AC3E}">
-        <p14:creationId xmlns:p14="http://schemas.microsoft.com/office/powerpoint/2010/main" val="1608574538"/>
-      </p:ext>
-    </p:extLst>
   </p:cSld>
   <p:clrMapOvr>
     <a:masterClrMapping/>
@@ -530,6 +526,11 @@
         </p:txBody>
       </p:sp>
     </p:spTree>
+    <p:extLst>
+      <p:ext uri="{BB962C8B-B14F-4D97-AF65-F5344CB8AC3E}">
+        <p14:creationId xmlns:p14="http://schemas.microsoft.com/office/powerpoint/2010/main" val="1608574538"/>
+      </p:ext>
+    </p:extLst>
   </p:cSld>
   <p:clrMapOvr>
     <a:masterClrMapping/>
@@ -1212,6 +1213,81 @@
 </p:notes>
 </file>
 
+<file path=ppt/notesSlides/notesSlide20.xml><?xml version="1.0" encoding="utf-8"?>
+<p:notes xmlns:a="http://schemas.openxmlformats.org/drawingml/2006/main" xmlns:r="http://schemas.openxmlformats.org/officeDocument/2006/relationships" xmlns:p="http://schemas.openxmlformats.org/presentationml/2006/main">
+  <p:cSld>
+    <p:spTree>
+      <p:nvGrpSpPr>
+        <p:cNvPr id="1" name=""/>
+        <p:cNvGrpSpPr/>
+        <p:nvPr/>
+      </p:nvGrpSpPr>
+      <p:grpSpPr>
+        <a:xfrm>
+          <a:off x="0" y="0"/>
+          <a:ext cx="0" cy="0"/>
+          <a:chOff x="0" y="0"/>
+          <a:chExt cx="0" cy="0"/>
+        </a:xfrm>
+      </p:grpSpPr>
+      <p:sp>
+        <p:nvSpPr>
+          <p:cNvPr id="2" name="Slide Image Placeholder 1"/>
+          <p:cNvSpPr>
+            <a:spLocks noGrp="1" noRot="1" noChangeAspect="1"/>
+          </p:cNvSpPr>
+          <p:nvPr>
+            <p:ph type="sldImg"/>
+          </p:nvPr>
+        </p:nvSpPr>
+        <p:spPr/>
+      </p:sp>
+      <p:sp>
+        <p:nvSpPr>
+          <p:cNvPr id="3" name="Notes Placeholder 2"/>
+          <p:cNvSpPr>
+            <a:spLocks noGrp="1"/>
+          </p:cNvSpPr>
+          <p:nvPr>
+            <p:ph type="body" idx="1"/>
+          </p:nvPr>
+        </p:nvSpPr>
+        <p:spPr/>
+        <p:txBody>
+          <a:bodyPr/>
+          <a:lstStyle/>
+          <a:p>
+            <a:endParaRPr/>
+          </a:p>
+        </p:txBody>
+      </p:sp>
+      <p:sp>
+        <p:nvSpPr>
+          <p:cNvPr id="4" name="Slide Number Placeholder 3"/>
+          <p:cNvSpPr>
+            <a:spLocks noGrp="1"/>
+          </p:cNvSpPr>
+          <p:nvPr>
+            <p:ph type="sldNum" idx="5"/>
+          </p:nvPr>
+        </p:nvSpPr>
+        <p:spPr/>
+        <p:txBody>
+          <a:bodyPr/>
+          <a:lstStyle/>
+          <a:p>
+            <a:endParaRPr/>
+          </a:p>
+        </p:txBody>
+      </p:sp>
+    </p:spTree>
+  </p:cSld>
+  <p:clrMapOvr>
+    <a:masterClrMapping/>
+  </p:clrMapOvr>
+</p:notes>
+</file>
+
 <file path=ppt/notesSlides/notesSlide3.xml><?xml version="1.0" encoding="utf-8"?>
 <p:notes xmlns:a="http://schemas.openxmlformats.org/drawingml/2006/main" xmlns:r="http://schemas.openxmlformats.org/officeDocument/2006/relationships" xmlns:p="http://schemas.openxmlformats.org/presentationml/2006/main">
   <p:cSld>
@@ -1708,30 +1784,53 @@
           <a:bodyPr/>
           <a:lstStyle/>
           <a:p>
+            <a:r>
+              <a:rPr lang="en-US" dirty="0"/>
+              <a:t>https://www.sciencedirect.com/topics/engineering/phasor-representation</a:t>
+            </a:r>
+            <a:r>
+              <a:rPr lang="zh-TW" altLang="en-US" dirty="0"/>
+              <a:t> </a:t>
+            </a:r>
+            <a:endParaRPr lang="en-US" altLang="zh-TW" dirty="0"/>
+          </a:p>
+          <a:p>
+            <a:endParaRPr lang="en-US" dirty="0"/>
+          </a:p>
+          <a:p>
+            <a:r>
+              <a:rPr lang="en-US" altLang="zh-TW" dirty="0"/>
+              <a:t>CSI=transmitted reference signal / received signal​</a:t>
+            </a:r>
+            <a:endParaRPr dirty="0"/>
+          </a:p>
+        </p:txBody>
+      </p:sp>
+      <p:sp>
+        <p:nvSpPr>
+          <p:cNvPr id="4" name="Slide Number Placeholder 3"/>
+          <p:cNvSpPr>
+            <a:spLocks noGrp="1"/>
+          </p:cNvSpPr>
+          <p:nvPr>
+            <p:ph type="sldNum" idx="5"/>
+          </p:nvPr>
+        </p:nvSpPr>
+        <p:spPr/>
+        <p:txBody>
+          <a:bodyPr/>
+          <a:lstStyle/>
+          <a:p>
             <a:endParaRPr/>
           </a:p>
         </p:txBody>
       </p:sp>
-      <p:sp>
-        <p:nvSpPr>
-          <p:cNvPr id="4" name="Slide Number Placeholder 3"/>
-          <p:cNvSpPr>
-            <a:spLocks noGrp="1"/>
-          </p:cNvSpPr>
-          <p:nvPr>
-            <p:ph type="sldNum" idx="5"/>
-          </p:nvPr>
-        </p:nvSpPr>
-        <p:spPr/>
-        <p:txBody>
-          <a:bodyPr/>
-          <a:lstStyle/>
-          <a:p>
-            <a:endParaRPr/>
-          </a:p>
-        </p:txBody>
-      </p:sp>
     </p:spTree>
+    <p:extLst>
+      <p:ext uri="{BB962C8B-B14F-4D97-AF65-F5344CB8AC3E}">
+        <p14:creationId xmlns:p14="http://schemas.microsoft.com/office/powerpoint/2010/main" val="1168397894"/>
+      </p:ext>
+    </p:extLst>
   </p:cSld>
   <p:clrMapOvr>
     <a:masterClrMapping/>
@@ -8001,34 +8100,9 @@
           <a:p>
             <a:r>
               <a:rPr lang="en-US" altLang="zh-TW" dirty="0"/>
-              <a:t>Spatial Spectrum Estimation</a:t>
-            </a:r>
-            <a:endParaRPr b="1" dirty="0"/>
-          </a:p>
-        </p:txBody>
-      </p:sp>
-      <p:sp>
-        <p:nvSpPr>
-          <p:cNvPr id="3" name="內容版面配置區 2">
-            <a:extLst>
-              <a:ext uri="{FF2B5EF4-FFF2-40B4-BE49-F238E27FC236}">
-                <a16:creationId xmlns:a16="http://schemas.microsoft.com/office/drawing/2014/main" id="{85EB7868-0B10-4ADE-BF08-3CE42A258785}"/>
-              </a:ext>
-            </a:extLst>
-          </p:cNvPr>
-          <p:cNvSpPr>
-            <a:spLocks noGrp="1"/>
-          </p:cNvSpPr>
-          <p:nvPr>
-            <p:ph idx="1"/>
-          </p:nvPr>
-        </p:nvSpPr>
-        <p:spPr/>
-        <p:txBody>
-          <a:bodyPr/>
-          <a:lstStyle/>
-          <a:p>
-            <a:endParaRPr dirty="0"/>
+              <a:t>CSI Representation</a:t>
+            </a:r>
+            <a:endParaRPr lang="zh-TW" altLang="zh-TW" dirty="0"/>
           </a:p>
         </p:txBody>
       </p:sp>
@@ -8056,7 +8130,7 @@
             <a:pPr>
               <a:buNone/>
             </a:pPr>
-            <a:fld id="{327921A4-25C4-3DB4-06B1-32693CEE2241}" type="slidenum">
+            <a:fld id="{DB7BEEEC-A170-5376-2B6E-CB54687B0CB1}" type="slidenum">
               <a:rPr sz="1400">
                 <a:latin typeface="Times New Roman"/>
                 <a:ea typeface="Times New Roman"/>
@@ -8072,10 +8146,225 @@
           </a:p>
         </p:txBody>
       </p:sp>
+      <mc:AlternateContent xmlns:mc="http://schemas.openxmlformats.org/markup-compatibility/2006">
+        <mc:Choice xmlns:a14="http://schemas.microsoft.com/office/drawing/2010/main" Requires="a14">
+          <p:sp>
+            <p:nvSpPr>
+              <p:cNvPr id="3" name="內容版面配置區 2">
+                <a:extLst>
+                  <a:ext uri="{FF2B5EF4-FFF2-40B4-BE49-F238E27FC236}">
+                    <a16:creationId xmlns:a16="http://schemas.microsoft.com/office/drawing/2014/main" id="{66361893-5D2A-0C1F-46D0-78D0A5600AB7}"/>
+                  </a:ext>
+                </a:extLst>
+              </p:cNvPr>
+              <p:cNvSpPr>
+                <a:spLocks noGrp="1"/>
+              </p:cNvSpPr>
+              <p:nvPr>
+                <p:ph idx="1"/>
+              </p:nvPr>
+            </p:nvSpPr>
+            <p:spPr>
+              <a:xfrm>
+                <a:off x="640613" y="1073275"/>
+                <a:ext cx="10916870" cy="5413072"/>
+              </a:xfrm>
+            </p:spPr>
+            <p:txBody>
+              <a:bodyPr/>
+              <a:lstStyle/>
+              <a:p>
+                <a:r>
+                  <a:rPr lang="en-US" altLang="zh-TW" dirty="0"/>
+                  <a:t>Represented as a complex exponential</a:t>
+                </a:r>
+                <a:r>
+                  <a:rPr lang="zh-TW" altLang="en-US" dirty="0"/>
+                  <a:t> </a:t>
+                </a:r>
+                <a:br>
+                  <a:rPr lang="en-US" altLang="zh-TW" b="0" i="1" dirty="0">
+                    <a:latin typeface="Cambria Math" panose="02040503050406030204" pitchFamily="18" charset="0"/>
+                  </a:rPr>
+                </a:br>
+                <a14:m>
+                  <m:oMath xmlns:m="http://schemas.openxmlformats.org/officeDocument/2006/math">
+                    <m:r>
+                      <a:rPr lang="en-US" altLang="zh-TW" b="0" i="1" dirty="0">
+                        <a:latin typeface="Cambria Math" panose="02040503050406030204" pitchFamily="18" charset="0"/>
+                      </a:rPr>
+                      <m:t>𝐴</m:t>
+                    </m:r>
+                    <m:sSup>
+                      <m:sSupPr>
+                        <m:ctrlPr>
+                          <a:rPr lang="en-US" altLang="zh-TW" i="1" dirty="0" smtClean="0">
+                            <a:latin typeface="Cambria Math" panose="02040503050406030204" pitchFamily="18" charset="0"/>
+                          </a:rPr>
+                        </m:ctrlPr>
+                      </m:sSupPr>
+                      <m:e>
+                        <m:r>
+                          <a:rPr lang="en-US" altLang="zh-TW" b="0" i="1" dirty="0" smtClean="0">
+                            <a:latin typeface="Cambria Math" panose="02040503050406030204" pitchFamily="18" charset="0"/>
+                          </a:rPr>
+                          <m:t>𝑒</m:t>
+                        </m:r>
+                      </m:e>
+                      <m:sup>
+                        <m:r>
+                          <a:rPr lang="en-US" altLang="zh-TW" b="0" i="1" dirty="0" smtClean="0">
+                            <a:latin typeface="Cambria Math" panose="02040503050406030204" pitchFamily="18" charset="0"/>
+                          </a:rPr>
+                          <m:t>𝑃𝑖</m:t>
+                        </m:r>
+                      </m:sup>
+                    </m:sSup>
+                  </m:oMath>
+                </a14:m>
+                <a:endParaRPr lang="en-US" altLang="zh-TW" dirty="0"/>
+              </a:p>
+              <a:p>
+                <a:r>
+                  <a:rPr lang="en-US" altLang="zh-TW" dirty="0"/>
+                  <a:t>A</a:t>
+                </a:r>
+                <a:r>
+                  <a:rPr lang="zh-TW" altLang="zh-TW" dirty="0"/>
+                  <a:t>:</a:t>
+                </a:r>
+                <a:r>
+                  <a:rPr lang="en-US" altLang="zh-TW" dirty="0"/>
+                  <a:t> Amplitude — </a:t>
+                </a:r>
+                <a:r>
+                  <a:rPr lang="zh-TW" altLang="zh-TW" dirty="0"/>
+                  <a:t>signal</a:t>
+                </a:r>
+                <a:r>
+                  <a:rPr lang="en-US" altLang="zh-TW" dirty="0"/>
+                  <a:t> strength relative to known transmitted wave</a:t>
+                </a:r>
+                <a:endParaRPr lang="zh-TW" altLang="zh-TW" dirty="0"/>
+              </a:p>
+              <a:p>
+                <a:r>
+                  <a:rPr lang="en-US" altLang="zh-TW" dirty="0"/>
+                  <a:t>P</a:t>
+                </a:r>
+                <a:r>
+                  <a:rPr lang="zh-TW" altLang="zh-TW" dirty="0"/>
+                  <a:t>:</a:t>
+                </a:r>
+                <a:r>
+                  <a:rPr lang="en-US" altLang="zh-TW" dirty="0"/>
+                  <a:t> Phase — signal’s rotation relative to a known transmitted wave</a:t>
+                </a:r>
+              </a:p>
+              <a:p>
+                <a:pPr marL="0" indent="0">
+                  <a:buNone/>
+                </a:pPr>
+                <a:endParaRPr lang="zh-TW" altLang="zh-TW" dirty="0"/>
+              </a:p>
+            </p:txBody>
+          </p:sp>
+        </mc:Choice>
+        <mc:Fallback>
+          <p:sp>
+            <p:nvSpPr>
+              <p:cNvPr id="3" name="內容版面配置區 2">
+                <a:extLst>
+                  <a:ext uri="{FF2B5EF4-FFF2-40B4-BE49-F238E27FC236}">
+                    <a16:creationId xmlns:a16="http://schemas.microsoft.com/office/drawing/2014/main" id="{66361893-5D2A-0C1F-46D0-78D0A5600AB7}"/>
+                  </a:ext>
+                </a:extLst>
+              </p:cNvPr>
+              <p:cNvSpPr>
+                <a:spLocks noGrp="1" noRot="1" noChangeAspect="1" noMove="1" noResize="1" noEditPoints="1" noAdjustHandles="1" noChangeArrowheads="1" noChangeShapeType="1" noTextEdit="1"/>
+              </p:cNvSpPr>
+              <p:nvPr>
+                <p:ph idx="1"/>
+              </p:nvPr>
+            </p:nvSpPr>
+            <p:spPr>
+              <a:xfrm>
+                <a:off x="640613" y="1073275"/>
+                <a:ext cx="10916870" cy="5413072"/>
+              </a:xfrm>
+              <a:blipFill>
+                <a:blip r:embed="rId3"/>
+                <a:stretch>
+                  <a:fillRect l="-670" t="-901"/>
+                </a:stretch>
+              </a:blipFill>
+            </p:spPr>
+            <p:txBody>
+              <a:bodyPr/>
+              <a:lstStyle/>
+              <a:p>
+                <a:r>
+                  <a:rPr lang="zh-TW" altLang="en-US">
+                    <a:noFill/>
+                  </a:rPr>
+                  <a:t> </a:t>
+                </a:r>
+              </a:p>
+            </p:txBody>
+          </p:sp>
+        </mc:Fallback>
+      </mc:AlternateContent>
+      <p:pic>
+        <p:nvPicPr>
+          <p:cNvPr id="1028" name="Picture 4">
+            <a:extLst>
+              <a:ext uri="{FF2B5EF4-FFF2-40B4-BE49-F238E27FC236}">
+                <a16:creationId xmlns:a16="http://schemas.microsoft.com/office/drawing/2014/main" id="{630BB101-C222-4B90-A86F-55D35332DFB4}"/>
+              </a:ext>
+            </a:extLst>
+          </p:cNvPr>
+          <p:cNvPicPr>
+            <a:picLocks noChangeAspect="1" noChangeArrowheads="1"/>
+          </p:cNvPicPr>
+          <p:nvPr/>
+        </p:nvPicPr>
+        <p:blipFill>
+          <a:blip r:embed="rId4">
+            <a:extLst>
+              <a:ext uri="{28A0092B-C50C-407E-A947-70E740481C1C}">
+                <a14:useLocalDpi xmlns:a14="http://schemas.microsoft.com/office/drawing/2010/main" val="0"/>
+              </a:ext>
+            </a:extLst>
+          </a:blip>
+          <a:srcRect/>
+          <a:stretch>
+            <a:fillRect/>
+          </a:stretch>
+        </p:blipFill>
+        <p:spPr bwMode="auto">
+          <a:xfrm>
+            <a:off x="2261259" y="3136269"/>
+            <a:ext cx="7813497" cy="2950640"/>
+          </a:xfrm>
+          <a:prstGeom prst="rect">
+            <a:avLst/>
+          </a:prstGeom>
+          <a:noFill/>
+          <a:extLst>
+            <a:ext uri="{909E8E84-426E-40DD-AFC4-6F175D3DCCD1}">
+              <a14:hiddenFill xmlns:a14="http://schemas.microsoft.com/office/drawing/2010/main">
+                <a:solidFill>
+                  <a:srgbClr val="FFFFFF"/>
+                </a:solidFill>
+              </a14:hiddenFill>
+            </a:ext>
+          </a:extLst>
+        </p:spPr>
+      </p:pic>
     </p:spTree>
     <p:extLst>
       <p:ext uri="{BB962C8B-B14F-4D97-AF65-F5344CB8AC3E}">
-        <p14:creationId xmlns:p14="http://schemas.microsoft.com/office/powerpoint/2010/main" val="3499234266"/>
+        <p14:creationId xmlns:p14="http://schemas.microsoft.com/office/powerpoint/2010/main" val="4113921122"/>
       </p:ext>
     </p:extLst>
   </p:cSld>
@@ -8107,6 +8396,130 @@
           <p:cNvPr id="2" name="標題 1">
             <a:extLst>
               <a:ext uri="{FF2B5EF4-FFF2-40B4-BE49-F238E27FC236}">
+                <a16:creationId xmlns:a16="http://schemas.microsoft.com/office/drawing/2014/main" id="{27A3B284-1CEC-47E9-98B8-BA58ABCB5210}"/>
+              </a:ext>
+            </a:extLst>
+          </p:cNvPr>
+          <p:cNvSpPr>
+            <a:spLocks noGrp="1"/>
+          </p:cNvSpPr>
+          <p:nvPr>
+            <p:ph type="title"/>
+          </p:nvPr>
+        </p:nvSpPr>
+        <p:spPr/>
+        <p:txBody>
+          <a:bodyPr/>
+          <a:lstStyle/>
+          <a:p>
+            <a:r>
+              <a:rPr lang="en-US" altLang="zh-TW" dirty="0"/>
+              <a:t>Spatial Spectrum Estimation Estimates AoA</a:t>
+            </a:r>
+            <a:endParaRPr b="1" dirty="0"/>
+          </a:p>
+        </p:txBody>
+      </p:sp>
+      <p:sp>
+        <p:nvSpPr>
+          <p:cNvPr id="3" name="內容版面配置區 2">
+            <a:extLst>
+              <a:ext uri="{FF2B5EF4-FFF2-40B4-BE49-F238E27FC236}">
+                <a16:creationId xmlns:a16="http://schemas.microsoft.com/office/drawing/2014/main" id="{85EB7868-0B10-4ADE-BF08-3CE42A258785}"/>
+              </a:ext>
+            </a:extLst>
+          </p:cNvPr>
+          <p:cNvSpPr>
+            <a:spLocks noGrp="1"/>
+          </p:cNvSpPr>
+          <p:nvPr>
+            <p:ph idx="1"/>
+          </p:nvPr>
+        </p:nvSpPr>
+        <p:spPr/>
+        <p:txBody>
+          <a:bodyPr/>
+          <a:lstStyle/>
+          <a:p>
+            <a:endParaRPr dirty="0"/>
+          </a:p>
+        </p:txBody>
+      </p:sp>
+      <p:sp>
+        <p:nvSpPr>
+          <p:cNvPr id="4" name="投影片編號版面配置區 3">
+            <a:extLst>
+              <a:ext uri="{FF2B5EF4-FFF2-40B4-BE49-F238E27FC236}">
+                <a16:creationId xmlns:a16="http://schemas.microsoft.com/office/drawing/2014/main" id="{C2FCD405-600C-462A-BF29-DAFF79456778}"/>
+              </a:ext>
+            </a:extLst>
+          </p:cNvPr>
+          <p:cNvSpPr>
+            <a:spLocks noGrp="1"/>
+          </p:cNvSpPr>
+          <p:nvPr>
+            <p:ph type="sldNum" idx="10"/>
+          </p:nvPr>
+        </p:nvSpPr>
+        <p:spPr/>
+        <p:txBody>
+          <a:bodyPr/>
+          <a:lstStyle/>
+          <a:p>
+            <a:pPr>
+              <a:buNone/>
+            </a:pPr>
+            <a:fld id="{327921A4-25C4-3DB4-06B1-32693CEE2241}" type="slidenum">
+              <a:rPr sz="1400">
+                <a:latin typeface="Times New Roman"/>
+                <a:ea typeface="Times New Roman"/>
+                <a:cs typeface="Times New Roman"/>
+              </a:rPr>
+              <a:t>11</a:t>
+            </a:fld>
+            <a:endParaRPr sz="1400">
+              <a:latin typeface="Times New Roman"/>
+              <a:ea typeface="Times New Roman"/>
+              <a:cs typeface="Times New Roman"/>
+            </a:endParaRPr>
+          </a:p>
+        </p:txBody>
+      </p:sp>
+    </p:spTree>
+    <p:extLst>
+      <p:ext uri="{BB962C8B-B14F-4D97-AF65-F5344CB8AC3E}">
+        <p14:creationId xmlns:p14="http://schemas.microsoft.com/office/powerpoint/2010/main" val="3499234266"/>
+      </p:ext>
+    </p:extLst>
+  </p:cSld>
+  <p:clrMapOvr>
+    <a:masterClrMapping/>
+  </p:clrMapOvr>
+</p:sld>
+</file>
+
+<file path=ppt/slides/slide12.xml><?xml version="1.0" encoding="utf-8"?>
+<p:sld xmlns:a="http://schemas.openxmlformats.org/drawingml/2006/main" xmlns:r="http://schemas.openxmlformats.org/officeDocument/2006/relationships" xmlns:p="http://schemas.openxmlformats.org/presentationml/2006/main">
+  <p:cSld>
+    <p:spTree>
+      <p:nvGrpSpPr>
+        <p:cNvPr id="1" name=""/>
+        <p:cNvGrpSpPr/>
+        <p:nvPr/>
+      </p:nvGrpSpPr>
+      <p:grpSpPr>
+        <a:xfrm>
+          <a:off x="0" y="0"/>
+          <a:ext cx="0" cy="0"/>
+          <a:chOff x="0" y="0"/>
+          <a:chExt cx="0" cy="0"/>
+        </a:xfrm>
+      </p:grpSpPr>
+      <p:sp>
+        <p:nvSpPr>
+          <p:cNvPr id="2" name="標題 1">
+            <a:extLst>
+              <a:ext uri="{FF2B5EF4-FFF2-40B4-BE49-F238E27FC236}">
                 <a16:creationId xmlns:a16="http://schemas.microsoft.com/office/drawing/2014/main" id="{155386B2-4D86-418A-841B-0E5321F04EE6}"/>
               </a:ext>
             </a:extLst>
@@ -8125,7 +8538,7 @@
           <a:p>
             <a:r>
               <a:rPr lang="en-US" altLang="zh-TW" dirty="0"/>
-              <a:t>Steering Vector</a:t>
+              <a:t>Steering Vector Encodes Angle-Dependent Phase</a:t>
             </a:r>
             <a:endParaRPr lang="zh-TW" altLang="en-US" dirty="0"/>
           </a:p>
@@ -8154,31 +8567,7 @@
           <a:p>
             <a:r>
               <a:rPr lang="en-US" altLang="zh-TW" dirty="0"/>
-              <a:t>phase pattern across antenna array</a:t>
-            </a:r>
-            <a:r>
-              <a:rPr lang="zh-TW" altLang="en-US" dirty="0"/>
-              <a:t> </a:t>
-            </a:r>
-            <a:r>
-              <a:rPr lang="en-US" altLang="zh-TW" dirty="0"/>
-              <a:t>when signal arrives from</a:t>
-            </a:r>
-            <a:r>
-              <a:rPr lang="zh-TW" altLang="en-US" dirty="0"/>
-              <a:t> </a:t>
-            </a:r>
-            <a:r>
-              <a:rPr lang="en-US" altLang="zh-TW" dirty="0"/>
-              <a:t>specific angle</a:t>
-            </a:r>
-            <a:r>
-              <a:rPr lang="zh-TW" altLang="en-US" dirty="0"/>
-              <a:t> </a:t>
-            </a:r>
-            <a:r>
-              <a:rPr lang="el-GR" altLang="zh-TW" dirty="0"/>
-              <a:t>θ</a:t>
+              <a:t>Phase pattern across the antenna array when a signal arrives from angle θ</a:t>
             </a:r>
             <a:endParaRPr lang="zh-TW" altLang="en-US" sz="2400" dirty="0">
               <a:latin typeface="Calibri" panose="020F0502020204030204" pitchFamily="34" charset="0"/>
@@ -8188,23 +8577,7 @@
           <a:p>
             <a:r>
               <a:rPr lang="en-US" altLang="zh-TW" dirty="0"/>
-              <a:t>Physical origin</a:t>
-            </a:r>
-            <a:r>
-              <a:rPr lang="zh-TW" altLang="en-US" dirty="0"/>
-              <a:t> </a:t>
-            </a:r>
-            <a:r>
-              <a:rPr lang="en-US" altLang="zh-TW" dirty="0"/>
-              <a:t>from a plane wave reaches different antennas with different propagation distances </a:t>
-            </a:r>
-            <a:r>
-              <a:rPr lang="en-US" altLang="zh-TW" dirty="0" err="1"/>
-              <a:t>dsin</a:t>
-            </a:r>
-            <a:r>
-              <a:rPr lang="el-GR" altLang="zh-TW" dirty="0"/>
-              <a:t>θ</a:t>
+              <a:t>Plane waves reach antennas at different distances, creating a dsinθ path difference</a:t>
             </a:r>
             <a:endParaRPr lang="zh-TW" altLang="en-US" dirty="0"/>
           </a:p>
@@ -8240,7 +8613,7 @@
                 <a:ea typeface="Times New Roman"/>
                 <a:cs typeface="Times New Roman"/>
               </a:rPr>
-              <a:t>11</a:t>
+              <a:t>12</a:t>
             </a:fld>
             <a:endParaRPr lang="en-US" altLang="zh-TW" sz="1400">
               <a:latin typeface="Times New Roman"/>
@@ -8901,7 +9274,7 @@
 </p:sld>
 </file>
 
-<file path=ppt/slides/slide12.xml><?xml version="1.0" encoding="utf-8"?>
+<file path=ppt/slides/slide13.xml><?xml version="1.0" encoding="utf-8"?>
 <p:sld xmlns:a="http://schemas.openxmlformats.org/drawingml/2006/main" xmlns:r="http://schemas.openxmlformats.org/officeDocument/2006/relationships" xmlns:p="http://schemas.openxmlformats.org/presentationml/2006/main">
   <p:cSld>
     <p:spTree>
@@ -8941,7 +9314,7 @@
           <a:p>
             <a:r>
               <a:rPr lang="en-US" b="1" dirty="0"/>
-              <a:t>MUSIC</a:t>
+              <a:t>MUSIC for AoA Estimation</a:t>
             </a:r>
             <a:endParaRPr b="1" dirty="0"/>
           </a:p>
@@ -8970,180 +9343,32 @@
           <a:p>
             <a:r>
               <a:rPr dirty="0"/>
-              <a:t>Motivate MUSIC for Wi-Fi APs because it can use existing multi-antenna CSI, provide higher angular resolution than other </a:t>
-            </a:r>
-            <a:r>
-              <a:rPr lang="en-US" altLang="zh-TW" dirty="0"/>
-              <a:t>Spatial Spectrum Estimation algorithm </a:t>
-            </a:r>
+              <a:t>MUSIC uses existing multi-antenna CSI and can provide high angular resolution without extra localization hardware.</a:t>
+            </a:r>
+          </a:p>
+          <a:p>
+            <a:r>
+              <a:rPr lang="zh-TW" altLang="en-US" dirty="0"/>
+              <a:t>Each CSI snapshot is x_n; multiple snapshots form X = [x_0, x_1, ..., x_n].</a:t>
+            </a:r>
+            <a:endParaRPr lang="en-US" altLang="zh-TW" dirty="0"/>
+          </a:p>
+          <a:p>
+            <a:r>
+              <a:rPr lang="zh-TW" altLang="en-US" dirty="0"/>
+              <a:t>Compute the covariance matrix R_x = (1/n) X X^H.</a:t>
+            </a:r>
+          </a:p>
+          <a:p>
             <a:r>
               <a:rPr dirty="0"/>
-              <a:t>without extra localization hardware</a:t>
+              <a:t>Apply eigenvalue decomposition and use small-eigenvalue eigenvectors as the noise subspace.</a:t>
             </a:r>
           </a:p>
           <a:p>
             <a:r>
               <a:rPr lang="zh-TW" altLang="en-US" dirty="0"/>
-              <a:t>每一個收到的 </a:t>
-            </a:r>
-            <a:r>
-              <a:rPr lang="en-US" altLang="zh-TW" dirty="0"/>
-              <a:t>CSI</a:t>
-            </a:r>
-            <a:r>
-              <a:rPr lang="zh-TW" altLang="en-US" dirty="0"/>
-              <a:t> 是</a:t>
-            </a:r>
-            <a:r>
-              <a:rPr lang="en-US" altLang="zh-TW" dirty="0" err="1"/>
-              <a:t>X_n</a:t>
-            </a:r>
-            <a:r>
-              <a:rPr lang="en-US" altLang="zh-TW" dirty="0"/>
-              <a:t> </a:t>
-            </a:r>
-            <a:r>
-              <a:rPr lang="zh-TW" altLang="en-US" dirty="0"/>
-              <a:t>有多個 </a:t>
-            </a:r>
-            <a:r>
-              <a:rPr lang="en-US" altLang="zh-TW" dirty="0"/>
-              <a:t>snapshot =&gt;</a:t>
-            </a:r>
-            <a:r>
-              <a:rPr lang="zh-TW" altLang="en-US" dirty="0"/>
-              <a:t> </a:t>
-            </a:r>
-            <a:r>
-              <a:rPr lang="en-US" altLang="zh-TW" dirty="0"/>
-              <a:t>X</a:t>
-            </a:r>
-            <a:r>
-              <a:rPr lang="zh-TW" altLang="en-US" dirty="0"/>
-              <a:t> </a:t>
-            </a:r>
-            <a:r>
-              <a:rPr lang="en-US" altLang="zh-TW" dirty="0"/>
-              <a:t>=</a:t>
-            </a:r>
-            <a:r>
-              <a:rPr lang="zh-TW" altLang="en-US" dirty="0"/>
-              <a:t> </a:t>
-            </a:r>
-            <a:r>
-              <a:rPr lang="en-US" altLang="zh-TW" dirty="0"/>
-              <a:t>[X_0, X_1, … </a:t>
-            </a:r>
-            <a:r>
-              <a:rPr lang="en-US" altLang="zh-TW" dirty="0" err="1"/>
-              <a:t>X_n</a:t>
-            </a:r>
-            <a:r>
-              <a:rPr lang="en-US" altLang="zh-TW" dirty="0"/>
-              <a:t>] </a:t>
-            </a:r>
-            <a:r>
-              <a:rPr lang="zh-TW" altLang="en-US" dirty="0"/>
-              <a:t>是 </a:t>
-            </a:r>
-            <a:r>
-              <a:rPr lang="en-US" altLang="zh-TW" dirty="0"/>
-              <a:t>CSI Dimension * snapshot number </a:t>
-            </a:r>
-            <a:r>
-              <a:rPr lang="zh-TW" altLang="en-US" dirty="0"/>
-              <a:t>的矩陣</a:t>
-            </a:r>
-            <a:endParaRPr lang="en-US" altLang="zh-TW" dirty="0"/>
-          </a:p>
-          <a:p>
-            <a:r>
-              <a:rPr lang="zh-TW" altLang="en-US" dirty="0"/>
-              <a:t>做 </a:t>
-            </a:r>
-            <a:r>
-              <a:rPr lang="en-US" altLang="zh-TW" dirty="0"/>
-              <a:t>correlation Rx = 1/n X </a:t>
-            </a:r>
-            <a:r>
-              <a:rPr lang="en-US" altLang="zh-TW" dirty="0" err="1"/>
-              <a:t>X</a:t>
-            </a:r>
-            <a:r>
-              <a:rPr lang="en-US" altLang="zh-TW" dirty="0"/>
-              <a:t> ^H</a:t>
-            </a:r>
-          </a:p>
-          <a:p>
-            <a:r>
-              <a:rPr dirty="0"/>
-              <a:t>Rx</a:t>
-            </a:r>
-            <a:r>
-              <a:rPr lang="zh-TW" altLang="en-US" dirty="0"/>
-              <a:t> 做 </a:t>
-            </a:r>
-            <a:r>
-              <a:rPr lang="en-US" altLang="zh-TW" dirty="0"/>
-              <a:t>eigenvalue decomposition</a:t>
-            </a:r>
-            <a:r>
-              <a:rPr lang="zh-TW" altLang="en-US" dirty="0"/>
-              <a:t> 把 </a:t>
-            </a:r>
-            <a:r>
-              <a:rPr lang="en-US" altLang="zh-TW" dirty="0"/>
-              <a:t>eigen value </a:t>
-            </a:r>
-            <a:r>
-              <a:rPr lang="zh-TW" altLang="en-US" dirty="0"/>
-              <a:t>小的</a:t>
-            </a:r>
-            <a:r>
-              <a:rPr lang="en-US" altLang="zh-TW" dirty="0"/>
-              <a:t>eigen vector</a:t>
-            </a:r>
-            <a:r>
-              <a:rPr lang="zh-TW" altLang="en-US" dirty="0"/>
-              <a:t>挑出來當 </a:t>
-            </a:r>
-            <a:r>
-              <a:rPr lang="en-US" altLang="zh-TW" dirty="0"/>
-              <a:t>noise subspace </a:t>
-            </a:r>
-            <a:r>
-              <a:rPr lang="zh-TW" altLang="en-US" dirty="0"/>
-              <a:t>的 </a:t>
-            </a:r>
-            <a:r>
-              <a:rPr lang="en-US" altLang="zh-TW" dirty="0"/>
-              <a:t>base</a:t>
-            </a:r>
-          </a:p>
-          <a:p>
-            <a:r>
-              <a:rPr lang="zh-TW" altLang="en-US" dirty="0"/>
-              <a:t>每一個角度都會有自己的 </a:t>
-            </a:r>
-            <a:r>
-              <a:rPr lang="en-US" altLang="zh-TW" dirty="0"/>
-              <a:t>steering vector </a:t>
-            </a:r>
-            <a:r>
-              <a:rPr lang="zh-TW" altLang="en-US" dirty="0"/>
-              <a:t>每一個跟</a:t>
-            </a:r>
-            <a:r>
-              <a:rPr lang="en-US" altLang="zh-TW" dirty="0"/>
-              <a:t>noise subspace </a:t>
-            </a:r>
-            <a:r>
-              <a:rPr lang="zh-TW" altLang="en-US" dirty="0"/>
-              <a:t>比對有沒有正交 愈是正交愈可能是 </a:t>
-            </a:r>
-            <a:r>
-              <a:rPr lang="en-US" altLang="zh-TW" dirty="0" err="1"/>
-              <a:t>AoA</a:t>
+              <a:t>For each candidate angle, compare its steering vector with the noise subspace; the most orthogonal vector indicates the most likely AoA.</a:t>
             </a:r>
             <a:endParaRPr dirty="0"/>
           </a:p>
@@ -9179,7 +9404,7 @@
                 <a:ea typeface="Times New Roman"/>
                 <a:cs typeface="Times New Roman"/>
               </a:rPr>
-              <a:t>12</a:t>
+              <a:t>13</a:t>
             </a:fld>
             <a:endParaRPr sz="1400">
               <a:latin typeface="Times New Roman"/>
@@ -9202,7 +9427,7 @@
 </p:sld>
 </file>
 
-<file path=ppt/slides/slide13.xml><?xml version="1.0" encoding="utf-8"?>
+<file path=ppt/slides/slide14.xml><?xml version="1.0" encoding="utf-8"?>
 <p:sld xmlns:a="http://schemas.openxmlformats.org/drawingml/2006/main" xmlns:r="http://schemas.openxmlformats.org/officeDocument/2006/relationships" xmlns:p="http://schemas.openxmlformats.org/presentationml/2006/main" show="0">
   <p:cSld>
     <p:spTree>
@@ -9242,7 +9467,7 @@
           <a:p>
             <a:r>
               <a:rPr lang="en-US" altLang="zh-TW" dirty="0"/>
-              <a:t>Steer Vector Math Presentation  from antenna array</a:t>
+              <a:t>Steering Vector Math from the Antenna Array</a:t>
             </a:r>
             <a:endParaRPr lang="zh-TW" altLang="en-US" dirty="0"/>
           </a:p>
@@ -9339,7 +9564,7 @@
                 <a:ea typeface="Times New Roman"/>
                 <a:cs typeface="Times New Roman"/>
               </a:rPr>
-              <a:t>13</a:t>
+              <a:t>14</a:t>
             </a:fld>
             <a:endParaRPr lang="en-US" altLang="zh-TW" sz="1400">
               <a:latin typeface="Times New Roman"/>
@@ -10000,146 +10225,6 @@
 </p:sld>
 </file>
 
-<file path=ppt/slides/slide14.xml><?xml version="1.0" encoding="utf-8"?>
-<p:sld xmlns:a="http://schemas.openxmlformats.org/drawingml/2006/main" xmlns:r="http://schemas.openxmlformats.org/officeDocument/2006/relationships" xmlns:p="http://schemas.openxmlformats.org/presentationml/2006/main">
-  <p:cSld>
-    <p:spTree>
-      <p:nvGrpSpPr>
-        <p:cNvPr id="1" name=""/>
-        <p:cNvGrpSpPr/>
-        <p:nvPr/>
-      </p:nvGrpSpPr>
-      <p:grpSpPr>
-        <a:xfrm>
-          <a:off x="0" y="0"/>
-          <a:ext cx="0" cy="0"/>
-          <a:chOff x="0" y="0"/>
-          <a:chExt cx="0" cy="0"/>
-        </a:xfrm>
-      </p:grpSpPr>
-      <p:sp>
-        <p:nvSpPr>
-          <p:cNvPr id="2" name="標題 1">
-            <a:extLst>
-              <a:ext uri="{FF2B5EF4-FFF2-40B4-BE49-F238E27FC236}">
-                <a16:creationId xmlns:a16="http://schemas.microsoft.com/office/drawing/2014/main" id="{27A3B284-1CEC-47E9-98B8-BA58ABCB5210}"/>
-              </a:ext>
-            </a:extLst>
-          </p:cNvPr>
-          <p:cNvSpPr>
-            <a:spLocks noGrp="1"/>
-          </p:cNvSpPr>
-          <p:nvPr>
-            <p:ph type="title"/>
-          </p:nvPr>
-        </p:nvSpPr>
-        <p:spPr/>
-        <p:txBody>
-          <a:bodyPr/>
-          <a:lstStyle/>
-          <a:p>
-            <a:r>
-              <a:rPr lang="en-US" dirty="0"/>
-              <a:t>LRG1 Ability  for RTS threshold control and metric collection</a:t>
-            </a:r>
-          </a:p>
-        </p:txBody>
-      </p:sp>
-      <p:sp>
-        <p:nvSpPr>
-          <p:cNvPr id="3" name="內容版面配置區 2">
-            <a:extLst>
-              <a:ext uri="{FF2B5EF4-FFF2-40B4-BE49-F238E27FC236}">
-                <a16:creationId xmlns:a16="http://schemas.microsoft.com/office/drawing/2014/main" id="{85EB7868-0B10-4ADE-BF08-3CE42A258785}"/>
-              </a:ext>
-            </a:extLst>
-          </p:cNvPr>
-          <p:cNvSpPr>
-            <a:spLocks noGrp="1"/>
-          </p:cNvSpPr>
-          <p:nvPr>
-            <p:ph idx="1"/>
-          </p:nvPr>
-        </p:nvSpPr>
-        <p:spPr/>
-        <p:txBody>
-          <a:bodyPr/>
-          <a:lstStyle/>
-          <a:p>
-            <a:r>
-              <a:rPr dirty="0"/>
-              <a:t>Review the RTS threshold as the main AP-side control knob.</a:t>
-            </a:r>
-          </a:p>
-          <a:p>
-            <a:r>
-              <a:rPr dirty="0"/>
-              <a:t>Describe AP-side measurements, including retry statistics, RSSI, CSI, </a:t>
-            </a:r>
-            <a:r>
-              <a:rPr dirty="0" err="1"/>
-              <a:t>AoA</a:t>
-            </a:r>
-            <a:r>
-              <a:rPr dirty="0"/>
-              <a:t>, and MCS.</a:t>
-            </a:r>
-          </a:p>
-        </p:txBody>
-      </p:sp>
-      <p:sp>
-        <p:nvSpPr>
-          <p:cNvPr id="4" name="投影片編號版面配置區 3">
-            <a:extLst>
-              <a:ext uri="{FF2B5EF4-FFF2-40B4-BE49-F238E27FC236}">
-                <a16:creationId xmlns:a16="http://schemas.microsoft.com/office/drawing/2014/main" id="{C2FCD405-600C-462A-BF29-DAFF79456778}"/>
-              </a:ext>
-            </a:extLst>
-          </p:cNvPr>
-          <p:cNvSpPr>
-            <a:spLocks noGrp="1"/>
-          </p:cNvSpPr>
-          <p:nvPr>
-            <p:ph type="sldNum" idx="10"/>
-          </p:nvPr>
-        </p:nvSpPr>
-        <p:spPr/>
-        <p:txBody>
-          <a:bodyPr/>
-          <a:lstStyle/>
-          <a:p>
-            <a:pPr>
-              <a:buNone/>
-            </a:pPr>
-            <a:fld id="{30394428-F1DC-E5F6-DB0C-7DE31F3D8A23}" type="slidenum">
-              <a:rPr sz="1400">
-                <a:latin typeface="Times New Roman"/>
-                <a:ea typeface="Times New Roman"/>
-                <a:cs typeface="Times New Roman"/>
-              </a:rPr>
-              <a:t>14</a:t>
-            </a:fld>
-            <a:endParaRPr sz="1400">
-              <a:latin typeface="Times New Roman"/>
-              <a:ea typeface="Times New Roman"/>
-              <a:cs typeface="Times New Roman"/>
-            </a:endParaRPr>
-          </a:p>
-        </p:txBody>
-      </p:sp>
-    </p:spTree>
-    <p:extLst>
-      <p:ext uri="{BB962C8B-B14F-4D97-AF65-F5344CB8AC3E}">
-        <p14:creationId xmlns:p14="http://schemas.microsoft.com/office/powerpoint/2010/main" val="3499234266"/>
-      </p:ext>
-    </p:extLst>
-  </p:cSld>
-  <p:clrMapOvr>
-    <a:masterClrMapping/>
-  </p:clrMapOvr>
-</p:sld>
-</file>
-
 <file path=ppt/slides/slide15.xml><?xml version="1.0" encoding="utf-8"?>
 <p:sld xmlns:a="http://schemas.openxmlformats.org/drawingml/2006/main" xmlns:r="http://schemas.openxmlformats.org/officeDocument/2006/relationships" xmlns:p="http://schemas.openxmlformats.org/presentationml/2006/main">
   <p:cSld>
@@ -10159,10 +10244,10 @@
       </p:grpSpPr>
       <p:sp>
         <p:nvSpPr>
-          <p:cNvPr id="2" name="?蔣?楊???ａ?蝵桀? 1">
+          <p:cNvPr id="2" name="標題 1">
             <a:extLst>
               <a:ext uri="{FF2B5EF4-FFF2-40B4-BE49-F238E27FC236}">
-                <a16:creationId xmlns:a16="http://schemas.microsoft.com/office/drawing/2014/main" id="{7C687AF8-AF63-1728-2C7B-76B8DC1837DE}"/>
+                <a16:creationId xmlns:a16="http://schemas.microsoft.com/office/drawing/2014/main" id="{27A3B284-1CEC-47E9-98B8-BA58ABCB5210}"/>
               </a:ext>
             </a:extLst>
           </p:cNvPr>
@@ -10170,6 +10255,68 @@
             <a:spLocks noGrp="1"/>
           </p:cNvSpPr>
           <p:nvPr>
+            <p:ph type="title"/>
+          </p:nvPr>
+        </p:nvSpPr>
+        <p:spPr/>
+        <p:txBody>
+          <a:bodyPr/>
+          <a:lstStyle/>
+          <a:p>
+            <a:r>
+              <a:rPr lang="en-US" dirty="0"/>
+              <a:t>LRG1 Provides AP-Side Control and Measurements</a:t>
+            </a:r>
+          </a:p>
+        </p:txBody>
+      </p:sp>
+      <p:sp>
+        <p:nvSpPr>
+          <p:cNvPr id="3" name="內容版面配置區 2">
+            <a:extLst>
+              <a:ext uri="{FF2B5EF4-FFF2-40B4-BE49-F238E27FC236}">
+                <a16:creationId xmlns:a16="http://schemas.microsoft.com/office/drawing/2014/main" id="{85EB7868-0B10-4ADE-BF08-3CE42A258785}"/>
+              </a:ext>
+            </a:extLst>
+          </p:cNvPr>
+          <p:cNvSpPr>
+            <a:spLocks noGrp="1"/>
+          </p:cNvSpPr>
+          <p:nvPr>
+            <p:ph idx="1"/>
+          </p:nvPr>
+        </p:nvSpPr>
+        <p:spPr/>
+        <p:txBody>
+          <a:bodyPr/>
+          <a:lstStyle/>
+          <a:p>
+            <a:r>
+              <a:rPr dirty="0"/>
+              <a:t>LRG1 exposes the RTS threshold as the main AP-side control knob.</a:t>
+            </a:r>
+          </a:p>
+          <a:p>
+            <a:r>
+              <a:rPr dirty="0"/>
+              <a:t>AP-side measurements include retry statistics, RSSI, CSI, AoA, and MCS.</a:t>
+            </a:r>
+          </a:p>
+        </p:txBody>
+      </p:sp>
+      <p:sp>
+        <p:nvSpPr>
+          <p:cNvPr id="4" name="投影片編號版面配置區 3">
+            <a:extLst>
+              <a:ext uri="{FF2B5EF4-FFF2-40B4-BE49-F238E27FC236}">
+                <a16:creationId xmlns:a16="http://schemas.microsoft.com/office/drawing/2014/main" id="{C2FCD405-600C-462A-BF29-DAFF79456778}"/>
+              </a:ext>
+            </a:extLst>
+          </p:cNvPr>
+          <p:cNvSpPr>
+            <a:spLocks noGrp="1"/>
+          </p:cNvSpPr>
+          <p:nvPr>
             <p:ph type="sldNum" idx="10"/>
           </p:nvPr>
         </p:nvSpPr>
@@ -10181,7 +10328,7 @@
             <a:pPr>
               <a:buNone/>
             </a:pPr>
-            <a:fld id="{B1C6C81E-38B9-7560-621D-5A151A79DF9B}" type="slidenum">
+            <a:fld id="{30394428-F1DC-E5F6-DB0C-7DE31F3D8A23}" type="slidenum">
               <a:rPr sz="1400">
                 <a:latin typeface="Times New Roman"/>
                 <a:ea typeface="Times New Roman"/>
@@ -10197,131 +10344,10 @@
           </a:p>
         </p:txBody>
       </p:sp>
-      <p:sp>
-        <p:nvSpPr>
-          <p:cNvPr id="3" name="?批捆??蔭? 2">
-            <a:extLst>
-              <a:ext uri="{FF2B5EF4-FFF2-40B4-BE49-F238E27FC236}">
-                <a16:creationId xmlns:a16="http://schemas.microsoft.com/office/drawing/2014/main" id="{EFDF35B5-B6BD-325F-B271-EE42028230F3}"/>
-              </a:ext>
-            </a:extLst>
-          </p:cNvPr>
-          <p:cNvSpPr>
-            <a:spLocks noGrp="1"/>
-          </p:cNvSpPr>
-          <p:nvPr>
-            <p:ph idx="1"/>
-          </p:nvPr>
-        </p:nvSpPr>
-        <p:spPr/>
-        <p:txBody>
-          <a:bodyPr/>
-          <a:lstStyle/>
-          <a:p>
-            <a:r>
-              <a:rPr dirty="0">
-                <a:solidFill>
-                  <a:schemeClr val="bg1">
-                    <a:lumMod val="50000"/>
-                  </a:schemeClr>
-                </a:solidFill>
-              </a:rPr>
-              <a:t>Introduction</a:t>
-            </a:r>
-          </a:p>
-          <a:p>
-            <a:r>
-              <a:rPr dirty="0">
-                <a:solidFill>
-                  <a:schemeClr val="bg1">
-                    <a:lumMod val="50000"/>
-                  </a:schemeClr>
-                </a:solidFill>
-              </a:rPr>
-              <a:t>Background</a:t>
-            </a:r>
-          </a:p>
-          <a:p>
-            <a:r>
-              <a:rPr dirty="0" err="1"/>
-              <a:t>AoA</a:t>
-            </a:r>
-            <a:r>
-              <a:rPr dirty="0"/>
-              <a:t>-Assisted Risk Score and RTS</a:t>
-            </a:r>
-            <a:r>
-              <a:rPr dirty="0">
-                <a:solidFill>
-                  <a:schemeClr val="bg1">
-                    <a:lumMod val="50000"/>
-                  </a:schemeClr>
-                </a:solidFill>
-              </a:rPr>
-              <a:t> </a:t>
-            </a:r>
-            <a:r>
-              <a:rPr dirty="0"/>
-              <a:t>Threshold Adaptation</a:t>
-            </a:r>
-          </a:p>
-          <a:p>
-            <a:r>
-              <a:rPr dirty="0">
-                <a:solidFill>
-                  <a:schemeClr val="bg1">
-                    <a:lumMod val="50000"/>
-                  </a:schemeClr>
-                </a:solidFill>
-              </a:rPr>
-              <a:t>Evaluation</a:t>
-            </a:r>
-          </a:p>
-          <a:p>
-            <a:r>
-              <a:rPr dirty="0">
-                <a:solidFill>
-                  <a:schemeClr val="bg1">
-                    <a:lumMod val="50000"/>
-                  </a:schemeClr>
-                </a:solidFill>
-              </a:rPr>
-              <a:t>Conclusion</a:t>
-            </a:r>
-          </a:p>
-        </p:txBody>
-      </p:sp>
-      <p:sp>
-        <p:nvSpPr>
-          <p:cNvPr id="4" name="璅? 3">
-            <a:extLst>
-              <a:ext uri="{FF2B5EF4-FFF2-40B4-BE49-F238E27FC236}">
-                <a16:creationId xmlns:a16="http://schemas.microsoft.com/office/drawing/2014/main" id="{363B54DA-5A57-63A3-3957-4A5B100F1AAB}"/>
-              </a:ext>
-            </a:extLst>
-          </p:cNvPr>
-          <p:cNvSpPr>
-            <a:spLocks noGrp="1"/>
-          </p:cNvSpPr>
-          <p:nvPr>
-            <p:ph type="title"/>
-          </p:nvPr>
-        </p:nvSpPr>
-        <p:spPr/>
-        <p:txBody>
-          <a:bodyPr/>
-          <a:lstStyle/>
-          <a:p>
-            <a:r>
-              <a:t>Outline</a:t>
-            </a:r>
-          </a:p>
-        </p:txBody>
-      </p:sp>
     </p:spTree>
     <p:extLst>
       <p:ext uri="{BB962C8B-B14F-4D97-AF65-F5344CB8AC3E}">
-        <p14:creationId xmlns:p14="http://schemas.microsoft.com/office/powerpoint/2010/main" val="2663263701"/>
+        <p14:creationId xmlns:p14="http://schemas.microsoft.com/office/powerpoint/2010/main" val="3499234266"/>
       </p:ext>
     </p:extLst>
   </p:cSld>
@@ -10350,10 +10376,10 @@
       </p:grpSpPr>
       <p:sp>
         <p:nvSpPr>
-          <p:cNvPr id="2" name="標題 1">
+          <p:cNvPr id="2" name="?蔣?楊???ａ?蝵桀? 1">
             <a:extLst>
               <a:ext uri="{FF2B5EF4-FFF2-40B4-BE49-F238E27FC236}">
-                <a16:creationId xmlns:a16="http://schemas.microsoft.com/office/drawing/2014/main" id="{27A3B284-1CEC-47E9-98B8-BA58ABCB5210}"/>
+                <a16:creationId xmlns:a16="http://schemas.microsoft.com/office/drawing/2014/main" id="{7C687AF8-AF63-1728-2C7B-76B8DC1837DE}"/>
               </a:ext>
             </a:extLst>
           </p:cNvPr>
@@ -10361,66 +10387,6 @@
             <a:spLocks noGrp="1"/>
           </p:cNvSpPr>
           <p:nvPr>
-            <p:ph type="title"/>
-          </p:nvPr>
-        </p:nvSpPr>
-        <p:spPr/>
-        <p:txBody>
-          <a:bodyPr/>
-          <a:lstStyle/>
-          <a:p>
-            <a:r>
-              <a:rPr b="1"/>
-              <a:t>Risk scoring design goal</a:t>
-            </a:r>
-          </a:p>
-        </p:txBody>
-      </p:sp>
-      <p:sp>
-        <p:nvSpPr>
-          <p:cNvPr id="3" name="內容版面配置區 2">
-            <a:extLst>
-              <a:ext uri="{FF2B5EF4-FFF2-40B4-BE49-F238E27FC236}">
-                <a16:creationId xmlns:a16="http://schemas.microsoft.com/office/drawing/2014/main" id="{85EB7868-0B10-4ADE-BF08-3CE42A258785}"/>
-              </a:ext>
-            </a:extLst>
-          </p:cNvPr>
-          <p:cNvSpPr>
-            <a:spLocks noGrp="1"/>
-          </p:cNvSpPr>
-          <p:nvPr>
-            <p:ph idx="1"/>
-          </p:nvPr>
-        </p:nvSpPr>
-        <p:spPr/>
-        <p:txBody>
-          <a:bodyPr/>
-          <a:lstStyle/>
-          <a:p>
-            <a:r>
-              <a:t>Present the overall design goal: use AP-side AoA and link observations to decide when RTS/CTS overhead is worthwhile.</a:t>
-            </a:r>
-          </a:p>
-          <a:p>
-            <a:r>
-              <a:t>Define the hidden-node risk score as the core decision variable for RTS threshold control.</a:t>
-            </a:r>
-          </a:p>
-        </p:txBody>
-      </p:sp>
-      <p:sp>
-        <p:nvSpPr>
-          <p:cNvPr id="4" name="投影片編號版面配置區 3">
-            <a:extLst>
-              <a:ext uri="{FF2B5EF4-FFF2-40B4-BE49-F238E27FC236}">
-                <a16:creationId xmlns:a16="http://schemas.microsoft.com/office/drawing/2014/main" id="{C2FCD405-600C-462A-BF29-DAFF79456778}"/>
-              </a:ext>
-            </a:extLst>
-          </p:cNvPr>
-          <p:cNvSpPr>
-            <a:spLocks noGrp="1"/>
-          </p:cNvSpPr>
-          <p:nvPr>
             <p:ph type="sldNum" idx="10"/>
           </p:nvPr>
         </p:nvSpPr>
@@ -10432,7 +10398,7 @@
             <a:pPr>
               <a:buNone/>
             </a:pPr>
-            <a:fld id="{CCF91274-D221-1BB4-3BF9-836E3AD31EBE}" type="slidenum">
+            <a:fld id="{B1C6C81E-38B9-7560-621D-5A151A79DF9B}" type="slidenum">
               <a:rPr sz="1400">
                 <a:latin typeface="Times New Roman"/>
                 <a:ea typeface="Times New Roman"/>
@@ -10448,10 +10414,113 @@
           </a:p>
         </p:txBody>
       </p:sp>
+      <p:sp>
+        <p:nvSpPr>
+          <p:cNvPr id="3" name="?批捆??蔭? 2">
+            <a:extLst>
+              <a:ext uri="{FF2B5EF4-FFF2-40B4-BE49-F238E27FC236}">
+                <a16:creationId xmlns:a16="http://schemas.microsoft.com/office/drawing/2014/main" id="{EFDF35B5-B6BD-325F-B271-EE42028230F3}"/>
+              </a:ext>
+            </a:extLst>
+          </p:cNvPr>
+          <p:cNvSpPr>
+            <a:spLocks noGrp="1"/>
+          </p:cNvSpPr>
+          <p:nvPr>
+            <p:ph idx="1"/>
+          </p:nvPr>
+        </p:nvSpPr>
+        <p:spPr/>
+        <p:txBody>
+          <a:bodyPr/>
+          <a:lstStyle/>
+          <a:p>
+            <a:r>
+              <a:rPr dirty="0">
+                <a:solidFill>
+                  <a:schemeClr val="bg1">
+                    <a:lumMod val="50000"/>
+                  </a:schemeClr>
+                </a:solidFill>
+              </a:rPr>
+              <a:t>Introduction</a:t>
+            </a:r>
+          </a:p>
+          <a:p>
+            <a:r>
+              <a:rPr dirty="0">
+                <a:solidFill>
+                  <a:schemeClr val="bg1">
+                    <a:lumMod val="50000"/>
+                  </a:schemeClr>
+                </a:solidFill>
+              </a:rPr>
+              <a:t>Background</a:t>
+            </a:r>
+          </a:p>
+          <a:p>
+            <a:r>
+              <a:rPr dirty="0" err="1"/>
+              <a:t>AoA-Assisted Risk Score and RTS Threshold Adaptation</a:t>
+            </a:r>
+          </a:p>
+          <a:p>
+            <a:r>
+              <a:rPr dirty="0">
+                <a:solidFill>
+                  <a:schemeClr val="bg1">
+                    <a:lumMod val="50000"/>
+                  </a:schemeClr>
+                </a:solidFill>
+              </a:rPr>
+              <a:t>Evaluation</a:t>
+            </a:r>
+          </a:p>
+          <a:p>
+            <a:r>
+              <a:rPr dirty="0">
+                <a:solidFill>
+                  <a:schemeClr val="bg1">
+                    <a:lumMod val="50000"/>
+                  </a:schemeClr>
+                </a:solidFill>
+              </a:rPr>
+              <a:t>Conclusion</a:t>
+            </a:r>
+          </a:p>
+        </p:txBody>
+      </p:sp>
+      <p:sp>
+        <p:nvSpPr>
+          <p:cNvPr id="4" name="璅? 3">
+            <a:extLst>
+              <a:ext uri="{FF2B5EF4-FFF2-40B4-BE49-F238E27FC236}">
+                <a16:creationId xmlns:a16="http://schemas.microsoft.com/office/drawing/2014/main" id="{363B54DA-5A57-63A3-3957-4A5B100F1AAB}"/>
+              </a:ext>
+            </a:extLst>
+          </p:cNvPr>
+          <p:cNvSpPr>
+            <a:spLocks noGrp="1"/>
+          </p:cNvSpPr>
+          <p:nvPr>
+            <p:ph type="title"/>
+          </p:nvPr>
+        </p:nvSpPr>
+        <p:spPr/>
+        <p:txBody>
+          <a:bodyPr/>
+          <a:lstStyle/>
+          <a:p>
+            <a:r>
+              <a:t>Outline</a:t>
+            </a:r>
+          </a:p>
+        </p:txBody>
+      </p:sp>
     </p:spTree>
     <p:extLst>
       <p:ext uri="{BB962C8B-B14F-4D97-AF65-F5344CB8AC3E}">
-        <p14:creationId xmlns:p14="http://schemas.microsoft.com/office/powerpoint/2010/main" val="3499234266"/>
+        <p14:creationId xmlns:p14="http://schemas.microsoft.com/office/powerpoint/2010/main" val="2663263701"/>
       </p:ext>
     </p:extLst>
   </p:cSld>
@@ -10501,7 +10570,7 @@
           <a:p>
             <a:r>
               <a:rPr b="1"/>
-              <a:t>AoA and link features for hidden-node risk</a:t>
+              <a:t>Risk Score Guides RTS Threshold Decisions</a:t>
             </a:r>
           </a:p>
         </p:txBody>
@@ -10528,12 +10597,12 @@
           <a:lstStyle/>
           <a:p>
             <a:r>
-              <a:t>Use AoA estimates from AP-side multi-antenna CSI as the main spatial feature for judging whether two clients are likely to be hidden from each other.</a:t>
-            </a:r>
-          </a:p>
-          <a:p>
-            <a:r>
-              <a:t>Combine AoA-based spatial separation with retry behavior, RSSI, MCS, and traffic activity so the score reflects both geometry and observed collision symptoms.</a:t>
+              <a:t>The AP uses AoA and link observations to decide when RTS/CTS overhead is worthwhile.</a:t>
+            </a:r>
+          </a:p>
+          <a:p>
+            <a:r>
+              <a:t>The hidden-node risk score becomes the decision variable for RTS threshold control.</a:t>
             </a:r>
           </a:p>
         </p:txBody>
@@ -10562,7 +10631,7 @@
             <a:pPr>
               <a:buNone/>
             </a:pPr>
-            <a:fld id="{844E025A-983C-6D44-79C6-4612AACD43FC}" type="slidenum">
+            <a:fld id="{CCF91274-D221-1BB4-3BF9-836E3AD31EBE}" type="slidenum">
               <a:rPr sz="1400">
                 <a:latin typeface="Times New Roman"/>
                 <a:ea typeface="Times New Roman"/>
@@ -10631,7 +10700,7 @@
           <a:p>
             <a:r>
               <a:rPr b="1"/>
-              <a:t>RTS threshold adaptation rule</a:t>
+              <a:t>AoA and Link Features Capture Hidden-Node Risk</a:t>
             </a:r>
           </a:p>
         </p:txBody>
@@ -10658,12 +10727,12 @@
           <a:lstStyle/>
           <a:p>
             <a:r>
-              <a:t>Present the RTS threshold adaptation rule: lower the threshold when hidden-node risk is high, and restore or raise it when risk is low to avoid unnecessary RTS/CTS overhead.</a:t>
-            </a:r>
-          </a:p>
-          <a:p>
-            <a:r>
-              <a:t>Include smoothing and hysteresis so the RTS threshold does not oscillate under noisy AoA or retry measurements.</a:t>
+              <a:t>AoA estimates from AP-side multi-antenna CSI provide the main spatial feature for hidden-node risk.</a:t>
+            </a:r>
+          </a:p>
+          <a:p>
+            <a:r>
+              <a:t>The score combines AoA separation with retries, RSSI, MCS, and traffic activity to reflect geometry and collision symptoms.</a:t>
             </a:r>
           </a:p>
         </p:txBody>
@@ -10692,7 +10761,7 @@
             <a:pPr>
               <a:buNone/>
             </a:pPr>
-            <a:fld id="{0BB18BA8-60F4-C50D-CD9B-1BB87D3E8506}" type="slidenum">
+            <a:fld id="{844E025A-983C-6D44-79C6-4612AACD43FC}" type="slidenum">
               <a:rPr sz="1400">
                 <a:latin typeface="Times New Roman"/>
                 <a:ea typeface="Times New Roman"/>
@@ -10740,10 +10809,10 @@
       </p:grpSpPr>
       <p:sp>
         <p:nvSpPr>
-          <p:cNvPr id="2" name="?蔣?楊???ａ?蝵桀? 1">
+          <p:cNvPr id="2" name="標題 1">
             <a:extLst>
               <a:ext uri="{FF2B5EF4-FFF2-40B4-BE49-F238E27FC236}">
-                <a16:creationId xmlns:a16="http://schemas.microsoft.com/office/drawing/2014/main" id="{7C687AF8-AF63-1728-2C7B-76B8DC1837DE}"/>
+                <a16:creationId xmlns:a16="http://schemas.microsoft.com/office/drawing/2014/main" id="{27A3B284-1CEC-47E9-98B8-BA58ABCB5210}"/>
               </a:ext>
             </a:extLst>
           </p:cNvPr>
@@ -10751,6 +10820,66 @@
             <a:spLocks noGrp="1"/>
           </p:cNvSpPr>
           <p:nvPr>
+            <p:ph type="title"/>
+          </p:nvPr>
+        </p:nvSpPr>
+        <p:spPr/>
+        <p:txBody>
+          <a:bodyPr/>
+          <a:lstStyle/>
+          <a:p>
+            <a:r>
+              <a:rPr b="1"/>
+              <a:t>RTS Threshold Adapts to Risk</a:t>
+            </a:r>
+          </a:p>
+        </p:txBody>
+      </p:sp>
+      <p:sp>
+        <p:nvSpPr>
+          <p:cNvPr id="3" name="內容版面配置區 2">
+            <a:extLst>
+              <a:ext uri="{FF2B5EF4-FFF2-40B4-BE49-F238E27FC236}">
+                <a16:creationId xmlns:a16="http://schemas.microsoft.com/office/drawing/2014/main" id="{85EB7868-0B10-4ADE-BF08-3CE42A258785}"/>
+              </a:ext>
+            </a:extLst>
+          </p:cNvPr>
+          <p:cNvSpPr>
+            <a:spLocks noGrp="1"/>
+          </p:cNvSpPr>
+          <p:nvPr>
+            <p:ph idx="1"/>
+          </p:nvPr>
+        </p:nvSpPr>
+        <p:spPr/>
+        <p:txBody>
+          <a:bodyPr/>
+          <a:lstStyle/>
+          <a:p>
+            <a:r>
+              <a:t>Lower the threshold when hidden-node risk is high; restore or raise it when risk is low.</a:t>
+            </a:r>
+          </a:p>
+          <a:p>
+            <a:r>
+              <a:t>Smoothing and hysteresis prevent oscillation under noisy AoA or retry measurements.</a:t>
+            </a:r>
+          </a:p>
+        </p:txBody>
+      </p:sp>
+      <p:sp>
+        <p:nvSpPr>
+          <p:cNvPr id="4" name="投影片編號版面配置區 3">
+            <a:extLst>
+              <a:ext uri="{FF2B5EF4-FFF2-40B4-BE49-F238E27FC236}">
+                <a16:creationId xmlns:a16="http://schemas.microsoft.com/office/drawing/2014/main" id="{C2FCD405-600C-462A-BF29-DAFF79456778}"/>
+              </a:ext>
+            </a:extLst>
+          </p:cNvPr>
+          <p:cNvSpPr>
+            <a:spLocks noGrp="1"/>
+          </p:cNvSpPr>
+          <p:nvPr>
             <p:ph type="sldNum" idx="10"/>
           </p:nvPr>
         </p:nvSpPr>
@@ -10762,7 +10891,7 @@
             <a:pPr>
               <a:buNone/>
             </a:pPr>
-            <a:fld id="{F3AE1AE4-D79E-94D6-E825-3FC6C21A77D2}" type="slidenum">
+            <a:fld id="{0BB18BA8-60F4-C50D-CD9B-1BB87D3E8506}" type="slidenum">
               <a:rPr sz="1400">
                 <a:latin typeface="Times New Roman"/>
                 <a:ea typeface="Times New Roman"/>
@@ -10778,123 +10907,10 @@
           </a:p>
         </p:txBody>
       </p:sp>
-      <p:sp>
-        <p:nvSpPr>
-          <p:cNvPr id="3" name="?批捆??蔭? 2">
-            <a:extLst>
-              <a:ext uri="{FF2B5EF4-FFF2-40B4-BE49-F238E27FC236}">
-                <a16:creationId xmlns:a16="http://schemas.microsoft.com/office/drawing/2014/main" id="{EFDF35B5-B6BD-325F-B271-EE42028230F3}"/>
-              </a:ext>
-            </a:extLst>
-          </p:cNvPr>
-          <p:cNvSpPr>
-            <a:spLocks noGrp="1"/>
-          </p:cNvSpPr>
-          <p:nvPr>
-            <p:ph idx="1"/>
-          </p:nvPr>
-        </p:nvSpPr>
-        <p:spPr/>
-        <p:txBody>
-          <a:bodyPr/>
-          <a:lstStyle/>
-          <a:p>
-            <a:r>
-              <a:rPr dirty="0">
-                <a:solidFill>
-                  <a:schemeClr val="bg1">
-                    <a:lumMod val="50000"/>
-                  </a:schemeClr>
-                </a:solidFill>
-              </a:rPr>
-              <a:t>Introduction</a:t>
-            </a:r>
-          </a:p>
-          <a:p>
-            <a:r>
-              <a:rPr dirty="0">
-                <a:solidFill>
-                  <a:schemeClr val="bg1">
-                    <a:lumMod val="50000"/>
-                  </a:schemeClr>
-                </a:solidFill>
-              </a:rPr>
-              <a:t>Background</a:t>
-            </a:r>
-          </a:p>
-          <a:p>
-            <a:r>
-              <a:rPr dirty="0" err="1">
-                <a:solidFill>
-                  <a:schemeClr val="bg1">
-                    <a:lumMod val="50000"/>
-                  </a:schemeClr>
-                </a:solidFill>
-              </a:rPr>
-              <a:t>AoA</a:t>
-            </a:r>
-            <a:r>
-              <a:rPr dirty="0">
-                <a:solidFill>
-                  <a:schemeClr val="bg1">
-                    <a:lumMod val="50000"/>
-                  </a:schemeClr>
-                </a:solidFill>
-              </a:rPr>
-              <a:t>-Assisted Risk Score and RTS Threshold Adaptation</a:t>
-            </a:r>
-          </a:p>
-          <a:p>
-            <a:r>
-              <a:rPr dirty="0"/>
-              <a:t>Evaluation</a:t>
-            </a:r>
-          </a:p>
-          <a:p>
-            <a:r>
-              <a:rPr dirty="0">
-                <a:solidFill>
-                  <a:schemeClr val="bg1">
-                    <a:lumMod val="50000"/>
-                  </a:schemeClr>
-                </a:solidFill>
-              </a:rPr>
-              <a:t>Conclusion</a:t>
-            </a:r>
-          </a:p>
-        </p:txBody>
-      </p:sp>
-      <p:sp>
-        <p:nvSpPr>
-          <p:cNvPr id="4" name="璅? 3">
-            <a:extLst>
-              <a:ext uri="{FF2B5EF4-FFF2-40B4-BE49-F238E27FC236}">
-                <a16:creationId xmlns:a16="http://schemas.microsoft.com/office/drawing/2014/main" id="{363B54DA-5A57-63A3-3957-4A5B100F1AAB}"/>
-              </a:ext>
-            </a:extLst>
-          </p:cNvPr>
-          <p:cNvSpPr>
-            <a:spLocks noGrp="1"/>
-          </p:cNvSpPr>
-          <p:nvPr>
-            <p:ph type="title"/>
-          </p:nvPr>
-        </p:nvSpPr>
-        <p:spPr/>
-        <p:txBody>
-          <a:bodyPr/>
-          <a:lstStyle/>
-          <a:p>
-            <a:r>
-              <a:t>Outline</a:t>
-            </a:r>
-          </a:p>
-        </p:txBody>
-      </p:sp>
     </p:spTree>
     <p:extLst>
       <p:ext uri="{BB962C8B-B14F-4D97-AF65-F5344CB8AC3E}">
-        <p14:creationId xmlns:p14="http://schemas.microsoft.com/office/powerpoint/2010/main" val="346352892"/>
+        <p14:creationId xmlns:p14="http://schemas.microsoft.com/office/powerpoint/2010/main" val="3499234266"/>
       </p:ext>
     </p:extLst>
   </p:cSld>
@@ -11076,10 +11092,10 @@
       </p:grpSpPr>
       <p:sp>
         <p:nvSpPr>
-          <p:cNvPr id="2" name="標題 1">
+          <p:cNvPr id="2" name="?蔣?楊???ａ?蝵桀? 1">
             <a:extLst>
               <a:ext uri="{FF2B5EF4-FFF2-40B4-BE49-F238E27FC236}">
-                <a16:creationId xmlns:a16="http://schemas.microsoft.com/office/drawing/2014/main" id="{27A3B284-1CEC-47E9-98B8-BA58ABCB5210}"/>
+                <a16:creationId xmlns:a16="http://schemas.microsoft.com/office/drawing/2014/main" id="{7C687AF8-AF63-1728-2C7B-76B8DC1837DE}"/>
               </a:ext>
             </a:extLst>
           </p:cNvPr>
@@ -11087,71 +11103,6 @@
             <a:spLocks noGrp="1"/>
           </p:cNvSpPr>
           <p:nvPr>
-            <p:ph type="title"/>
-          </p:nvPr>
-        </p:nvSpPr>
-        <p:spPr/>
-        <p:txBody>
-          <a:bodyPr/>
-          <a:lstStyle/>
-          <a:p>
-            <a:r>
-              <a:rPr b="1"/>
-              <a:t>Evaluation scenarios, baselines, and metrics</a:t>
-            </a:r>
-          </a:p>
-        </p:txBody>
-      </p:sp>
-      <p:sp>
-        <p:nvSpPr>
-          <p:cNvPr id="3" name="內容版面配置區 2">
-            <a:extLst>
-              <a:ext uri="{FF2B5EF4-FFF2-40B4-BE49-F238E27FC236}">
-                <a16:creationId xmlns:a16="http://schemas.microsoft.com/office/drawing/2014/main" id="{85EB7868-0B10-4ADE-BF08-3CE42A258785}"/>
-              </a:ext>
-            </a:extLst>
-          </p:cNvPr>
-          <p:cNvSpPr>
-            <a:spLocks noGrp="1"/>
-          </p:cNvSpPr>
-          <p:nvPr>
-            <p:ph idx="1"/>
-          </p:nvPr>
-        </p:nvSpPr>
-        <p:spPr/>
-        <p:txBody>
-          <a:bodyPr/>
-          <a:lstStyle/>
-          <a:p>
-            <a:r>
-              <a:t>Define test scenarios for hidden-node and non-hidden-node conditions.</a:t>
-            </a:r>
-          </a:p>
-          <a:p>
-            <a:r>
-              <a:t>Compare static RTS/CTS settings with the proposed AoA-assisted dynamic RTS threshold policy.</a:t>
-            </a:r>
-          </a:p>
-          <a:p>
-            <a:r>
-              <a:t>Measure throughput, retry rate, latency, MCS distribution, and fairness.</a:t>
-            </a:r>
-          </a:p>
-        </p:txBody>
-      </p:sp>
-      <p:sp>
-        <p:nvSpPr>
-          <p:cNvPr id="4" name="投影片編號版面配置區 3">
-            <a:extLst>
-              <a:ext uri="{FF2B5EF4-FFF2-40B4-BE49-F238E27FC236}">
-                <a16:creationId xmlns:a16="http://schemas.microsoft.com/office/drawing/2014/main" id="{C2FCD405-600C-462A-BF29-DAFF79456778}"/>
-              </a:ext>
-            </a:extLst>
-          </p:cNvPr>
-          <p:cNvSpPr>
-            <a:spLocks noGrp="1"/>
-          </p:cNvSpPr>
-          <p:nvPr>
             <p:ph type="sldNum" idx="10"/>
           </p:nvPr>
         </p:nvSpPr>
@@ -11163,7 +11114,7 @@
             <a:pPr>
               <a:buNone/>
             </a:pPr>
-            <a:fld id="{5AB55966-FA28-BC73-EA9E-53DF014DF033}" type="slidenum">
+            <a:fld id="{F3AE1AE4-D79E-94D6-E825-3FC6C21A77D2}" type="slidenum">
               <a:rPr sz="1400">
                 <a:latin typeface="Times New Roman"/>
                 <a:ea typeface="Times New Roman"/>
@@ -11179,10 +11130,123 @@
           </a:p>
         </p:txBody>
       </p:sp>
+      <p:sp>
+        <p:nvSpPr>
+          <p:cNvPr id="3" name="?批捆??蔭? 2">
+            <a:extLst>
+              <a:ext uri="{FF2B5EF4-FFF2-40B4-BE49-F238E27FC236}">
+                <a16:creationId xmlns:a16="http://schemas.microsoft.com/office/drawing/2014/main" id="{EFDF35B5-B6BD-325F-B271-EE42028230F3}"/>
+              </a:ext>
+            </a:extLst>
+          </p:cNvPr>
+          <p:cNvSpPr>
+            <a:spLocks noGrp="1"/>
+          </p:cNvSpPr>
+          <p:nvPr>
+            <p:ph idx="1"/>
+          </p:nvPr>
+        </p:nvSpPr>
+        <p:spPr/>
+        <p:txBody>
+          <a:bodyPr/>
+          <a:lstStyle/>
+          <a:p>
+            <a:r>
+              <a:rPr dirty="0">
+                <a:solidFill>
+                  <a:schemeClr val="bg1">
+                    <a:lumMod val="50000"/>
+                  </a:schemeClr>
+                </a:solidFill>
+              </a:rPr>
+              <a:t>Introduction</a:t>
+            </a:r>
+          </a:p>
+          <a:p>
+            <a:r>
+              <a:rPr dirty="0">
+                <a:solidFill>
+                  <a:schemeClr val="bg1">
+                    <a:lumMod val="50000"/>
+                  </a:schemeClr>
+                </a:solidFill>
+              </a:rPr>
+              <a:t>Background</a:t>
+            </a:r>
+          </a:p>
+          <a:p>
+            <a:r>
+              <a:rPr dirty="0" err="1">
+                <a:solidFill>
+                  <a:schemeClr val="bg1">
+                    <a:lumMod val="50000"/>
+                  </a:schemeClr>
+                </a:solidFill>
+              </a:rPr>
+              <a:t>AoA</a:t>
+            </a:r>
+            <a:r>
+              <a:rPr dirty="0">
+                <a:solidFill>
+                  <a:schemeClr val="bg1">
+                    <a:lumMod val="50000"/>
+                  </a:schemeClr>
+                </a:solidFill>
+              </a:rPr>
+              <a:t>-Assisted Risk Score and RTS Threshold Adaptation</a:t>
+            </a:r>
+          </a:p>
+          <a:p>
+            <a:r>
+              <a:rPr dirty="0"/>
+              <a:t>Evaluation</a:t>
+            </a:r>
+          </a:p>
+          <a:p>
+            <a:r>
+              <a:rPr dirty="0">
+                <a:solidFill>
+                  <a:schemeClr val="bg1">
+                    <a:lumMod val="50000"/>
+                  </a:schemeClr>
+                </a:solidFill>
+              </a:rPr>
+              <a:t>Conclusion</a:t>
+            </a:r>
+          </a:p>
+        </p:txBody>
+      </p:sp>
+      <p:sp>
+        <p:nvSpPr>
+          <p:cNvPr id="4" name="璅? 3">
+            <a:extLst>
+              <a:ext uri="{FF2B5EF4-FFF2-40B4-BE49-F238E27FC236}">
+                <a16:creationId xmlns:a16="http://schemas.microsoft.com/office/drawing/2014/main" id="{363B54DA-5A57-63A3-3957-4A5B100F1AAB}"/>
+              </a:ext>
+            </a:extLst>
+          </p:cNvPr>
+          <p:cNvSpPr>
+            <a:spLocks noGrp="1"/>
+          </p:cNvSpPr>
+          <p:nvPr>
+            <p:ph type="title"/>
+          </p:nvPr>
+        </p:nvSpPr>
+        <p:spPr/>
+        <p:txBody>
+          <a:bodyPr/>
+          <a:lstStyle/>
+          <a:p>
+            <a:r>
+              <a:t>Outline</a:t>
+            </a:r>
+          </a:p>
+        </p:txBody>
+      </p:sp>
     </p:spTree>
     <p:extLst>
       <p:ext uri="{BB962C8B-B14F-4D97-AF65-F5344CB8AC3E}">
-        <p14:creationId xmlns:p14="http://schemas.microsoft.com/office/powerpoint/2010/main" val="3499234266"/>
+        <p14:creationId xmlns:p14="http://schemas.microsoft.com/office/powerpoint/2010/main" val="346352892"/>
       </p:ext>
     </p:extLst>
   </p:cSld>
@@ -11232,7 +11296,7 @@
           <a:p>
             <a:r>
               <a:rPr b="1"/>
-              <a:t>Performance analysis focus</a:t>
+              <a:t>Evaluation Compares Static and Dynamic Policies</a:t>
             </a:r>
           </a:p>
         </p:txBody>
@@ -11259,7 +11323,17 @@
           <a:lstStyle/>
           <a:p>
             <a:r>
-              <a:t>Analyze when the proposed method improves performance and when it has limited benefit.</a:t>
+              <a:t>Test hidden-node and non-hidden-node scenarios.</a:t>
+            </a:r>
+          </a:p>
+          <a:p>
+            <a:r>
+              <a:t>Compare static RTS/CTS settings with the AoA-assisted dynamic RTS threshold policy.</a:t>
+            </a:r>
+          </a:p>
+          <a:p>
+            <a:r>
+              <a:t>Measure throughput, retry rate, latency, MCS distribution, and fairness.</a:t>
             </a:r>
           </a:p>
         </p:txBody>
@@ -11288,7 +11362,7 @@
             <a:pPr>
               <a:buNone/>
             </a:pPr>
-            <a:fld id="{02F15020-66A7-620A-7B7A-C05C4312DEAE}" type="slidenum">
+            <a:fld id="{5AB55966-FA28-BC73-EA9E-53DF014DF033}" type="slidenum">
               <a:rPr sz="1400">
                 <a:latin typeface="Times New Roman"/>
                 <a:ea typeface="Times New Roman"/>
@@ -11336,6 +11410,131 @@
       </p:grpSpPr>
       <p:sp>
         <p:nvSpPr>
+          <p:cNvPr id="2" name="標題 1">
+            <a:extLst>
+              <a:ext uri="{FF2B5EF4-FFF2-40B4-BE49-F238E27FC236}">
+                <a16:creationId xmlns:a16="http://schemas.microsoft.com/office/drawing/2014/main" id="{27A3B284-1CEC-47E9-98B8-BA58ABCB5210}"/>
+              </a:ext>
+            </a:extLst>
+          </p:cNvPr>
+          <p:cNvSpPr>
+            <a:spLocks noGrp="1"/>
+          </p:cNvSpPr>
+          <p:nvPr>
+            <p:ph type="title"/>
+          </p:nvPr>
+        </p:nvSpPr>
+        <p:spPr/>
+        <p:txBody>
+          <a:bodyPr/>
+          <a:lstStyle/>
+          <a:p>
+            <a:r>
+              <a:rPr b="1"/>
+              <a:t>Performance Analysis Separates Gains from Limits</a:t>
+            </a:r>
+          </a:p>
+        </p:txBody>
+      </p:sp>
+      <p:sp>
+        <p:nvSpPr>
+          <p:cNvPr id="3" name="內容版面配置區 2">
+            <a:extLst>
+              <a:ext uri="{FF2B5EF4-FFF2-40B4-BE49-F238E27FC236}">
+                <a16:creationId xmlns:a16="http://schemas.microsoft.com/office/drawing/2014/main" id="{85EB7868-0B10-4ADE-BF08-3CE42A258785}"/>
+              </a:ext>
+            </a:extLst>
+          </p:cNvPr>
+          <p:cNvSpPr>
+            <a:spLocks noGrp="1"/>
+          </p:cNvSpPr>
+          <p:nvPr>
+            <p:ph idx="1"/>
+          </p:nvPr>
+        </p:nvSpPr>
+        <p:spPr/>
+        <p:txBody>
+          <a:bodyPr/>
+          <a:lstStyle/>
+          <a:p>
+            <a:r>
+              <a:t>Analyze when the method improves performance and when its benefit is limited.</a:t>
+            </a:r>
+          </a:p>
+        </p:txBody>
+      </p:sp>
+      <p:sp>
+        <p:nvSpPr>
+          <p:cNvPr id="4" name="投影片編號版面配置區 3">
+            <a:extLst>
+              <a:ext uri="{FF2B5EF4-FFF2-40B4-BE49-F238E27FC236}">
+                <a16:creationId xmlns:a16="http://schemas.microsoft.com/office/drawing/2014/main" id="{C2FCD405-600C-462A-BF29-DAFF79456778}"/>
+              </a:ext>
+            </a:extLst>
+          </p:cNvPr>
+          <p:cNvSpPr>
+            <a:spLocks noGrp="1"/>
+          </p:cNvSpPr>
+          <p:nvPr>
+            <p:ph type="sldNum" idx="10"/>
+          </p:nvPr>
+        </p:nvSpPr>
+        <p:spPr/>
+        <p:txBody>
+          <a:bodyPr/>
+          <a:lstStyle/>
+          <a:p>
+            <a:pPr>
+              <a:buNone/>
+            </a:pPr>
+            <a:fld id="{02F15020-66A7-620A-7B7A-C05C4312DEAE}" type="slidenum">
+              <a:rPr sz="1400">
+                <a:latin typeface="Times New Roman"/>
+                <a:ea typeface="Times New Roman"/>
+                <a:cs typeface="Times New Roman"/>
+              </a:rPr>
+              <a:t>22</a:t>
+            </a:fld>
+            <a:endParaRPr sz="1400">
+              <a:latin typeface="Times New Roman"/>
+              <a:ea typeface="Times New Roman"/>
+              <a:cs typeface="Times New Roman"/>
+            </a:endParaRPr>
+          </a:p>
+        </p:txBody>
+      </p:sp>
+    </p:spTree>
+    <p:extLst>
+      <p:ext uri="{BB962C8B-B14F-4D97-AF65-F5344CB8AC3E}">
+        <p14:creationId xmlns:p14="http://schemas.microsoft.com/office/powerpoint/2010/main" val="3499234266"/>
+      </p:ext>
+    </p:extLst>
+  </p:cSld>
+  <p:clrMapOvr>
+    <a:masterClrMapping/>
+  </p:clrMapOvr>
+</p:sld>
+</file>
+
+<file path=ppt/slides/slide23.xml><?xml version="1.0" encoding="utf-8"?>
+<p:sld xmlns:a="http://schemas.openxmlformats.org/drawingml/2006/main" xmlns:r="http://schemas.openxmlformats.org/officeDocument/2006/relationships" xmlns:p="http://schemas.openxmlformats.org/presentationml/2006/main">
+  <p:cSld>
+    <p:spTree>
+      <p:nvGrpSpPr>
+        <p:cNvPr id="1" name=""/>
+        <p:cNvGrpSpPr/>
+        <p:nvPr/>
+      </p:nvGrpSpPr>
+      <p:grpSpPr>
+        <a:xfrm>
+          <a:off x="0" y="0"/>
+          <a:ext cx="0" cy="0"/>
+          <a:chOff x="0" y="0"/>
+          <a:chExt cx="0" cy="0"/>
+        </a:xfrm>
+      </p:grpSpPr>
+      <p:sp>
+        <p:nvSpPr>
           <p:cNvPr id="2" name="?蔣?楊???ａ?蝵桀? 1">
             <a:extLst>
               <a:ext uri="{FF2B5EF4-FFF2-40B4-BE49-F238E27FC236}">
@@ -11364,7 +11563,7 @@
                 <a:ea typeface="Times New Roman"/>
                 <a:cs typeface="Times New Roman"/>
               </a:rPr>
-              <a:t>22</a:t>
+              <a:t>23</a:t>
             </a:fld>
             <a:endParaRPr sz="1400">
               <a:latin typeface="Times New Roman"/>
@@ -11723,7 +11922,7 @@
           <a:p>
             <a:r>
               <a:rPr lang="en-US" altLang="zh-TW" dirty="0"/>
-              <a:t>Hidden Node Problem</a:t>
+              <a:t>Hidden Nodes Cause Receiver-Side Collisions</a:t>
             </a:r>
             <a:endParaRPr dirty="0"/>
           </a:p>
@@ -11791,17 +11990,35 @@
           <a:lstStyle/>
           <a:p>
             <a:r>
-              <a:rPr lang="zh-TW" altLang="zh-TW" dirty="0"/>
-              <a:t>The hidden node problem occurs when two nodes in a wireless network can communicate with a third node, but cannot communicate with each other directly due to obstacles or being out of range</a:t>
-            </a:r>
-            <a:endParaRPr lang="en-US" altLang="zh-TW" dirty="0"/>
-          </a:p>
-          <a:p>
-            <a:r>
-              <a:rPr lang="zh-TW" altLang="zh-TW" dirty="0"/>
-              <a:t> This can lead to collisions at the third node when both nodes transmit simultaneously</a:t>
-            </a:r>
-            <a:endParaRPr lang="zh-TW" altLang="en-US" dirty="0"/>
+              <a:rPr lang="en-US" altLang="zh-TW" dirty="0"/>
+              <a:t>Hidden node reaches AP but cannot sense other nodes using same AP</a:t>
+            </a:r>
+          </a:p>
+          <a:p>
+            <a:r>
+              <a:rPr lang="en-US" altLang="zh-TW" dirty="0"/>
+              <a:t>Nodes cannot hear each other</a:t>
+            </a:r>
+          </a:p>
+          <a:p>
+            <a:pPr lvl="1"/>
+            <a:r>
+              <a:rPr lang="en-US" altLang="zh-TW" dirty="0"/>
+              <a:t>May transmit simultaneously</a:t>
+            </a:r>
+          </a:p>
+          <a:p>
+            <a:r>
+              <a:rPr lang="en-US" altLang="zh-TW" dirty="0"/>
+              <a:t>Simultaneous transmissions collide at AP</a:t>
+            </a:r>
+          </a:p>
+          <a:p>
+            <a:pPr lvl="1"/>
+            <a:r>
+              <a:rPr lang="en-US" altLang="zh-TW" dirty="0"/>
+              <a:t>Reduces wireless network throughput</a:t>
+            </a:r>
           </a:p>
         </p:txBody>
       </p:sp>
@@ -11819,7 +12036,7 @@
         </p:nvGrpSpPr>
         <p:grpSpPr>
           <a:xfrm>
-            <a:off x="2968242" y="3129382"/>
+            <a:off x="5523554" y="3080581"/>
             <a:ext cx="6255516" cy="3356964"/>
             <a:chOff x="2864188" y="3407243"/>
             <a:chExt cx="6255516" cy="3356964"/>
@@ -12248,7 +12465,7 @@
           <a:p>
             <a:r>
               <a:rPr lang="en-US" altLang="zh-TW" dirty="0"/>
-              <a:t>RTS/CTS Mitigation</a:t>
+              <a:t>RTS/CTS Mitigates Hidden-Node Collisions</a:t>
             </a:r>
             <a:endParaRPr dirty="0"/>
           </a:p>
@@ -12276,81 +12493,53 @@
           <a:lstStyle/>
           <a:p>
             <a:r>
+              <a:rPr lang="en-US" altLang="zh-TW" dirty="0"/>
+              <a:t>O</a:t>
+            </a:r>
+            <a:r>
               <a:rPr lang="zh-TW" altLang="zh-TW" dirty="0"/>
-              <a:t>RTS/CTS is an optional 802.11 mechanism used before data transmission</a:t>
+              <a:t>ptional 802.11 handshake before data transmission.</a:t>
             </a:r>
             <a:endParaRPr lang="en-US" altLang="zh-TW" dirty="0"/>
           </a:p>
           <a:p>
             <a:r>
               <a:rPr lang="zh-TW" altLang="zh-TW" dirty="0"/>
-              <a:t>Sender first sends an </a:t>
-            </a:r>
-            <a:r>
-              <a:rPr lang="zh-TW" altLang="zh-TW" b="1" dirty="0"/>
-              <a:t>RTS</a:t>
-            </a:r>
+              <a:t>Sender sends RTS to request channel access.</a:t>
+            </a:r>
+            <a:endParaRPr lang="en-US" altLang="zh-TW" dirty="0"/>
+          </a:p>
+          <a:p>
             <a:r>
               <a:rPr lang="zh-TW" altLang="zh-TW" dirty="0"/>
-              <a:t> frame to request channel access</a:t>
+              <a:t>Receiver sends CTS to grant transmission permission.</a:t>
             </a:r>
             <a:endParaRPr lang="en-US" altLang="zh-TW" dirty="0"/>
           </a:p>
           <a:p>
             <a:r>
               <a:rPr lang="zh-TW" altLang="zh-TW" dirty="0"/>
-              <a:t>Receiver replies with a </a:t>
-            </a:r>
-            <a:r>
-              <a:rPr lang="zh-TW" altLang="zh-TW" b="1" dirty="0"/>
-              <a:t>CTS</a:t>
-            </a:r>
+              <a:t>Nearby nodes that hear RTS or CTS update NAV and defer.</a:t>
+            </a:r>
+            <a:endParaRPr lang="en-US" altLang="zh-TW" dirty="0"/>
+          </a:p>
+          <a:p>
             <a:r>
               <a:rPr lang="zh-TW" altLang="zh-TW" dirty="0"/>
-              <a:t> frame to grant transmission permission</a:t>
+              <a:t>Hidden nodes may miss RTS but still hear CTS from the receiver.</a:t>
             </a:r>
             <a:endParaRPr lang="en-US" altLang="zh-TW" dirty="0"/>
           </a:p>
           <a:p>
             <a:r>
+              <a:rPr lang="en-US" altLang="zh-TW" dirty="0"/>
+              <a:t>Sender transmits data after the channel is reserved.</a:t>
+            </a:r>
+          </a:p>
+          <a:p>
+            <a:r>
               <a:rPr lang="zh-TW" altLang="zh-TW" dirty="0"/>
-              <a:t>Nearby nodes that hear RTS or CTS update their </a:t>
-            </a:r>
-            <a:r>
-              <a:rPr lang="zh-TW" altLang="zh-TW" b="1" dirty="0"/>
-              <a:t>NAV</a:t>
-            </a:r>
-            <a:r>
-              <a:rPr lang="zh-TW" altLang="zh-TW" dirty="0"/>
-              <a:t> and defer transmission</a:t>
-            </a:r>
-            <a:endParaRPr lang="en-US" altLang="zh-TW" dirty="0"/>
-          </a:p>
-          <a:p>
-            <a:r>
-              <a:rPr lang="zh-TW" altLang="zh-TW" dirty="0"/>
-              <a:t>Hidden nodes that cannot hear the sender may still hear the receiver</a:t>
-            </a:r>
-            <a:r>
-              <a:rPr lang="en-US" altLang="zh-TW" dirty="0"/>
-              <a:t>’s </a:t>
-            </a:r>
-            <a:r>
-              <a:rPr lang="zh-TW" altLang="zh-TW" dirty="0"/>
-              <a:t>CTS, so they remain silent</a:t>
-            </a:r>
-            <a:endParaRPr lang="en-US" altLang="zh-TW" dirty="0"/>
-          </a:p>
-          <a:p>
-            <a:r>
-              <a:rPr lang="en-US" altLang="zh-TW" dirty="0"/>
-              <a:t>Sender sends real data</a:t>
-            </a:r>
-          </a:p>
-          <a:p>
-            <a:r>
-              <a:rPr lang="zh-TW" altLang="zh-TW" dirty="0"/>
-              <a:t>This reserves the channel around the receiver and reduces hidden-node collisions</a:t>
+              <a:t>Reserving the receiver's neighborhood reduces hidden-node collisions.</a:t>
             </a:r>
           </a:p>
         </p:txBody>
@@ -12484,7 +12673,7 @@
           <a:p>
             <a:r>
               <a:rPr lang="zh-TW" altLang="zh-TW" dirty="0"/>
-              <a:t>Static RTS Threshold Limitation</a:t>
+              <a:t>Static RTS Thresholds Cannot Track Hidden-Node Risk</a:t>
             </a:r>
             <a:endParaRPr lang="zh-TW" altLang="en-US" dirty="0"/>
           </a:p>
@@ -12513,22 +12702,14 @@
           <a:p>
             <a:r>
               <a:rPr lang="zh-TW" altLang="zh-TW" dirty="0"/>
-              <a:t>In conventional 802.11, the RTS threshold is usually configured as a </a:t>
-            </a:r>
-            <a:r>
-              <a:rPr lang="zh-TW" altLang="zh-TW" b="1" dirty="0"/>
-              <a:t>static value</a:t>
-            </a:r>
+              <a:t>Conventional 802.11 usually uses a fixed RTS threshold.</a:t>
+            </a:r>
+            <a:endParaRPr lang="en-US" altLang="zh-TW" dirty="0"/>
+          </a:p>
+          <a:p>
             <a:r>
               <a:rPr lang="zh-TW" altLang="zh-TW" dirty="0"/>
-              <a:t>.</a:t>
-            </a:r>
-            <a:endParaRPr lang="en-US" altLang="zh-TW" dirty="0"/>
-          </a:p>
-          <a:p>
-            <a:r>
-              <a:rPr lang="zh-TW" altLang="zh-TW" dirty="0"/>
-              <a:t>Because the threshold is fixed, it cannot adapt to STA physical location or hidden-node conditions.</a:t>
+              <a:t>A fixed threshold cannot adapt to station location or changing hidden-node conditions.</a:t>
             </a:r>
             <a:endParaRPr lang="zh-TW" altLang="en-US" dirty="0"/>
           </a:p>
@@ -12655,31 +12836,7 @@
           <a:p>
             <a:r>
               <a:rPr dirty="0"/>
-              <a:t>State the thesis goal early: let the AP infer hidden-node risk from </a:t>
-            </a:r>
-            <a:r>
-              <a:rPr lang="en-US" altLang="zh-TW" dirty="0"/>
-              <a:t>Angle of Arrival </a:t>
-            </a:r>
-            <a:r>
-              <a:rPr lang="zh-TW" altLang="en-US" dirty="0"/>
-              <a:t> </a:t>
-            </a:r>
-            <a:r>
-              <a:rPr lang="en-US" altLang="zh-TW" dirty="0"/>
-              <a:t>(</a:t>
-            </a:r>
-            <a:r>
-              <a:rPr dirty="0" err="1"/>
-              <a:t>AoA</a:t>
-            </a:r>
-            <a:r>
-              <a:rPr lang="en-US" altLang="zh-TW" dirty="0"/>
-              <a:t>)</a:t>
-            </a:r>
-            <a:r>
-              <a:rPr dirty="0"/>
-              <a:t> and link observations, then tune the RTS threshold dynamically.</a:t>
+              <a:t>The AP infers hidden-node risk from Angle of Arrival (AoA) and link observations, then tunes the RTS threshold dynamically.</a:t>
             </a:r>
           </a:p>
         </p:txBody>
@@ -12960,16 +13117,21 @@
           <a:p>
             <a:r>
               <a:rPr lang="zh-TW" altLang="zh-TW" dirty="0"/>
-              <a:t>WiFi OFDM</a:t>
-            </a:r>
-            <a:r>
-              <a:rPr lang="en-US" altLang="zh-TW" dirty="0"/>
+              <a:t>Wi-Fi </a:t>
+            </a:r>
+            <a:r>
+              <a:rPr lang="zh-TW" altLang="zh-TW" b="1" dirty="0"/>
+              <a:t>Channel State Information</a:t>
+            </a:r>
+            <a:r>
+              <a:rPr lang="zh-TW" altLang="en-US" b="1" dirty="0"/>
               <a:t> </a:t>
             </a:r>
             <a:r>
-              <a:rPr b="1" dirty="0"/>
-              <a:t>CSI</a:t>
-            </a:r>
+              <a:rPr lang="en-US" altLang="zh-TW" b="1" dirty="0"/>
+              <a:t>(CSI)</a:t>
+            </a:r>
+            <a:endParaRPr lang="zh-TW" altLang="zh-TW" dirty="0"/>
           </a:p>
         </p:txBody>
       </p:sp>
@@ -13040,128 +13202,682 @@
           <a:lstStyle/>
           <a:p>
             <a:r>
-              <a:rPr lang="zh-TW" altLang="zh-TW" b="1" dirty="0"/>
-              <a:t>CSI means Channel State Information</a:t>
-            </a:r>
-            <a:endParaRPr lang="en-US" altLang="zh-TW" b="1" dirty="0"/>
-          </a:p>
-          <a:p>
+              <a:rPr lang="en-US" altLang="zh-TW" dirty="0"/>
+              <a:t>D</a:t>
+            </a:r>
             <a:r>
               <a:rPr lang="zh-TW" altLang="zh-TW" dirty="0"/>
-              <a:t>It describes how a WiFi signal changes from transmitter to receiver</a:t>
-            </a:r>
-            <a:endParaRPr lang="en-US" altLang="zh-TW" dirty="0"/>
-          </a:p>
-          <a:p>
-            <a:r>
-              <a:rPr lang="zh-TW" altLang="zh-TW" dirty="0"/>
-              <a:t>CSI is not measured directly from random data.</a:t>
-            </a:r>
-          </a:p>
-          <a:p>
-            <a:r>
-              <a:rPr lang="zh-TW" altLang="zh-TW" dirty="0"/>
-              <a:t>The sender first sends a </a:t>
-            </a:r>
-            <a:r>
-              <a:rPr lang="zh-TW" altLang="zh-TW" b="1" dirty="0"/>
-              <a:t>known signal pattern</a:t>
-            </a:r>
-            <a:endParaRPr lang="en-US" altLang="zh-TW" b="1" dirty="0"/>
-          </a:p>
-          <a:p>
+              <a:t>escribes </a:t>
+            </a:r>
             <a:r>
               <a:rPr lang="en-US" altLang="zh-TW" dirty="0"/>
-              <a:t>Receiver </a:t>
-            </a:r>
-            <a:r>
-              <a:rPr lang="zh-TW" altLang="zh-TW" dirty="0"/>
-              <a:t>measure</a:t>
-            </a:r>
+              <a:t>propagation process of the wireless signal </a:t>
+            </a:r>
+          </a:p>
+          <a:p>
+            <a:pPr lvl="1"/>
             <a:r>
               <a:rPr lang="en-US" altLang="zh-TW" dirty="0"/>
-              <a:t> CSI</a:t>
-            </a:r>
-            <a:r>
-              <a:rPr lang="zh-TW" altLang="zh-TW" dirty="0"/>
-              <a:t> on </a:t>
-            </a:r>
+              <a:t> therefore contains geometric information of the propagation space</a:t>
+            </a:r>
+          </a:p>
+          <a:p>
             <a:r>
               <a:rPr lang="en-US" altLang="zh-TW" dirty="0"/>
-              <a:t>each subcarrier and each transmit-receiver antenna pair</a:t>
+              <a:t>Sender transmits a pattern known to receiver</a:t>
+            </a:r>
+          </a:p>
+          <a:p>
+            <a:r>
+              <a:rPr lang="en-US" altLang="zh-TW" dirty="0"/>
+              <a:t>The receiver estimates CSI for each subcarrier and transmit-receive antenna pair</a:t>
             </a:r>
             <a:endParaRPr lang="zh-TW" altLang="zh-TW" dirty="0"/>
           </a:p>
-          <a:p>
-            <a:r>
-              <a:rPr lang="zh-TW" altLang="zh-TW" dirty="0"/>
-              <a:t>Each CSI value is complex:</a:t>
-            </a:r>
-          </a:p>
-          <a:p>
-            <a:pPr lvl="1"/>
-            <a:r>
-              <a:rPr lang="zh-TW" altLang="zh-TW" b="1" dirty="0"/>
-              <a:t>Amplitude</a:t>
-            </a:r>
-            <a:r>
-              <a:rPr lang="zh-TW" altLang="zh-TW" dirty="0"/>
-              <a:t>:</a:t>
-            </a:r>
-            <a:endParaRPr lang="en-US" altLang="zh-TW" dirty="0"/>
-          </a:p>
-          <a:p>
-            <a:pPr lvl="2"/>
-            <a:r>
-              <a:rPr lang="zh-TW" altLang="zh-TW" dirty="0"/>
-              <a:t> how strong the signal is</a:t>
-            </a:r>
-            <a:endParaRPr lang="en-US" altLang="zh-TW" dirty="0"/>
-          </a:p>
-          <a:p>
-            <a:pPr lvl="2"/>
-            <a:r>
-              <a:rPr lang="zh-TW" altLang="zh-TW" dirty="0"/>
-              <a:t>A larger amplitude means the signal is stronger</a:t>
-            </a:r>
-          </a:p>
-          <a:p>
-            <a:pPr lvl="1"/>
-            <a:r>
-              <a:rPr lang="zh-TW" altLang="zh-TW" b="1" dirty="0"/>
-              <a:t>Phase</a:t>
-            </a:r>
-            <a:r>
-              <a:rPr lang="zh-TW" altLang="zh-TW" dirty="0"/>
-              <a:t>: </a:t>
-            </a:r>
-            <a:endParaRPr lang="en-US" altLang="zh-TW" dirty="0"/>
-          </a:p>
-          <a:p>
-            <a:pPr lvl="2"/>
-            <a:r>
-              <a:rPr lang="zh-TW" altLang="zh-TW" dirty="0"/>
-              <a:t>how much the signal is shifted</a:t>
-            </a:r>
-            <a:endParaRPr lang="en-US" altLang="zh-TW" dirty="0"/>
-          </a:p>
-          <a:p>
-            <a:pPr lvl="2"/>
-            <a:r>
-              <a:rPr lang="zh-TW" altLang="zh-TW" dirty="0"/>
-              <a:t>Different paths or arrival directions create different phase shifts</a:t>
-            </a:r>
-            <a:endParaRPr lang="en-US" altLang="zh-TW" dirty="0"/>
-          </a:p>
-          <a:p>
-            <a:r>
-              <a:rPr lang="en-US" altLang="zh-TW" dirty="0"/>
-              <a:t>Represent in e </a:t>
-            </a:r>
-            <a:endParaRPr lang="zh-TW" altLang="zh-TW" dirty="0"/>
-          </a:p>
-        </p:txBody>
-      </p:sp>
+        </p:txBody>
+      </p:sp>
+      <p:grpSp>
+        <p:nvGrpSpPr>
+          <p:cNvPr id="40" name="群組 39">
+            <a:extLst>
+              <a:ext uri="{FF2B5EF4-FFF2-40B4-BE49-F238E27FC236}">
+                <a16:creationId xmlns:a16="http://schemas.microsoft.com/office/drawing/2014/main" id="{7FEA01D5-F631-4160-B957-66CC4C52B2EE}"/>
+              </a:ext>
+            </a:extLst>
+          </p:cNvPr>
+          <p:cNvGrpSpPr/>
+          <p:nvPr/>
+        </p:nvGrpSpPr>
+        <p:grpSpPr>
+          <a:xfrm>
+            <a:off x="2174588" y="3779811"/>
+            <a:ext cx="8223781" cy="1892997"/>
+            <a:chOff x="1422748" y="4073235"/>
+            <a:chExt cx="8223781" cy="1892997"/>
+          </a:xfrm>
+        </p:grpSpPr>
+        <p:pic>
+          <p:nvPicPr>
+            <p:cNvPr id="8" name="圖片 7">
+              <a:extLst>
+                <a:ext uri="{FF2B5EF4-FFF2-40B4-BE49-F238E27FC236}">
+                  <a16:creationId xmlns:a16="http://schemas.microsoft.com/office/drawing/2014/main" id="{6010C766-B3B0-4065-BB06-6C3220DE8E03}"/>
+                </a:ext>
+              </a:extLst>
+            </p:cNvPr>
+            <p:cNvPicPr>
+              <a:picLocks noChangeAspect="1"/>
+            </p:cNvPicPr>
+            <p:nvPr/>
+          </p:nvPicPr>
+          <p:blipFill>
+            <a:blip r:embed="rId3">
+              <a:extLst>
+                <a:ext uri="{28A0092B-C50C-407E-A947-70E740481C1C}">
+                  <a14:useLocalDpi xmlns:a14="http://schemas.microsoft.com/office/drawing/2010/main" val="0"/>
+                </a:ext>
+              </a:extLst>
+            </a:blip>
+            <a:stretch>
+              <a:fillRect/>
+            </a:stretch>
+          </p:blipFill>
+          <p:spPr>
+            <a:xfrm>
+              <a:off x="1422748" y="4520551"/>
+              <a:ext cx="971430" cy="971430"/>
+            </a:xfrm>
+            <a:prstGeom prst="rect">
+              <a:avLst/>
+            </a:prstGeom>
+          </p:spPr>
+        </p:pic>
+        <p:pic>
+          <p:nvPicPr>
+            <p:cNvPr id="9" name="內容版面配置區 5">
+              <a:extLst>
+                <a:ext uri="{FF2B5EF4-FFF2-40B4-BE49-F238E27FC236}">
+                  <a16:creationId xmlns:a16="http://schemas.microsoft.com/office/drawing/2014/main" id="{CB892C52-E602-4F45-90B6-340B67A27500}"/>
+                </a:ext>
+              </a:extLst>
+            </p:cNvPr>
+            <p:cNvPicPr>
+              <a:picLocks noChangeAspect="1"/>
+            </p:cNvPicPr>
+            <p:nvPr/>
+          </p:nvPicPr>
+          <p:blipFill>
+            <a:blip r:embed="rId4">
+              <a:extLst>
+                <a:ext uri="{28A0092B-C50C-407E-A947-70E740481C1C}">
+                  <a14:useLocalDpi xmlns:a14="http://schemas.microsoft.com/office/drawing/2010/main" val="0"/>
+                </a:ext>
+              </a:extLst>
+            </a:blip>
+            <a:stretch>
+              <a:fillRect/>
+            </a:stretch>
+          </p:blipFill>
+          <p:spPr>
+            <a:xfrm>
+              <a:off x="8610392" y="4520551"/>
+              <a:ext cx="1036137" cy="1036137"/>
+            </a:xfrm>
+            <a:prstGeom prst="rect">
+              <a:avLst/>
+            </a:prstGeom>
+            <a:noFill/>
+          </p:spPr>
+        </p:pic>
+        <p:cxnSp>
+          <p:nvCxnSpPr>
+            <p:cNvPr id="10" name="直線接點 9">
+              <a:extLst>
+                <a:ext uri="{FF2B5EF4-FFF2-40B4-BE49-F238E27FC236}">
+                  <a16:creationId xmlns:a16="http://schemas.microsoft.com/office/drawing/2014/main" id="{CC6448C3-9AE5-41C9-A09C-502F5AC67BFD}"/>
+                </a:ext>
+              </a:extLst>
+            </p:cNvPr>
+            <p:cNvCxnSpPr/>
+            <p:nvPr/>
+          </p:nvCxnSpPr>
+          <p:spPr>
+            <a:xfrm>
+              <a:off x="1422748" y="4073236"/>
+              <a:ext cx="8105716" cy="0"/>
+            </a:xfrm>
+            <a:prstGeom prst="line">
+              <a:avLst/>
+            </a:prstGeom>
+            <a:ln w="28575">
+              <a:solidFill>
+                <a:schemeClr val="tx1"/>
+              </a:solidFill>
+            </a:ln>
+          </p:spPr>
+          <p:style>
+            <a:lnRef idx="1">
+              <a:schemeClr val="accent1"/>
+            </a:lnRef>
+            <a:fillRef idx="0">
+              <a:schemeClr val="accent1"/>
+            </a:fillRef>
+            <a:effectRef idx="0">
+              <a:schemeClr val="accent1"/>
+            </a:effectRef>
+            <a:fontRef idx="minor">
+              <a:schemeClr val="tx1"/>
+            </a:fontRef>
+          </p:style>
+        </p:cxnSp>
+        <p:sp>
+          <p:nvSpPr>
+            <p:cNvPr id="24" name="手繪多邊形: 圖案 23">
+              <a:extLst>
+                <a:ext uri="{FF2B5EF4-FFF2-40B4-BE49-F238E27FC236}">
+                  <a16:creationId xmlns:a16="http://schemas.microsoft.com/office/drawing/2014/main" id="{207C9F42-1C3F-42D6-9780-BB080908024E}"/>
+                </a:ext>
+              </a:extLst>
+            </p:cNvPr>
+            <p:cNvSpPr/>
+            <p:nvPr/>
+          </p:nvSpPr>
+          <p:spPr>
+            <a:xfrm>
+              <a:off x="1433945" y="5340350"/>
+              <a:ext cx="8073737" cy="619936"/>
+            </a:xfrm>
+            <a:custGeom>
+              <a:avLst/>
+              <a:gdLst>
+                <a:gd name="connsiteX0" fmla="*/ 0 w 8073737"/>
+                <a:gd name="connsiteY0" fmla="*/ 592859 h 619936"/>
+                <a:gd name="connsiteX1" fmla="*/ 2431473 w 8073737"/>
+                <a:gd name="connsiteY1" fmla="*/ 551295 h 619936"/>
+                <a:gd name="connsiteX2" fmla="*/ 3564082 w 8073737"/>
+                <a:gd name="connsiteY2" fmla="*/ 577 h 619936"/>
+                <a:gd name="connsiteX3" fmla="*/ 3979719 w 8073737"/>
+                <a:gd name="connsiteY3" fmla="*/ 447386 h 619936"/>
+                <a:gd name="connsiteX4" fmla="*/ 8073737 w 8073737"/>
+                <a:gd name="connsiteY4" fmla="*/ 520123 h 619936"/>
+              </a:gdLst>
+              <a:ahLst/>
+              <a:cxnLst>
+                <a:cxn ang="0">
+                  <a:pos x="connsiteX0" y="connsiteY0"/>
+                </a:cxn>
+                <a:cxn ang="0">
+                  <a:pos x="connsiteX1" y="connsiteY1"/>
+                </a:cxn>
+                <a:cxn ang="0">
+                  <a:pos x="connsiteX2" y="connsiteY2"/>
+                </a:cxn>
+                <a:cxn ang="0">
+                  <a:pos x="connsiteX3" y="connsiteY3"/>
+                </a:cxn>
+                <a:cxn ang="0">
+                  <a:pos x="connsiteX4" y="connsiteY4"/>
+                </a:cxn>
+              </a:cxnLst>
+              <a:rect l="l" t="t" r="r" b="b"/>
+              <a:pathLst>
+                <a:path w="8073737" h="619936">
+                  <a:moveTo>
+                    <a:pt x="0" y="592859"/>
+                  </a:moveTo>
+                  <a:cubicBezTo>
+                    <a:pt x="918730" y="621434"/>
+                    <a:pt x="1837460" y="650009"/>
+                    <a:pt x="2431473" y="551295"/>
+                  </a:cubicBezTo>
+                  <a:cubicBezTo>
+                    <a:pt x="3025486" y="452581"/>
+                    <a:pt x="3306041" y="17895"/>
+                    <a:pt x="3564082" y="577"/>
+                  </a:cubicBezTo>
+                  <a:cubicBezTo>
+                    <a:pt x="3822123" y="-16741"/>
+                    <a:pt x="3228110" y="360795"/>
+                    <a:pt x="3979719" y="447386"/>
+                  </a:cubicBezTo>
+                  <a:cubicBezTo>
+                    <a:pt x="4731328" y="533977"/>
+                    <a:pt x="7335983" y="528782"/>
+                    <a:pt x="8073737" y="520123"/>
+                  </a:cubicBezTo>
+                </a:path>
+              </a:pathLst>
+            </a:custGeom>
+            <a:noFill/>
+            <a:ln w="28575">
+              <a:solidFill>
+                <a:schemeClr val="tx1"/>
+              </a:solidFill>
+            </a:ln>
+          </p:spPr>
+          <p:style>
+            <a:lnRef idx="2">
+              <a:schemeClr val="accent1">
+                <a:shade val="50000"/>
+              </a:schemeClr>
+            </a:lnRef>
+            <a:fillRef idx="1">
+              <a:schemeClr val="accent1"/>
+            </a:fillRef>
+            <a:effectRef idx="0">
+              <a:schemeClr val="accent1"/>
+            </a:effectRef>
+            <a:fontRef idx="minor">
+              <a:schemeClr val="lt1"/>
+            </a:fontRef>
+          </p:style>
+          <p:txBody>
+            <a:bodyPr rtlCol="0" anchor="ctr"/>
+            <a:lstStyle/>
+            <a:p>
+              <a:pPr algn="ctr"/>
+              <a:endParaRPr lang="zh-TW" altLang="en-US"/>
+            </a:p>
+          </p:txBody>
+        </p:sp>
+        <p:cxnSp>
+          <p:nvCxnSpPr>
+            <p:cNvPr id="26" name="直線單箭頭接點 25">
+              <a:extLst>
+                <a:ext uri="{FF2B5EF4-FFF2-40B4-BE49-F238E27FC236}">
+                  <a16:creationId xmlns:a16="http://schemas.microsoft.com/office/drawing/2014/main" id="{0838522E-6A11-442B-9640-F8B7F1B7B862}"/>
+                </a:ext>
+              </a:extLst>
+            </p:cNvPr>
+            <p:cNvCxnSpPr>
+              <a:stCxn id="8" idx="3"/>
+              <a:endCxn id="9" idx="1"/>
+            </p:cNvCxnSpPr>
+            <p:nvPr/>
+          </p:nvCxnSpPr>
+          <p:spPr>
+            <a:xfrm>
+              <a:off x="2394178" y="5006266"/>
+              <a:ext cx="6216214" cy="32354"/>
+            </a:xfrm>
+            <a:prstGeom prst="straightConnector1">
+              <a:avLst/>
+            </a:prstGeom>
+            <a:ln w="12700">
+              <a:solidFill>
+                <a:srgbClr val="FF0000"/>
+              </a:solidFill>
+              <a:prstDash val="lgDashDot"/>
+              <a:tailEnd type="triangle"/>
+            </a:ln>
+          </p:spPr>
+          <p:style>
+            <a:lnRef idx="1">
+              <a:schemeClr val="accent1"/>
+            </a:lnRef>
+            <a:fillRef idx="0">
+              <a:schemeClr val="accent1"/>
+            </a:fillRef>
+            <a:effectRef idx="0">
+              <a:schemeClr val="accent1"/>
+            </a:effectRef>
+            <a:fontRef idx="minor">
+              <a:schemeClr val="tx1"/>
+            </a:fontRef>
+          </p:style>
+        </p:cxnSp>
+        <p:cxnSp>
+          <p:nvCxnSpPr>
+            <p:cNvPr id="28" name="直線接點 27">
+              <a:extLst>
+                <a:ext uri="{FF2B5EF4-FFF2-40B4-BE49-F238E27FC236}">
+                  <a16:creationId xmlns:a16="http://schemas.microsoft.com/office/drawing/2014/main" id="{73171AB8-6342-4A7D-A1F9-4BF06F1E29FD}"/>
+                </a:ext>
+              </a:extLst>
+            </p:cNvPr>
+            <p:cNvCxnSpPr>
+              <a:stCxn id="8" idx="3"/>
+            </p:cNvCxnSpPr>
+            <p:nvPr/>
+          </p:nvCxnSpPr>
+          <p:spPr>
+            <a:xfrm flipV="1">
+              <a:off x="2394178" y="4073236"/>
+              <a:ext cx="3076635" cy="933030"/>
+            </a:xfrm>
+            <a:prstGeom prst="line">
+              <a:avLst/>
+            </a:prstGeom>
+            <a:ln w="12700">
+              <a:solidFill>
+                <a:srgbClr val="FF0000"/>
+              </a:solidFill>
+              <a:prstDash val="lgDashDot"/>
+            </a:ln>
+          </p:spPr>
+          <p:style>
+            <a:lnRef idx="1">
+              <a:schemeClr val="accent1"/>
+            </a:lnRef>
+            <a:fillRef idx="0">
+              <a:schemeClr val="accent1"/>
+            </a:fillRef>
+            <a:effectRef idx="0">
+              <a:schemeClr val="accent1"/>
+            </a:effectRef>
+            <a:fontRef idx="minor">
+              <a:schemeClr val="tx1"/>
+            </a:fontRef>
+          </p:style>
+        </p:cxnSp>
+        <p:cxnSp>
+          <p:nvCxnSpPr>
+            <p:cNvPr id="30" name="直線單箭頭接點 29">
+              <a:extLst>
+                <a:ext uri="{FF2B5EF4-FFF2-40B4-BE49-F238E27FC236}">
+                  <a16:creationId xmlns:a16="http://schemas.microsoft.com/office/drawing/2014/main" id="{9CC9A31A-1529-41FB-ABC3-72C5AF7DF74E}"/>
+                </a:ext>
+              </a:extLst>
+            </p:cNvPr>
+            <p:cNvCxnSpPr>
+              <a:cxnSpLocks/>
+            </p:cNvCxnSpPr>
+            <p:nvPr/>
+          </p:nvCxnSpPr>
+          <p:spPr>
+            <a:xfrm>
+              <a:off x="5462869" y="4073235"/>
+              <a:ext cx="3163411" cy="751799"/>
+            </a:xfrm>
+            <a:prstGeom prst="straightConnector1">
+              <a:avLst/>
+            </a:prstGeom>
+            <a:ln w="12700">
+              <a:solidFill>
+                <a:srgbClr val="FF0000"/>
+              </a:solidFill>
+              <a:prstDash val="lgDashDot"/>
+              <a:tailEnd type="triangle"/>
+            </a:ln>
+          </p:spPr>
+          <p:style>
+            <a:lnRef idx="1">
+              <a:schemeClr val="accent1"/>
+            </a:lnRef>
+            <a:fillRef idx="0">
+              <a:schemeClr val="accent1"/>
+            </a:fillRef>
+            <a:effectRef idx="0">
+              <a:schemeClr val="accent1"/>
+            </a:effectRef>
+            <a:fontRef idx="minor">
+              <a:schemeClr val="tx1"/>
+            </a:fontRef>
+          </p:style>
+        </p:cxnSp>
+        <p:cxnSp>
+          <p:nvCxnSpPr>
+            <p:cNvPr id="32" name="直線接點 31">
+              <a:extLst>
+                <a:ext uri="{FF2B5EF4-FFF2-40B4-BE49-F238E27FC236}">
+                  <a16:creationId xmlns:a16="http://schemas.microsoft.com/office/drawing/2014/main" id="{23EF1E2B-298B-4078-BC0B-AAB23A76B184}"/>
+                </a:ext>
+              </a:extLst>
+            </p:cNvPr>
+            <p:cNvCxnSpPr>
+              <a:stCxn id="8" idx="3"/>
+            </p:cNvCxnSpPr>
+            <p:nvPr/>
+          </p:nvCxnSpPr>
+          <p:spPr>
+            <a:xfrm>
+              <a:off x="2394178" y="5006266"/>
+              <a:ext cx="2125867" cy="644052"/>
+            </a:xfrm>
+            <a:prstGeom prst="line">
+              <a:avLst/>
+            </a:prstGeom>
+            <a:ln w="12700">
+              <a:solidFill>
+                <a:srgbClr val="FF0000"/>
+              </a:solidFill>
+              <a:prstDash val="lgDashDot"/>
+            </a:ln>
+          </p:spPr>
+          <p:style>
+            <a:lnRef idx="1">
+              <a:schemeClr val="accent1"/>
+            </a:lnRef>
+            <a:fillRef idx="0">
+              <a:schemeClr val="accent1"/>
+            </a:fillRef>
+            <a:effectRef idx="0">
+              <a:schemeClr val="accent1"/>
+            </a:effectRef>
+            <a:fontRef idx="minor">
+              <a:schemeClr val="tx1"/>
+            </a:fontRef>
+          </p:style>
+        </p:cxnSp>
+        <p:cxnSp>
+          <p:nvCxnSpPr>
+            <p:cNvPr id="34" name="直線接點 33">
+              <a:extLst>
+                <a:ext uri="{FF2B5EF4-FFF2-40B4-BE49-F238E27FC236}">
+                  <a16:creationId xmlns:a16="http://schemas.microsoft.com/office/drawing/2014/main" id="{2230EF8C-9824-4F48-B7EA-3D8D1C4937E2}"/>
+                </a:ext>
+              </a:extLst>
+            </p:cNvPr>
+            <p:cNvCxnSpPr>
+              <a:endCxn id="24" idx="3"/>
+            </p:cNvCxnSpPr>
+            <p:nvPr/>
+          </p:nvCxnSpPr>
+          <p:spPr>
+            <a:xfrm>
+              <a:off x="4520045" y="5650318"/>
+              <a:ext cx="893619" cy="137418"/>
+            </a:xfrm>
+            <a:prstGeom prst="line">
+              <a:avLst/>
+            </a:prstGeom>
+            <a:ln w="12700">
+              <a:solidFill>
+                <a:srgbClr val="FF0000"/>
+              </a:solidFill>
+              <a:prstDash val="lgDashDot"/>
+            </a:ln>
+          </p:spPr>
+          <p:style>
+            <a:lnRef idx="1">
+              <a:schemeClr val="accent1"/>
+            </a:lnRef>
+            <a:fillRef idx="0">
+              <a:schemeClr val="accent1"/>
+            </a:fillRef>
+            <a:effectRef idx="0">
+              <a:schemeClr val="accent1"/>
+            </a:effectRef>
+            <a:fontRef idx="minor">
+              <a:schemeClr val="tx1"/>
+            </a:fontRef>
+          </p:style>
+        </p:cxnSp>
+        <p:cxnSp>
+          <p:nvCxnSpPr>
+            <p:cNvPr id="36" name="直線單箭頭接點 35">
+              <a:extLst>
+                <a:ext uri="{FF2B5EF4-FFF2-40B4-BE49-F238E27FC236}">
+                  <a16:creationId xmlns:a16="http://schemas.microsoft.com/office/drawing/2014/main" id="{D33F1F70-816C-4D85-897B-59ABC7366C03}"/>
+                </a:ext>
+              </a:extLst>
+            </p:cNvPr>
+            <p:cNvCxnSpPr>
+              <a:stCxn id="24" idx="3"/>
+            </p:cNvCxnSpPr>
+            <p:nvPr/>
+          </p:nvCxnSpPr>
+          <p:spPr>
+            <a:xfrm flipV="1">
+              <a:off x="5413664" y="5328292"/>
+              <a:ext cx="3212616" cy="459444"/>
+            </a:xfrm>
+            <a:prstGeom prst="straightConnector1">
+              <a:avLst/>
+            </a:prstGeom>
+            <a:ln w="12700">
+              <a:solidFill>
+                <a:srgbClr val="FF0000"/>
+              </a:solidFill>
+              <a:prstDash val="lgDashDot"/>
+              <a:tailEnd type="triangle"/>
+            </a:ln>
+          </p:spPr>
+          <p:style>
+            <a:lnRef idx="1">
+              <a:schemeClr val="accent1"/>
+            </a:lnRef>
+            <a:fillRef idx="0">
+              <a:schemeClr val="accent1"/>
+            </a:fillRef>
+            <a:effectRef idx="0">
+              <a:schemeClr val="accent1"/>
+            </a:effectRef>
+            <a:fontRef idx="minor">
+              <a:schemeClr val="tx1"/>
+            </a:fontRef>
+          </p:style>
+        </p:cxnSp>
+        <p:sp>
+          <p:nvSpPr>
+            <p:cNvPr id="39" name="文字方塊 38">
+              <a:extLst>
+                <a:ext uri="{FF2B5EF4-FFF2-40B4-BE49-F238E27FC236}">
+                  <a16:creationId xmlns:a16="http://schemas.microsoft.com/office/drawing/2014/main" id="{1330D563-4B7E-4C21-B5AE-0B45A3B2FAF6}"/>
+                </a:ext>
+              </a:extLst>
+            </p:cNvPr>
+            <p:cNvSpPr txBox="1"/>
+            <p:nvPr/>
+          </p:nvSpPr>
+          <p:spPr>
+            <a:xfrm>
+              <a:off x="2569141" y="4162905"/>
+              <a:ext cx="965200" cy="461665"/>
+            </a:xfrm>
+            <a:prstGeom prst="rect">
+              <a:avLst/>
+            </a:prstGeom>
+            <a:noFill/>
+          </p:spPr>
+          <p:txBody>
+            <a:bodyPr wrap="square" rtlCol="0">
+              <a:spAutoFit/>
+            </a:bodyPr>
+            <a:lstStyle/>
+            <a:p>
+              <a:r>
+                <a:rPr lang="en-US" altLang="zh-TW" sz="2400" dirty="0">
+                  <a:latin typeface="Calibri" panose="020F0502020204030204" pitchFamily="34" charset="0"/>
+                  <a:ea typeface="Calibri" panose="020F0502020204030204" pitchFamily="34" charset="0"/>
+                  <a:cs typeface="Calibri" panose="020F0502020204030204" pitchFamily="34" charset="0"/>
+                </a:rPr>
+                <a:t>Path 1 </a:t>
+              </a:r>
+              <a:endParaRPr lang="zh-TW" altLang="en-US" sz="2400" dirty="0">
+                <a:latin typeface="Calibri" panose="020F0502020204030204" pitchFamily="34" charset="0"/>
+                <a:cs typeface="Calibri" panose="020F0502020204030204" pitchFamily="34" charset="0"/>
+              </a:endParaRPr>
+            </a:p>
+          </p:txBody>
+        </p:sp>
+        <p:sp>
+          <p:nvSpPr>
+            <p:cNvPr id="41" name="文字方塊 40">
+              <a:extLst>
+                <a:ext uri="{FF2B5EF4-FFF2-40B4-BE49-F238E27FC236}">
+                  <a16:creationId xmlns:a16="http://schemas.microsoft.com/office/drawing/2014/main" id="{B1965B1F-4DC8-45F7-A061-8BB110B4402A}"/>
+                </a:ext>
+              </a:extLst>
+            </p:cNvPr>
+            <p:cNvSpPr txBox="1"/>
+            <p:nvPr/>
+          </p:nvSpPr>
+          <p:spPr>
+            <a:xfrm>
+              <a:off x="3840106" y="4630876"/>
+              <a:ext cx="965200" cy="461665"/>
+            </a:xfrm>
+            <a:prstGeom prst="rect">
+              <a:avLst/>
+            </a:prstGeom>
+            <a:noFill/>
+          </p:spPr>
+          <p:txBody>
+            <a:bodyPr wrap="square" rtlCol="0">
+              <a:spAutoFit/>
+            </a:bodyPr>
+            <a:lstStyle/>
+            <a:p>
+              <a:r>
+                <a:rPr lang="en-US" altLang="zh-TW" sz="2400" dirty="0">
+                  <a:latin typeface="Calibri" panose="020F0502020204030204" pitchFamily="34" charset="0"/>
+                  <a:ea typeface="Calibri" panose="020F0502020204030204" pitchFamily="34" charset="0"/>
+                  <a:cs typeface="Calibri" panose="020F0502020204030204" pitchFamily="34" charset="0"/>
+                </a:rPr>
+                <a:t>Path 2</a:t>
+              </a:r>
+              <a:endParaRPr lang="zh-TW" altLang="en-US" sz="2400" dirty="0">
+                <a:latin typeface="Calibri" panose="020F0502020204030204" pitchFamily="34" charset="0"/>
+                <a:cs typeface="Calibri" panose="020F0502020204030204" pitchFamily="34" charset="0"/>
+              </a:endParaRPr>
+            </a:p>
+          </p:txBody>
+        </p:sp>
+        <p:sp>
+          <p:nvSpPr>
+            <p:cNvPr id="42" name="文字方塊 41">
+              <a:extLst>
+                <a:ext uri="{FF2B5EF4-FFF2-40B4-BE49-F238E27FC236}">
+                  <a16:creationId xmlns:a16="http://schemas.microsoft.com/office/drawing/2014/main" id="{4C5725DA-CDC1-46B9-92A9-0595974EC67D}"/>
+                </a:ext>
+              </a:extLst>
+            </p:cNvPr>
+            <p:cNvSpPr txBox="1"/>
+            <p:nvPr/>
+          </p:nvSpPr>
+          <p:spPr>
+            <a:xfrm>
+              <a:off x="2825843" y="5504567"/>
+              <a:ext cx="965200" cy="461665"/>
+            </a:xfrm>
+            <a:prstGeom prst="rect">
+              <a:avLst/>
+            </a:prstGeom>
+            <a:noFill/>
+          </p:spPr>
+          <p:txBody>
+            <a:bodyPr wrap="square" rtlCol="0">
+              <a:spAutoFit/>
+            </a:bodyPr>
+            <a:lstStyle/>
+            <a:p>
+              <a:r>
+                <a:rPr lang="en-US" altLang="zh-TW" sz="2400" dirty="0">
+                  <a:latin typeface="Calibri" panose="020F0502020204030204" pitchFamily="34" charset="0"/>
+                  <a:ea typeface="Calibri" panose="020F0502020204030204" pitchFamily="34" charset="0"/>
+                  <a:cs typeface="Calibri" panose="020F0502020204030204" pitchFamily="34" charset="0"/>
+                </a:rPr>
+                <a:t>Path 3 </a:t>
+              </a:r>
+              <a:endParaRPr lang="zh-TW" altLang="en-US" sz="2400" dirty="0">
+                <a:latin typeface="Calibri" panose="020F0502020204030204" pitchFamily="34" charset="0"/>
+                <a:cs typeface="Calibri" panose="020F0502020204030204" pitchFamily="34" charset="0"/>
+              </a:endParaRPr>
+            </a:p>
+          </p:txBody>
+        </p:sp>
+      </p:grpSp>
     </p:spTree>
     <p:extLst>
       <p:ext uri="{BB962C8B-B14F-4D97-AF65-F5344CB8AC3E}">

</xml_diff>